<commit_message>
Label every result slide with the condition and the task it came from
With three conditions and four tasks in one deck, a reader had no way to
tell which numbers a slide was showing. Slides 3, 5, 6, 7, 8 and 9 now
carry a badge naming the condition and the scope: PRIMARY for the
fixed-5 B=8 results on slides 6, 7 and 9, ALL THREE CONDITIONS for the
attribution on slide 8, and the applies-to-all note on the two design
slides. Slide 7's badge says T4 only and slide 8's says T1 only, because
those slides show one task each and previously did not say so.

The search-space table now names T1 to T4 before they are used anywhere,
says which qubit count each task runs at and why, and gives gate count
and budget per condition instead of quoting the primary's values as if
they were universal. Slide 8's footer claimed "same tasks" while the
figure shows T1 alone; it now says all four ran and explains why T1 is
the one plotted.

Co-Authored-By: Claude Opus 5 <noreply@anthropic.com>
</commit_message>
<xml_diff>
--- a/docs/presentation/mini5/20260731_GSoC_mini5.pptx
+++ b/docs/presentation/mini5/20260731_GSoC_mini5.pptx
@@ -1970,7 +1970,7 @@
                 <a:ea typeface="Arial" pitchFamily="34" charset="-122"/>
                 <a:cs typeface="Arial" pitchFamily="34" charset="-120"/>
               </a:rPr>
-              <a:t>July 31, 2026  ·  commit be1b93c  ·  experiment/bench-v2-real-llm-cost-minimal</a:t>
+              <a:t>July 31, 2026  ·  commit 0c7dff9  ·  experiment/bench-v2-real-llm-cost-minimal</a:t>
             </a:r>
             <a:endParaRPr lang="en-US" sz="1200" dirty="0"/>
           </a:p>
@@ -3298,6 +3298,86 @@
           </a:p>
         </p:txBody>
       </p:sp>
+      <p:sp>
+        <p:nvSpPr>
+          <p:cNvPr id="4" name="Shape 2"/>
+          <p:cNvSpPr/>
+          <p:nvPr/>
+        </p:nvSpPr>
+        <p:spPr>
+          <a:xfrm>
+            <a:off x="5699455" y="256032"/>
+            <a:ext cx="5989320" cy="402336"/>
+          </a:xfrm>
+          <a:prstGeom prst="roundRect">
+            <a:avLst>
+              <a:gd name="adj" fmla="val 15909"/>
+            </a:avLst>
+          </a:prstGeom>
+          <a:solidFill>
+            <a:srgbClr val="F4F6FA"/>
+          </a:solidFill>
+          <a:ln w="12700">
+            <a:solidFill>
+              <a:srgbClr val="D8DDE6"/>
+            </a:solidFill>
+            <a:prstDash val="solid"/>
+          </a:ln>
+        </p:spPr>
+      </p:sp>
+      <p:sp>
+        <p:nvSpPr>
+          <p:cNvPr id="5" name="Text 3"/>
+          <p:cNvSpPr/>
+          <p:nvPr/>
+        </p:nvSpPr>
+        <p:spPr>
+          <a:xfrm>
+            <a:off x="5836615" y="274320"/>
+            <a:ext cx="5715000" cy="365760"/>
+          </a:xfrm>
+          <a:prstGeom prst="rect">
+            <a:avLst/>
+          </a:prstGeom>
+          <a:noFill/>
+          <a:ln/>
+        </p:spPr>
+        <p:txBody>
+          <a:bodyPr wrap="square" lIns="0" tIns="0" rIns="0" bIns="0" rtlCol="0" anchor="ctr"/>
+          <a:lstStyle/>
+          <a:p>
+            <a:pPr algn="r" indent="0" marL="0">
+              <a:buNone/>
+            </a:pPr>
+            <a:r>
+              <a:rPr lang="en-US" sz="1150" b="1" dirty="0">
+                <a:solidFill>
+                  <a:srgbClr val="1E3A5F"/>
+                </a:solidFill>
+                <a:latin typeface="Arial" pitchFamily="34" charset="0"/>
+                <a:ea typeface="Arial" pitchFamily="34" charset="-122"/>
+                <a:cs typeface="Arial" pitchFamily="34" charset="-120"/>
+              </a:rPr>
+              <a:t>Applies to all three conditions</a:t>
+            </a:r>
+            <a:pPr algn="r" indent="0" marL="0">
+              <a:buNone/>
+            </a:pPr>
+            <a:r>
+              <a:rPr lang="en-US" sz="1150" dirty="0">
+                <a:solidFill>
+                  <a:srgbClr val="55606E"/>
+                </a:solidFill>
+                <a:latin typeface="Arial" pitchFamily="34" charset="0"/>
+                <a:ea typeface="Arial" pitchFamily="34" charset="-122"/>
+                <a:cs typeface="Arial" pitchFamily="34" charset="-120"/>
+              </a:rPr>
+              <a:t>   only gate count and B differ between them</a:t>
+            </a:r>
+            <a:endParaRPr lang="en-US" sz="1150" dirty="0"/>
+          </a:p>
+        </p:txBody>
+      </p:sp>
       <p:graphicFrame>
         <p:nvGraphicFramePr>
           <p:cNvPr id="4" name="Table 0"/>
@@ -3313,7 +3393,7 @@
           </p:nvPr>
         </p:nvGraphicFramePr>
         <p:xfrm>
-          <a:off x="548640" y="1463040"/>
+          <a:off x="548640" y="1371600"/>
           <a:ext cx="11109960" cy="914400"/>
         </p:xfrm>
         <a:graphic>
@@ -3321,10 +3401,10 @@
             <a:tbl>
               <a:tblPr/>
               <a:tblGrid>
-                <a:gridCol w="2514600"/>
-                <a:gridCol w="8595360"/>
+                <a:gridCol w="2194560"/>
+                <a:gridCol w="8915400"/>
               </a:tblGrid>
-              <a:tr h="402336">
+              <a:tr h="365760">
                 <a:tc>
                   <a:txBody>
                     <a:bodyPr/>
@@ -3334,7 +3414,7 @@
                         <a:buNone/>
                       </a:pPr>
                       <a:r>
-                        <a:rPr lang="en-US" sz="1400" b="1" dirty="0">
+                        <a:rPr lang="en-US" sz="1250" b="1" dirty="0">
                           <a:solidFill>
                             <a:srgbClr val="FFFFFF"/>
                           </a:solidFill>
@@ -3344,14 +3424,14 @@
                         </a:rPr>
                         <a:t>Constraint</a:t>
                       </a:r>
-                      <a:endParaRPr lang="en-US" sz="1400" dirty="0">
+                      <a:endParaRPr lang="en-US" sz="1250" dirty="0">
                         <a:latin typeface="Arial" charset="0"/>
                         <a:ea typeface="Arial" charset="0"/>
                         <a:cs typeface="Arial" charset="0"/>
                       </a:endParaRPr>
                     </a:p>
                   </a:txBody>
-                  <a:tcPr marL="64008" marR="64008" marT="64008" marB="64008" anchor="ctr">
+                  <a:tcPr marL="54864" marR="54864" marT="54864" marB="54864" anchor="ctr">
                     <a:lnL w="9525" cap="flat" cmpd="sng" algn="ctr">
                       <a:solidFill>
                         <a:srgbClr val="D8DDE6"/>
@@ -3402,7 +3482,7 @@
                         <a:buNone/>
                       </a:pPr>
                       <a:r>
-                        <a:rPr lang="en-US" sz="1400" b="1" dirty="0">
+                        <a:rPr lang="en-US" sz="1250" b="1" dirty="0">
                           <a:solidFill>
                             <a:srgbClr val="FFFFFF"/>
                           </a:solidFill>
@@ -3412,14 +3492,14 @@
                         </a:rPr>
                         <a:t>Value</a:t>
                       </a:r>
-                      <a:endParaRPr lang="en-US" sz="1400" dirty="0">
+                      <a:endParaRPr lang="en-US" sz="1250" dirty="0">
                         <a:latin typeface="Arial" charset="0"/>
                         <a:ea typeface="Arial" charset="0"/>
                         <a:cs typeface="Arial" charset="0"/>
                       </a:endParaRPr>
                     </a:p>
                   </a:txBody>
-                  <a:tcPr marL="64008" marR="64008" marT="64008" marB="64008" anchor="ctr">
+                  <a:tcPr marL="54864" marR="54864" marT="54864" marB="54864" anchor="ctr">
                     <a:lnL w="9525" cap="flat" cmpd="sng" algn="ctr">
                       <a:solidFill>
                         <a:srgbClr val="D8DDE6"/>
@@ -3462,7 +3542,7 @@
                   </a:tcPr>
                 </a:tc>
               </a:tr>
-              <a:tr h="402336">
+              <a:tr h="365760">
                 <a:tc>
                   <a:txBody>
                     <a:bodyPr/>
@@ -3472,7 +3552,7 @@
                         <a:buNone/>
                       </a:pPr>
                       <a:r>
-                        <a:rPr lang="en-US" sz="1400" dirty="0">
+                        <a:rPr lang="en-US" sz="1250" dirty="0">
                           <a:solidFill>
                             <a:srgbClr val="000000"/>
                           </a:solidFill>
@@ -3480,16 +3560,16 @@
                           <a:ea typeface="Arial" pitchFamily="34" charset="-122"/>
                           <a:cs typeface="Arial" pitchFamily="34" charset="-120"/>
                         </a:rPr>
-                        <a:t>Qubits</a:t>
+                        <a:t>Tasks</a:t>
                       </a:r>
-                      <a:endParaRPr lang="en-US" sz="1400" dirty="0">
+                      <a:endParaRPr lang="en-US" sz="1250" dirty="0">
                         <a:latin typeface="Arial" charset="0"/>
                         <a:ea typeface="Arial" charset="0"/>
                         <a:cs typeface="Arial" charset="0"/>
                       </a:endParaRPr>
                     </a:p>
                   </a:txBody>
-                  <a:tcPr marL="64008" marR="64008" marT="64008" marB="64008" anchor="ctr">
+                  <a:tcPr marL="54864" marR="54864" marT="54864" marB="54864" anchor="ctr">
                     <a:lnL w="9525" cap="flat" cmpd="sng" algn="ctr">
                       <a:solidFill>
                         <a:srgbClr val="D8DDE6"/>
@@ -3537,7 +3617,7 @@
                         <a:buNone/>
                       </a:pPr>
                       <a:r>
-                        <a:rPr lang="en-US" sz="1400" dirty="0">
+                        <a:rPr lang="en-US" sz="1250" dirty="0">
                           <a:solidFill>
                             <a:srgbClr val="000000"/>
                           </a:solidFill>
@@ -3545,16 +3625,16 @@
                           <a:ea typeface="Arial" pitchFamily="34" charset="-122"/>
                           <a:cs typeface="Arial" pitchFamily="34" charset="-120"/>
                         </a:rPr>
-                        <a:t>3 for T1 and T2 (2^3 = 8 amplitudes); 5 for T3 and T4 (2^5 = 32)</a:t>
+                        <a:t>T1 Gaussian peak position · T2 sinusoid frequency · T3 change-point location · T4 one peak vs two (binary)</a:t>
                       </a:r>
-                      <a:endParaRPr lang="en-US" sz="1400" dirty="0">
+                      <a:endParaRPr lang="en-US" sz="1250" dirty="0">
                         <a:latin typeface="Arial" charset="0"/>
                         <a:ea typeface="Arial" charset="0"/>
                         <a:cs typeface="Arial" charset="0"/>
                       </a:endParaRPr>
                     </a:p>
                   </a:txBody>
-                  <a:tcPr marL="64008" marR="64008" marT="64008" marB="64008" anchor="ctr">
+                  <a:tcPr marL="54864" marR="54864" marT="54864" marB="54864" anchor="ctr">
                     <a:lnL w="9525" cap="flat" cmpd="sng" algn="ctr">
                       <a:solidFill>
                         <a:srgbClr val="D8DDE6"/>
@@ -3594,7 +3674,7 @@
                   </a:tcPr>
                 </a:tc>
               </a:tr>
-              <a:tr h="402336">
+              <a:tr h="365760">
                 <a:tc>
                   <a:txBody>
                     <a:bodyPr/>
@@ -3604,7 +3684,7 @@
                         <a:buNone/>
                       </a:pPr>
                       <a:r>
-                        <a:rPr lang="en-US" sz="1400" dirty="0">
+                        <a:rPr lang="en-US" sz="1250" dirty="0">
                           <a:solidFill>
                             <a:srgbClr val="000000"/>
                           </a:solidFill>
@@ -3612,16 +3692,16 @@
                           <a:ea typeface="Arial" pitchFamily="34" charset="-122"/>
                           <a:cs typeface="Arial" pitchFamily="34" charset="-120"/>
                         </a:rPr>
-                        <a:t>Gate count</a:t>
+                        <a:t>Qubits</a:t>
                       </a:r>
-                      <a:endParaRPr lang="en-US" sz="1400" dirty="0">
+                      <a:endParaRPr lang="en-US" sz="1250" dirty="0">
                         <a:latin typeface="Arial" charset="0"/>
                         <a:ea typeface="Arial" charset="0"/>
                         <a:cs typeface="Arial" charset="0"/>
                       </a:endParaRPr>
                     </a:p>
                   </a:txBody>
-                  <a:tcPr marL="64008" marR="64008" marT="64008" marB="64008" anchor="ctr">
+                  <a:tcPr marL="54864" marR="54864" marT="54864" marB="54864" anchor="ctr">
                     <a:lnL w="9525" cap="flat" cmpd="sng" algn="ctr">
                       <a:solidFill>
                         <a:srgbClr val="D8DDE6"/>
@@ -3669,7 +3749,7 @@
                         <a:buNone/>
                       </a:pPr>
                       <a:r>
-                        <a:rPr lang="en-US" sz="1400" dirty="0">
+                        <a:rPr lang="en-US" sz="1250" dirty="0">
                           <a:solidFill>
                             <a:srgbClr val="000000"/>
                           </a:solidFill>
@@ -3677,16 +3757,16 @@
                           <a:ea typeface="Arial" pitchFamily="34" charset="-122"/>
                           <a:cs typeface="Arial" pitchFamily="34" charset="-120"/>
                         </a:rPr>
-                        <a:t>EXACTLY 5 - not a maximum, not a range. Identical for every method.</a:t>
+                        <a:t>3 for T1, T2 (2^3 = 8 amplitudes); 5 for T3, T4 (2^5 = 32) - T3 and T4 are only frozen at n=5</a:t>
                       </a:r>
-                      <a:endParaRPr lang="en-US" sz="1400" dirty="0">
+                      <a:endParaRPr lang="en-US" sz="1250" dirty="0">
                         <a:latin typeface="Arial" charset="0"/>
                         <a:ea typeface="Arial" charset="0"/>
                         <a:cs typeface="Arial" charset="0"/>
                       </a:endParaRPr>
                     </a:p>
                   </a:txBody>
-                  <a:tcPr marL="64008" marR="64008" marT="64008" marB="64008" anchor="ctr">
+                  <a:tcPr marL="54864" marR="54864" marT="54864" marB="54864" anchor="ctr">
                     <a:lnL w="9525" cap="flat" cmpd="sng" algn="ctr">
                       <a:solidFill>
                         <a:srgbClr val="D8DDE6"/>
@@ -3726,7 +3806,7 @@
                   </a:tcPr>
                 </a:tc>
               </a:tr>
-              <a:tr h="402336">
+              <a:tr h="365760">
                 <a:tc>
                   <a:txBody>
                     <a:bodyPr/>
@@ -3736,7 +3816,7 @@
                         <a:buNone/>
                       </a:pPr>
                       <a:r>
-                        <a:rPr lang="en-US" sz="1400" dirty="0">
+                        <a:rPr lang="en-US" sz="1250" dirty="0">
                           <a:solidFill>
                             <a:srgbClr val="000000"/>
                           </a:solidFill>
@@ -3744,16 +3824,16 @@
                           <a:ea typeface="Arial" pitchFamily="34" charset="-122"/>
                           <a:cs typeface="Arial" pitchFamily="34" charset="-120"/>
                         </a:rPr>
-                        <a:t>Gate set (7 types)</a:t>
+                        <a:t>Gate count</a:t>
                       </a:r>
-                      <a:endParaRPr lang="en-US" sz="1400" dirty="0">
+                      <a:endParaRPr lang="en-US" sz="1250" dirty="0">
                         <a:latin typeface="Arial" charset="0"/>
                         <a:ea typeface="Arial" charset="0"/>
                         <a:cs typeface="Arial" charset="0"/>
                       </a:endParaRPr>
                     </a:p>
                   </a:txBody>
-                  <a:tcPr marL="64008" marR="64008" marT="64008" marB="64008" anchor="ctr">
+                  <a:tcPr marL="54864" marR="54864" marT="54864" marB="54864" anchor="ctr">
                     <a:lnL w="9525" cap="flat" cmpd="sng" algn="ctr">
                       <a:solidFill>
                         <a:srgbClr val="D8DDE6"/>
@@ -3801,7 +3881,7 @@
                         <a:buNone/>
                       </a:pPr>
                       <a:r>
-                        <a:rPr lang="en-US" sz="1400" dirty="0">
+                        <a:rPr lang="en-US" sz="1250" dirty="0">
                           <a:solidFill>
                             <a:srgbClr val="000000"/>
                           </a:solidFill>
@@ -3809,16 +3889,16 @@
                           <a:ea typeface="Arial" pitchFamily="34" charset="-122"/>
                           <a:cs typeface="Arial" pitchFamily="34" charset="-120"/>
                         </a:rPr>
-                        <a:t>one wire: H, RX, RY, RZ      two wires: CRX, CRY, CRZ</a:t>
+                        <a:t>PRIMARY exactly 5 (not a max, not a range); Controls A and B relax it to 1-5. Every arm faces the same setting.</a:t>
                       </a:r>
-                      <a:endParaRPr lang="en-US" sz="1400" dirty="0">
+                      <a:endParaRPr lang="en-US" sz="1250" dirty="0">
                         <a:latin typeface="Arial" charset="0"/>
                         <a:ea typeface="Arial" charset="0"/>
                         <a:cs typeface="Arial" charset="0"/>
                       </a:endParaRPr>
                     </a:p>
                   </a:txBody>
-                  <a:tcPr marL="64008" marR="64008" marT="64008" marB="64008" anchor="ctr">
+                  <a:tcPr marL="54864" marR="54864" marT="54864" marB="54864" anchor="ctr">
                     <a:lnL w="9525" cap="flat" cmpd="sng" algn="ctr">
                       <a:solidFill>
                         <a:srgbClr val="D8DDE6"/>
@@ -3858,7 +3938,7 @@
                   </a:tcPr>
                 </a:tc>
               </a:tr>
-              <a:tr h="402336">
+              <a:tr h="365760">
                 <a:tc>
                   <a:txBody>
                     <a:bodyPr/>
@@ -3868,7 +3948,7 @@
                         <a:buNone/>
                       </a:pPr>
                       <a:r>
-                        <a:rPr lang="en-US" sz="1400" dirty="0">
+                        <a:rPr lang="en-US" sz="1250" dirty="0">
                           <a:solidFill>
                             <a:srgbClr val="000000"/>
                           </a:solidFill>
@@ -3876,16 +3956,16 @@
                           <a:ea typeface="Arial" pitchFamily="34" charset="-122"/>
                           <a:cs typeface="Arial" pitchFamily="34" charset="-120"/>
                         </a:rPr>
-                        <a:t>Angles</a:t>
+                        <a:t>Gate set (7 types)</a:t>
                       </a:r>
-                      <a:endParaRPr lang="en-US" sz="1400" dirty="0">
+                      <a:endParaRPr lang="en-US" sz="1250" dirty="0">
                         <a:latin typeface="Arial" charset="0"/>
                         <a:ea typeface="Arial" charset="0"/>
                         <a:cs typeface="Arial" charset="0"/>
                       </a:endParaRPr>
                     </a:p>
                   </a:txBody>
-                  <a:tcPr marL="64008" marR="64008" marT="64008" marB="64008" anchor="ctr">
+                  <a:tcPr marL="54864" marR="54864" marT="54864" marB="54864" anchor="ctr">
                     <a:lnL w="9525" cap="flat" cmpd="sng" algn="ctr">
                       <a:solidFill>
                         <a:srgbClr val="D8DDE6"/>
@@ -3933,7 +4013,7 @@
                         <a:buNone/>
                       </a:pPr>
                       <a:r>
-                        <a:rPr lang="en-US" sz="1400" dirty="0">
+                        <a:rPr lang="en-US" sz="1250" dirty="0">
                           <a:solidFill>
                             <a:srgbClr val="000000"/>
                           </a:solidFill>
@@ -3941,16 +4021,16 @@
                           <a:ea typeface="Arial" pitchFamily="34" charset="-122"/>
                           <a:cs typeface="Arial" pitchFamily="34" charset="-120"/>
                         </a:rPr>
-                        <a:t>one continuous theta per gate in [-pi, pi]; H carries none</a:t>
+                        <a:t>one wire: H, RX, RY, RZ      two wires: CRX, CRY, CRZ</a:t>
                       </a:r>
-                      <a:endParaRPr lang="en-US" sz="1400" dirty="0">
+                      <a:endParaRPr lang="en-US" sz="1250" dirty="0">
                         <a:latin typeface="Arial" charset="0"/>
                         <a:ea typeface="Arial" charset="0"/>
                         <a:cs typeface="Arial" charset="0"/>
                       </a:endParaRPr>
                     </a:p>
                   </a:txBody>
-                  <a:tcPr marL="64008" marR="64008" marT="64008" marB="64008" anchor="ctr">
+                  <a:tcPr marL="54864" marR="54864" marT="54864" marB="54864" anchor="ctr">
                     <a:lnL w="9525" cap="flat" cmpd="sng" algn="ctr">
                       <a:solidFill>
                         <a:srgbClr val="D8DDE6"/>
@@ -3990,7 +4070,7 @@
                   </a:tcPr>
                 </a:tc>
               </a:tr>
-              <a:tr h="402336">
+              <a:tr h="365760">
                 <a:tc>
                   <a:txBody>
                     <a:bodyPr/>
@@ -4000,7 +4080,7 @@
                         <a:buNone/>
                       </a:pPr>
                       <a:r>
-                        <a:rPr lang="en-US" sz="1400" dirty="0">
+                        <a:rPr lang="en-US" sz="1250" dirty="0">
                           <a:solidFill>
                             <a:srgbClr val="000000"/>
                           </a:solidFill>
@@ -4008,16 +4088,16 @@
                           <a:ea typeface="Arial" pitchFamily="34" charset="-122"/>
                           <a:cs typeface="Arial" pitchFamily="34" charset="-120"/>
                         </a:rPr>
-                        <a:t>Training</a:t>
+                        <a:t>Angles</a:t>
                       </a:r>
-                      <a:endParaRPr lang="en-US" sz="1400" dirty="0">
+                      <a:endParaRPr lang="en-US" sz="1250" dirty="0">
                         <a:latin typeface="Arial" charset="0"/>
                         <a:ea typeface="Arial" charset="0"/>
                         <a:cs typeface="Arial" charset="0"/>
                       </a:endParaRPr>
                     </a:p>
                   </a:txBody>
-                  <a:tcPr marL="64008" marR="64008" marT="64008" marB="64008" anchor="ctr">
+                  <a:tcPr marL="54864" marR="54864" marT="54864" marB="54864" anchor="ctr">
                     <a:lnL w="9525" cap="flat" cmpd="sng" algn="ctr">
                       <a:solidFill>
                         <a:srgbClr val="D8DDE6"/>
@@ -4065,7 +4145,7 @@
                         <a:buNone/>
                       </a:pPr>
                       <a:r>
-                        <a:rPr lang="en-US" sz="1400" dirty="0">
+                        <a:rPr lang="en-US" sz="1250" dirty="0">
                           <a:solidFill>
                             <a:srgbClr val="000000"/>
                           </a:solidFill>
@@ -4073,16 +4153,16 @@
                           <a:ea typeface="Arial" pitchFamily="34" charset="-122"/>
                           <a:cs typeface="Arial" pitchFamily="34" charset="-120"/>
                         </a:rPr>
-                        <a:t>NONE. The proposed angles are evaluated verbatim - no optimizer exists on this path.</a:t>
+                        <a:t>one continuous theta per gate in [-pi, pi]; H carries none</a:t>
                       </a:r>
-                      <a:endParaRPr lang="en-US" sz="1400" dirty="0">
+                      <a:endParaRPr lang="en-US" sz="1250" dirty="0">
                         <a:latin typeface="Arial" charset="0"/>
                         <a:ea typeface="Arial" charset="0"/>
                         <a:cs typeface="Arial" charset="0"/>
                       </a:endParaRPr>
                     </a:p>
                   </a:txBody>
-                  <a:tcPr marL="64008" marR="64008" marT="64008" marB="64008" anchor="ctr">
+                  <a:tcPr marL="54864" marR="54864" marT="54864" marB="54864" anchor="ctr">
                     <a:lnL w="9525" cap="flat" cmpd="sng" algn="ctr">
                       <a:solidFill>
                         <a:srgbClr val="D8DDE6"/>
@@ -4122,7 +4202,7 @@
                   </a:tcPr>
                 </a:tc>
               </a:tr>
-              <a:tr h="402336">
+              <a:tr h="365760">
                 <a:tc>
                   <a:txBody>
                     <a:bodyPr/>
@@ -4132,7 +4212,7 @@
                         <a:buNone/>
                       </a:pPr>
                       <a:r>
-                        <a:rPr lang="en-US" sz="1400" dirty="0">
+                        <a:rPr lang="en-US" sz="1250" dirty="0">
                           <a:solidFill>
                             <a:srgbClr val="000000"/>
                           </a:solidFill>
@@ -4140,16 +4220,16 @@
                           <a:ea typeface="Arial" pitchFamily="34" charset="-122"/>
                           <a:cs typeface="Arial" pitchFamily="34" charset="-120"/>
                         </a:rPr>
-                        <a:t>Encoding / readout</a:t>
+                        <a:t>Budget</a:t>
                       </a:r>
-                      <a:endParaRPr lang="en-US" sz="1400" dirty="0">
+                      <a:endParaRPr lang="en-US" sz="1250" dirty="0">
                         <a:latin typeface="Arial" charset="0"/>
                         <a:ea typeface="Arial" charset="0"/>
                         <a:cs typeface="Arial" charset="0"/>
                       </a:endParaRPr>
                     </a:p>
                   </a:txBody>
-                  <a:tcPr marL="64008" marR="64008" marT="64008" marB="64008" anchor="ctr">
+                  <a:tcPr marL="54864" marR="54864" marT="54864" marB="54864" anchor="ctr">
                     <a:lnL w="9525" cap="flat" cmpd="sng" algn="ctr">
                       <a:solidFill>
                         <a:srgbClr val="D8DDE6"/>
@@ -4197,7 +4277,7 @@
                         <a:buNone/>
                       </a:pPr>
                       <a:r>
-                        <a:rPr lang="en-US" sz="1400" dirty="0">
+                        <a:rPr lang="en-US" sz="1250" dirty="0">
                           <a:solidFill>
                             <a:srgbClr val="000000"/>
                           </a:solidFill>
@@ -4205,16 +4285,16 @@
                           <a:ea typeface="Arial" pitchFamily="34" charset="-122"/>
                           <a:cs typeface="Arial" pitchFamily="34" charset="-120"/>
                         </a:rPr>
-                        <a:t>amplitude encoding; Pauli-Z on qubit 0; prediction = (1 - &lt;Z0&gt;)/2</a:t>
+                        <a:t>PRIMARY and Control A: B = 8 unique candidates. Control B: B = 4, the pilot's setting. 10 seeds throughout.</a:t>
                       </a:r>
-                      <a:endParaRPr lang="en-US" sz="1400" dirty="0">
+                      <a:endParaRPr lang="en-US" sz="1250" dirty="0">
                         <a:latin typeface="Arial" charset="0"/>
                         <a:ea typeface="Arial" charset="0"/>
                         <a:cs typeface="Arial" charset="0"/>
                       </a:endParaRPr>
                     </a:p>
                   </a:txBody>
-                  <a:tcPr marL="64008" marR="64008" marT="64008" marB="64008" anchor="ctr">
+                  <a:tcPr marL="54864" marR="54864" marT="54864" marB="54864" anchor="ctr">
                     <a:lnL w="9525" cap="flat" cmpd="sng" algn="ctr">
                       <a:solidFill>
                         <a:srgbClr val="D8DDE6"/>
@@ -4254,7 +4334,7 @@
                   </a:tcPr>
                 </a:tc>
               </a:tr>
-              <a:tr h="402336">
+              <a:tr h="365760">
                 <a:tc>
                   <a:txBody>
                     <a:bodyPr/>
@@ -4264,7 +4344,7 @@
                         <a:buNone/>
                       </a:pPr>
                       <a:r>
-                        <a:rPr lang="en-US" sz="1400" dirty="0">
+                        <a:rPr lang="en-US" sz="1250" dirty="0">
                           <a:solidFill>
                             <a:srgbClr val="000000"/>
                           </a:solidFill>
@@ -4272,16 +4352,16 @@
                           <a:ea typeface="Arial" pitchFamily="34" charset="-122"/>
                           <a:cs typeface="Arial" pitchFamily="34" charset="-120"/>
                         </a:rPr>
-                        <a:t>Classical parameters</a:t>
+                        <a:t>Training</a:t>
                       </a:r>
-                      <a:endParaRPr lang="en-US" sz="1400" dirty="0">
+                      <a:endParaRPr lang="en-US" sz="1250" dirty="0">
                         <a:latin typeface="Arial" charset="0"/>
                         <a:ea typeface="Arial" charset="0"/>
                         <a:cs typeface="Arial" charset="0"/>
                       </a:endParaRPr>
                     </a:p>
                   </a:txBody>
-                  <a:tcPr marL="64008" marR="64008" marT="64008" marB="64008" anchor="ctr">
+                  <a:tcPr marL="54864" marR="54864" marT="54864" marB="54864" anchor="ctr">
                     <a:lnL w="9525" cap="flat" cmpd="sng" algn="ctr">
                       <a:solidFill>
                         <a:srgbClr val="D8DDE6"/>
@@ -4329,7 +4409,271 @@
                         <a:buNone/>
                       </a:pPr>
                       <a:r>
-                        <a:rPr lang="en-US" sz="1400" dirty="0">
+                        <a:rPr lang="en-US" sz="1250" dirty="0">
+                          <a:solidFill>
+                            <a:srgbClr val="000000"/>
+                          </a:solidFill>
+                          <a:latin typeface="Arial" pitchFamily="34" charset="0"/>
+                          <a:ea typeface="Arial" pitchFamily="34" charset="-122"/>
+                          <a:cs typeface="Arial" pitchFamily="34" charset="-120"/>
+                        </a:rPr>
+                        <a:t>NONE. The proposed angles are evaluated verbatim - no optimizer exists on this path.</a:t>
+                      </a:r>
+                      <a:endParaRPr lang="en-US" sz="1250" dirty="0">
+                        <a:latin typeface="Arial" charset="0"/>
+                        <a:ea typeface="Arial" charset="0"/>
+                        <a:cs typeface="Arial" charset="0"/>
+                      </a:endParaRPr>
+                    </a:p>
+                  </a:txBody>
+                  <a:tcPr marL="54864" marR="54864" marT="54864" marB="54864" anchor="ctr">
+                    <a:lnL w="9525" cap="flat" cmpd="sng" algn="ctr">
+                      <a:solidFill>
+                        <a:srgbClr val="D8DDE6"/>
+                      </a:solidFill>
+                      <a:prstDash val="solid"/>
+                      <a:round/>
+                      <a:headEnd type="none" w="med" len="med"/>
+                      <a:tailEnd type="none" w="med" len="med"/>
+                    </a:lnL>
+                    <a:lnR w="9525" cap="flat" cmpd="sng" algn="ctr">
+                      <a:solidFill>
+                        <a:srgbClr val="D8DDE6"/>
+                      </a:solidFill>
+                      <a:prstDash val="solid"/>
+                      <a:round/>
+                      <a:headEnd type="none" w="med" len="med"/>
+                      <a:tailEnd type="none" w="med" len="med"/>
+                    </a:lnR>
+                    <a:lnT w="9525" cap="flat" cmpd="sng" algn="ctr">
+                      <a:solidFill>
+                        <a:srgbClr val="D8DDE6"/>
+                      </a:solidFill>
+                      <a:prstDash val="solid"/>
+                      <a:round/>
+                      <a:headEnd type="none" w="med" len="med"/>
+                      <a:tailEnd type="none" w="med" len="med"/>
+                    </a:lnT>
+                    <a:lnB w="9525" cap="flat" cmpd="sng" algn="ctr">
+                      <a:solidFill>
+                        <a:srgbClr val="D8DDE6"/>
+                      </a:solidFill>
+                      <a:prstDash val="solid"/>
+                      <a:round/>
+                      <a:headEnd type="none" w="med" len="med"/>
+                      <a:tailEnd type="none" w="med" len="med"/>
+                    </a:lnB>
+                  </a:tcPr>
+                </a:tc>
+              </a:tr>
+              <a:tr h="365760">
+                <a:tc>
+                  <a:txBody>
+                    <a:bodyPr/>
+                    <a:lstStyle/>
+                    <a:p>
+                      <a:pPr indent="0" marL="0">
+                        <a:buNone/>
+                      </a:pPr>
+                      <a:r>
+                        <a:rPr lang="en-US" sz="1250" dirty="0">
+                          <a:solidFill>
+                            <a:srgbClr val="000000"/>
+                          </a:solidFill>
+                          <a:latin typeface="Arial" pitchFamily="34" charset="0"/>
+                          <a:ea typeface="Arial" pitchFamily="34" charset="-122"/>
+                          <a:cs typeface="Arial" pitchFamily="34" charset="-120"/>
+                        </a:rPr>
+                        <a:t>Encoding / readout</a:t>
+                      </a:r>
+                      <a:endParaRPr lang="en-US" sz="1250" dirty="0">
+                        <a:latin typeface="Arial" charset="0"/>
+                        <a:ea typeface="Arial" charset="0"/>
+                        <a:cs typeface="Arial" charset="0"/>
+                      </a:endParaRPr>
+                    </a:p>
+                  </a:txBody>
+                  <a:tcPr marL="54864" marR="54864" marT="54864" marB="54864" anchor="ctr">
+                    <a:lnL w="9525" cap="flat" cmpd="sng" algn="ctr">
+                      <a:solidFill>
+                        <a:srgbClr val="D8DDE6"/>
+                      </a:solidFill>
+                      <a:prstDash val="solid"/>
+                      <a:round/>
+                      <a:headEnd type="none" w="med" len="med"/>
+                      <a:tailEnd type="none" w="med" len="med"/>
+                    </a:lnL>
+                    <a:lnR w="9525" cap="flat" cmpd="sng" algn="ctr">
+                      <a:solidFill>
+                        <a:srgbClr val="D8DDE6"/>
+                      </a:solidFill>
+                      <a:prstDash val="solid"/>
+                      <a:round/>
+                      <a:headEnd type="none" w="med" len="med"/>
+                      <a:tailEnd type="none" w="med" len="med"/>
+                    </a:lnR>
+                    <a:lnT w="9525" cap="flat" cmpd="sng" algn="ctr">
+                      <a:solidFill>
+                        <a:srgbClr val="D8DDE6"/>
+                      </a:solidFill>
+                      <a:prstDash val="solid"/>
+                      <a:round/>
+                      <a:headEnd type="none" w="med" len="med"/>
+                      <a:tailEnd type="none" w="med" len="med"/>
+                    </a:lnT>
+                    <a:lnB w="9525" cap="flat" cmpd="sng" algn="ctr">
+                      <a:solidFill>
+                        <a:srgbClr val="D8DDE6"/>
+                      </a:solidFill>
+                      <a:prstDash val="solid"/>
+                      <a:round/>
+                      <a:headEnd type="none" w="med" len="med"/>
+                      <a:tailEnd type="none" w="med" len="med"/>
+                    </a:lnB>
+                  </a:tcPr>
+                </a:tc>
+                <a:tc>
+                  <a:txBody>
+                    <a:bodyPr/>
+                    <a:lstStyle/>
+                    <a:p>
+                      <a:pPr indent="0" marL="0">
+                        <a:buNone/>
+                      </a:pPr>
+                      <a:r>
+                        <a:rPr lang="en-US" sz="1250" dirty="0">
+                          <a:solidFill>
+                            <a:srgbClr val="000000"/>
+                          </a:solidFill>
+                          <a:latin typeface="Arial" pitchFamily="34" charset="0"/>
+                          <a:ea typeface="Arial" pitchFamily="34" charset="-122"/>
+                          <a:cs typeface="Arial" pitchFamily="34" charset="-120"/>
+                        </a:rPr>
+                        <a:t>amplitude encoding; Pauli-Z on qubit 0; prediction = (1 - &lt;Z0&gt;)/2</a:t>
+                      </a:r>
+                      <a:endParaRPr lang="en-US" sz="1250" dirty="0">
+                        <a:latin typeface="Arial" charset="0"/>
+                        <a:ea typeface="Arial" charset="0"/>
+                        <a:cs typeface="Arial" charset="0"/>
+                      </a:endParaRPr>
+                    </a:p>
+                  </a:txBody>
+                  <a:tcPr marL="54864" marR="54864" marT="54864" marB="54864" anchor="ctr">
+                    <a:lnL w="9525" cap="flat" cmpd="sng" algn="ctr">
+                      <a:solidFill>
+                        <a:srgbClr val="D8DDE6"/>
+                      </a:solidFill>
+                      <a:prstDash val="solid"/>
+                      <a:round/>
+                      <a:headEnd type="none" w="med" len="med"/>
+                      <a:tailEnd type="none" w="med" len="med"/>
+                    </a:lnL>
+                    <a:lnR w="9525" cap="flat" cmpd="sng" algn="ctr">
+                      <a:solidFill>
+                        <a:srgbClr val="D8DDE6"/>
+                      </a:solidFill>
+                      <a:prstDash val="solid"/>
+                      <a:round/>
+                      <a:headEnd type="none" w="med" len="med"/>
+                      <a:tailEnd type="none" w="med" len="med"/>
+                    </a:lnR>
+                    <a:lnT w="9525" cap="flat" cmpd="sng" algn="ctr">
+                      <a:solidFill>
+                        <a:srgbClr val="D8DDE6"/>
+                      </a:solidFill>
+                      <a:prstDash val="solid"/>
+                      <a:round/>
+                      <a:headEnd type="none" w="med" len="med"/>
+                      <a:tailEnd type="none" w="med" len="med"/>
+                    </a:lnT>
+                    <a:lnB w="9525" cap="flat" cmpd="sng" algn="ctr">
+                      <a:solidFill>
+                        <a:srgbClr val="D8DDE6"/>
+                      </a:solidFill>
+                      <a:prstDash val="solid"/>
+                      <a:round/>
+                      <a:headEnd type="none" w="med" len="med"/>
+                      <a:tailEnd type="none" w="med" len="med"/>
+                    </a:lnB>
+                  </a:tcPr>
+                </a:tc>
+              </a:tr>
+              <a:tr h="365760">
+                <a:tc>
+                  <a:txBody>
+                    <a:bodyPr/>
+                    <a:lstStyle/>
+                    <a:p>
+                      <a:pPr indent="0" marL="0">
+                        <a:buNone/>
+                      </a:pPr>
+                      <a:r>
+                        <a:rPr lang="en-US" sz="1250" dirty="0">
+                          <a:solidFill>
+                            <a:srgbClr val="000000"/>
+                          </a:solidFill>
+                          <a:latin typeface="Arial" pitchFamily="34" charset="0"/>
+                          <a:ea typeface="Arial" pitchFamily="34" charset="-122"/>
+                          <a:cs typeface="Arial" pitchFamily="34" charset="-120"/>
+                        </a:rPr>
+                        <a:t>Classical params</a:t>
+                      </a:r>
+                      <a:endParaRPr lang="en-US" sz="1250" dirty="0">
+                        <a:latin typeface="Arial" charset="0"/>
+                        <a:ea typeface="Arial" charset="0"/>
+                        <a:cs typeface="Arial" charset="0"/>
+                      </a:endParaRPr>
+                    </a:p>
+                  </a:txBody>
+                  <a:tcPr marL="54864" marR="54864" marT="54864" marB="54864" anchor="ctr">
+                    <a:lnL w="9525" cap="flat" cmpd="sng" algn="ctr">
+                      <a:solidFill>
+                        <a:srgbClr val="D8DDE6"/>
+                      </a:solidFill>
+                      <a:prstDash val="solid"/>
+                      <a:round/>
+                      <a:headEnd type="none" w="med" len="med"/>
+                      <a:tailEnd type="none" w="med" len="med"/>
+                    </a:lnL>
+                    <a:lnR w="9525" cap="flat" cmpd="sng" algn="ctr">
+                      <a:solidFill>
+                        <a:srgbClr val="D8DDE6"/>
+                      </a:solidFill>
+                      <a:prstDash val="solid"/>
+                      <a:round/>
+                      <a:headEnd type="none" w="med" len="med"/>
+                      <a:tailEnd type="none" w="med" len="med"/>
+                    </a:lnR>
+                    <a:lnT w="9525" cap="flat" cmpd="sng" algn="ctr">
+                      <a:solidFill>
+                        <a:srgbClr val="D8DDE6"/>
+                      </a:solidFill>
+                      <a:prstDash val="solid"/>
+                      <a:round/>
+                      <a:headEnd type="none" w="med" len="med"/>
+                      <a:tailEnd type="none" w="med" len="med"/>
+                    </a:lnT>
+                    <a:lnB w="9525" cap="flat" cmpd="sng" algn="ctr">
+                      <a:solidFill>
+                        <a:srgbClr val="D8DDE6"/>
+                      </a:solidFill>
+                      <a:prstDash val="solid"/>
+                      <a:round/>
+                      <a:headEnd type="none" w="med" len="med"/>
+                      <a:tailEnd type="none" w="med" len="med"/>
+                    </a:lnB>
+                  </a:tcPr>
+                </a:tc>
+                <a:tc>
+                  <a:txBody>
+                    <a:bodyPr/>
+                    <a:lstStyle/>
+                    <a:p>
+                      <a:pPr indent="0" marL="0">
+                        <a:buNone/>
+                      </a:pPr>
+                      <a:r>
+                        <a:rPr lang="en-US" sz="1250" dirty="0">
                           <a:solidFill>
                             <a:srgbClr val="000000"/>
                           </a:solidFill>
@@ -4339,14 +4683,14 @@
                         </a:rPr>
                         <a:t>zero - no dense layer can rescue a weak circuit</a:t>
                       </a:r>
-                      <a:endParaRPr lang="en-US" sz="1400" dirty="0">
+                      <a:endParaRPr lang="en-US" sz="1250" dirty="0">
                         <a:latin typeface="Arial" charset="0"/>
                         <a:ea typeface="Arial" charset="0"/>
                         <a:cs typeface="Arial" charset="0"/>
                       </a:endParaRPr>
                     </a:p>
                   </a:txBody>
-                  <a:tcPr marL="64008" marR="64008" marT="64008" marB="64008" anchor="ctr">
+                  <a:tcPr marL="54864" marR="54864" marT="54864" marB="54864" anchor="ctr">
                     <a:lnL w="9525" cap="flat" cmpd="sng" algn="ctr">
                       <a:solidFill>
                         <a:srgbClr val="D8DDE6"/>
@@ -4392,18 +4736,18 @@
       </p:graphicFrame>
       <p:sp>
         <p:nvSpPr>
-          <p:cNvPr id="5" name="Shape 2"/>
+          <p:cNvPr id="7" name="Shape 4"/>
           <p:cNvSpPr/>
           <p:nvPr/>
         </p:nvSpPr>
         <p:spPr>
           <a:xfrm>
-            <a:off x="548640" y="5029200"/>
-            <a:ext cx="11109960" cy="1051560"/>
+            <a:off x="548640" y="5440680"/>
+            <a:ext cx="11109960" cy="822960"/>
           </a:xfrm>
           <a:prstGeom prst="roundRect">
             <a:avLst>
-              <a:gd name="adj" fmla="val 6957"/>
+              <a:gd name="adj" fmla="val 8889"/>
             </a:avLst>
           </a:prstGeom>
           <a:solidFill>
@@ -4419,14 +4763,14 @@
       </p:sp>
       <p:sp>
         <p:nvSpPr>
-          <p:cNvPr id="6" name="Text 3"/>
+          <p:cNvPr id="8" name="Text 5"/>
           <p:cNvSpPr/>
           <p:nvPr/>
         </p:nvSpPr>
         <p:spPr>
           <a:xfrm>
-            <a:off x="777240" y="5138928"/>
-            <a:ext cx="10607040" cy="822960"/>
+            <a:off x="777240" y="5513832"/>
+            <a:ext cx="10607040" cy="685800"/>
           </a:xfrm>
           <a:prstGeom prst="rect">
             <a:avLst/>
@@ -4472,7 +4816,7 @@
       </p:sp>
       <p:sp>
         <p:nvSpPr>
-          <p:cNvPr id="7" name="Text 4"/>
+          <p:cNvPr id="9" name="Text 6"/>
           <p:cNvSpPr/>
           <p:nvPr/>
         </p:nvSpPr>
@@ -4963,6 +5307,86 @@
               <a:t>Five arms, one shared budget of unique candidates</a:t>
             </a:r>
             <a:endParaRPr lang="en-US" sz="3000" dirty="0"/>
+          </a:p>
+        </p:txBody>
+      </p:sp>
+      <p:sp>
+        <p:nvSpPr>
+          <p:cNvPr id="4" name="Shape 2"/>
+          <p:cNvSpPr/>
+          <p:nvPr/>
+        </p:nvSpPr>
+        <p:spPr>
+          <a:xfrm>
+            <a:off x="5699455" y="256032"/>
+            <a:ext cx="5989320" cy="402336"/>
+          </a:xfrm>
+          <a:prstGeom prst="roundRect">
+            <a:avLst>
+              <a:gd name="adj" fmla="val 15909"/>
+            </a:avLst>
+          </a:prstGeom>
+          <a:solidFill>
+            <a:srgbClr val="F4F6FA"/>
+          </a:solidFill>
+          <a:ln w="12700">
+            <a:solidFill>
+              <a:srgbClr val="D8DDE6"/>
+            </a:solidFill>
+            <a:prstDash val="solid"/>
+          </a:ln>
+        </p:spPr>
+      </p:sp>
+      <p:sp>
+        <p:nvSpPr>
+          <p:cNvPr id="5" name="Text 3"/>
+          <p:cNvSpPr/>
+          <p:nvPr/>
+        </p:nvSpPr>
+        <p:spPr>
+          <a:xfrm>
+            <a:off x="5836615" y="274320"/>
+            <a:ext cx="5715000" cy="365760"/>
+          </a:xfrm>
+          <a:prstGeom prst="rect">
+            <a:avLst/>
+          </a:prstGeom>
+          <a:noFill/>
+          <a:ln/>
+        </p:spPr>
+        <p:txBody>
+          <a:bodyPr wrap="square" lIns="0" tIns="0" rIns="0" bIns="0" rtlCol="0" anchor="ctr"/>
+          <a:lstStyle/>
+          <a:p>
+            <a:pPr algn="r" indent="0" marL="0">
+              <a:buNone/>
+            </a:pPr>
+            <a:r>
+              <a:rPr lang="en-US" sz="1150" b="1" dirty="0">
+                <a:solidFill>
+                  <a:srgbClr val="1E3A5F"/>
+                </a:solidFill>
+                <a:latin typeface="Arial" pitchFamily="34" charset="0"/>
+                <a:ea typeface="Arial" pitchFamily="34" charset="-122"/>
+                <a:cs typeface="Arial" pitchFamily="34" charset="-120"/>
+              </a:rPr>
+              <a:t>Applies to all three conditions</a:t>
+            </a:r>
+            <a:pPr algn="r" indent="0" marL="0">
+              <a:buNone/>
+            </a:pPr>
+            <a:r>
+              <a:rPr lang="en-US" sz="1150" dirty="0">
+                <a:solidFill>
+                  <a:srgbClr val="55606E"/>
+                </a:solidFill>
+                <a:latin typeface="Arial" pitchFamily="34" charset="0"/>
+                <a:ea typeface="Arial" pitchFamily="34" charset="-122"/>
+                <a:cs typeface="Arial" pitchFamily="34" charset="-120"/>
+              </a:rPr>
+              <a:t>   arms are identical throughout</a:t>
+            </a:r>
+            <a:endParaRPr lang="en-US" sz="1150" dirty="0"/>
           </a:p>
         </p:txBody>
       </p:sp>
@@ -6190,7 +6614,7 @@
       </p:graphicFrame>
       <p:sp>
         <p:nvSpPr>
-          <p:cNvPr id="5" name="Shape 2"/>
+          <p:cNvPr id="7" name="Shape 4"/>
           <p:cNvSpPr/>
           <p:nvPr/>
         </p:nvSpPr>
@@ -6217,7 +6641,7 @@
       </p:sp>
       <p:sp>
         <p:nvSpPr>
-          <p:cNvPr id="6" name="Text 3"/>
+          <p:cNvPr id="8" name="Text 5"/>
           <p:cNvSpPr/>
           <p:nvPr/>
         </p:nvSpPr>
@@ -6270,7 +6694,7 @@
       </p:sp>
       <p:sp>
         <p:nvSpPr>
-          <p:cNvPr id="7" name="Text 4"/>
+          <p:cNvPr id="9" name="Text 6"/>
           <p:cNvSpPr/>
           <p:nvPr/>
         </p:nvSpPr>
@@ -6417,9 +6841,89 @@
           </a:p>
         </p:txBody>
       </p:sp>
+      <p:sp>
+        <p:nvSpPr>
+          <p:cNvPr id="4" name="Shape 2"/>
+          <p:cNvSpPr/>
+          <p:nvPr/>
+        </p:nvSpPr>
+        <p:spPr>
+          <a:xfrm>
+            <a:off x="5699455" y="256032"/>
+            <a:ext cx="5989320" cy="402336"/>
+          </a:xfrm>
+          <a:prstGeom prst="roundRect">
+            <a:avLst>
+              <a:gd name="adj" fmla="val 15909"/>
+            </a:avLst>
+          </a:prstGeom>
+          <a:solidFill>
+            <a:srgbClr val="F4F6FA"/>
+          </a:solidFill>
+          <a:ln w="12700">
+            <a:solidFill>
+              <a:srgbClr val="D8DDE6"/>
+            </a:solidFill>
+            <a:prstDash val="solid"/>
+          </a:ln>
+        </p:spPr>
+      </p:sp>
+      <p:sp>
+        <p:nvSpPr>
+          <p:cNvPr id="5" name="Text 3"/>
+          <p:cNvSpPr/>
+          <p:nvPr/>
+        </p:nvSpPr>
+        <p:spPr>
+          <a:xfrm>
+            <a:off x="5836615" y="274320"/>
+            <a:ext cx="5715000" cy="365760"/>
+          </a:xfrm>
+          <a:prstGeom prst="rect">
+            <a:avLst/>
+          </a:prstGeom>
+          <a:noFill/>
+          <a:ln/>
+        </p:spPr>
+        <p:txBody>
+          <a:bodyPr wrap="square" lIns="0" tIns="0" rIns="0" bIns="0" rtlCol="0" anchor="ctr"/>
+          <a:lstStyle/>
+          <a:p>
+            <a:pPr algn="r" indent="0" marL="0">
+              <a:buNone/>
+            </a:pPr>
+            <a:r>
+              <a:rPr lang="en-US" sz="1150" b="1" dirty="0">
+                <a:solidFill>
+                  <a:srgbClr val="1E3A5F"/>
+                </a:solidFill>
+                <a:latin typeface="Arial" pitchFamily="34" charset="0"/>
+                <a:ea typeface="Arial" pitchFamily="34" charset="-122"/>
+                <a:cs typeface="Arial" pitchFamily="34" charset="-120"/>
+              </a:rPr>
+              <a:t>PRIMARY: exactly 5 gates, B = 8, 10 seeds</a:t>
+            </a:r>
+            <a:pPr algn="r" indent="0" marL="0">
+              <a:buNone/>
+            </a:pPr>
+            <a:r>
+              <a:rPr lang="en-US" sz="1150" dirty="0">
+                <a:solidFill>
+                  <a:srgbClr val="55606E"/>
+                </a:solidFill>
+                <a:latin typeface="Arial" pitchFamily="34" charset="0"/>
+                <a:ea typeface="Arial" pitchFamily="34" charset="-122"/>
+                <a:cs typeface="Arial" pitchFamily="34" charset="-120"/>
+              </a:rPr>
+              <a:t>   all four tasks, T1-T4</a:t>
+            </a:r>
+            <a:endParaRPr lang="en-US" sz="1150" dirty="0"/>
+          </a:p>
+        </p:txBody>
+      </p:sp>
       <p:pic>
         <p:nvPicPr>
-          <p:cNvPr id="4" name="Image 0" descr="/Users/hatanakatomoya/Developer/Sim/llm-vqc/.claude/worktrees/github-author-config-faee6e/docs/presentation/mini5/figures/fig_main.png">    </p:cNvPr>
+          <p:cNvPr id="6" name="Image 0" descr="/Users/hatanakatomoya/Developer/Sim/llm-vqc/.claude/worktrees/github-author-config-faee6e/docs/presentation/mini5/figures/fig_main.png">    </p:cNvPr>
           <p:cNvPicPr>
             <a:picLocks noChangeAspect="1"/>
           </p:cNvPicPr>
@@ -6443,7 +6947,7 @@
       </p:pic>
       <p:sp>
         <p:nvSpPr>
-          <p:cNvPr id="5" name="Shape 2"/>
+          <p:cNvPr id="7" name="Shape 4"/>
           <p:cNvSpPr/>
           <p:nvPr/>
         </p:nvSpPr>
@@ -6470,7 +6974,7 @@
       </p:sp>
       <p:sp>
         <p:nvSpPr>
-          <p:cNvPr id="6" name="Text 3"/>
+          <p:cNvPr id="8" name="Text 5"/>
           <p:cNvSpPr/>
           <p:nvPr/>
         </p:nvSpPr>
@@ -6537,7 +7041,7 @@
       </p:sp>
       <p:sp>
         <p:nvSpPr>
-          <p:cNvPr id="7" name="Text 4"/>
+          <p:cNvPr id="9" name="Text 6"/>
           <p:cNvSpPr/>
           <p:nvPr/>
         </p:nvSpPr>
@@ -6684,9 +7188,89 @@
           </a:p>
         </p:txBody>
       </p:sp>
+      <p:sp>
+        <p:nvSpPr>
+          <p:cNvPr id="4" name="Shape 2"/>
+          <p:cNvSpPr/>
+          <p:nvPr/>
+        </p:nvSpPr>
+        <p:spPr>
+          <a:xfrm>
+            <a:off x="5699455" y="256032"/>
+            <a:ext cx="5989320" cy="402336"/>
+          </a:xfrm>
+          <a:prstGeom prst="roundRect">
+            <a:avLst>
+              <a:gd name="adj" fmla="val 15909"/>
+            </a:avLst>
+          </a:prstGeom>
+          <a:solidFill>
+            <a:srgbClr val="F4F6FA"/>
+          </a:solidFill>
+          <a:ln w="12700">
+            <a:solidFill>
+              <a:srgbClr val="D8DDE6"/>
+            </a:solidFill>
+            <a:prstDash val="solid"/>
+          </a:ln>
+        </p:spPr>
+      </p:sp>
+      <p:sp>
+        <p:nvSpPr>
+          <p:cNvPr id="5" name="Text 3"/>
+          <p:cNvSpPr/>
+          <p:nvPr/>
+        </p:nvSpPr>
+        <p:spPr>
+          <a:xfrm>
+            <a:off x="5836615" y="274320"/>
+            <a:ext cx="5715000" cy="365760"/>
+          </a:xfrm>
+          <a:prstGeom prst="rect">
+            <a:avLst/>
+          </a:prstGeom>
+          <a:noFill/>
+          <a:ln/>
+        </p:spPr>
+        <p:txBody>
+          <a:bodyPr wrap="square" lIns="0" tIns="0" rIns="0" bIns="0" rtlCol="0" anchor="ctr"/>
+          <a:lstStyle/>
+          <a:p>
+            <a:pPr algn="r" indent="0" marL="0">
+              <a:buNone/>
+            </a:pPr>
+            <a:r>
+              <a:rPr lang="en-US" sz="1150" b="1" dirty="0">
+                <a:solidFill>
+                  <a:srgbClr val="1E3A5F"/>
+                </a:solidFill>
+                <a:latin typeface="Arial" pitchFamily="34" charset="0"/>
+                <a:ea typeface="Arial" pitchFamily="34" charset="-122"/>
+                <a:cs typeface="Arial" pitchFamily="34" charset="-120"/>
+              </a:rPr>
+              <a:t>PRIMARY: exactly 5 gates, B = 8, 10 seeds</a:t>
+            </a:r>
+            <a:pPr algn="r" indent="0" marL="0">
+              <a:buNone/>
+            </a:pPr>
+            <a:r>
+              <a:rPr lang="en-US" sz="1150" dirty="0">
+                <a:solidFill>
+                  <a:srgbClr val="55606E"/>
+                </a:solidFill>
+                <a:latin typeface="Arial" pitchFamily="34" charset="0"/>
+                <a:ea typeface="Arial" pitchFamily="34" charset="-122"/>
+                <a:cs typeface="Arial" pitchFamily="34" charset="-120"/>
+              </a:rPr>
+              <a:t>   T4 only (peak count, 5 qubits)</a:t>
+            </a:r>
+            <a:endParaRPr lang="en-US" sz="1150" dirty="0"/>
+          </a:p>
+        </p:txBody>
+      </p:sp>
       <p:pic>
         <p:nvPicPr>
-          <p:cNvPr id="4" name="Image 0" descr="/Users/hatanakatomoya/Developer/Sim/llm-vqc/.claude/worktrees/github-author-config-faee6e/docs/presentation/mini5/figures/fig_t4_check.png">    </p:cNvPr>
+          <p:cNvPr id="6" name="Image 0" descr="/Users/hatanakatomoya/Developer/Sim/llm-vqc/.claude/worktrees/github-author-config-faee6e/docs/presentation/mini5/figures/fig_t4_check.png">    </p:cNvPr>
           <p:cNvPicPr>
             <a:picLocks noChangeAspect="1"/>
           </p:cNvPicPr>
@@ -6710,7 +7294,7 @@
       </p:pic>
       <p:sp>
         <p:nvSpPr>
-          <p:cNvPr id="5" name="Text 2"/>
+          <p:cNvPr id="7" name="Text 4"/>
           <p:cNvSpPr/>
           <p:nvPr/>
         </p:nvSpPr>
@@ -6828,7 +7412,7 @@
       </p:sp>
       <p:sp>
         <p:nvSpPr>
-          <p:cNvPr id="6" name="Shape 3"/>
+          <p:cNvPr id="8" name="Shape 5"/>
           <p:cNvSpPr/>
           <p:nvPr/>
         </p:nvSpPr>
@@ -6855,7 +7439,7 @@
       </p:sp>
       <p:sp>
         <p:nvSpPr>
-          <p:cNvPr id="7" name="Text 4"/>
+          <p:cNvPr id="9" name="Text 6"/>
           <p:cNvSpPr/>
           <p:nvPr/>
         </p:nvSpPr>
@@ -6908,7 +7492,7 @@
       </p:sp>
       <p:sp>
         <p:nvSpPr>
-          <p:cNvPr id="8" name="Text 5"/>
+          <p:cNvPr id="10" name="Text 7"/>
           <p:cNvSpPr/>
           <p:nvPr/>
         </p:nvSpPr>
@@ -7055,9 +7639,89 @@
           </a:p>
         </p:txBody>
       </p:sp>
+      <p:sp>
+        <p:nvSpPr>
+          <p:cNvPr id="4" name="Shape 2"/>
+          <p:cNvSpPr/>
+          <p:nvPr/>
+        </p:nvSpPr>
+        <p:spPr>
+          <a:xfrm>
+            <a:off x="5699455" y="256032"/>
+            <a:ext cx="5989320" cy="402336"/>
+          </a:xfrm>
+          <a:prstGeom prst="roundRect">
+            <a:avLst>
+              <a:gd name="adj" fmla="val 15909"/>
+            </a:avLst>
+          </a:prstGeom>
+          <a:solidFill>
+            <a:srgbClr val="F4F6FA"/>
+          </a:solidFill>
+          <a:ln w="12700">
+            <a:solidFill>
+              <a:srgbClr val="D8DDE6"/>
+            </a:solidFill>
+            <a:prstDash val="solid"/>
+          </a:ln>
+        </p:spPr>
+      </p:sp>
+      <p:sp>
+        <p:nvSpPr>
+          <p:cNvPr id="5" name="Text 3"/>
+          <p:cNvSpPr/>
+          <p:nvPr/>
+        </p:nvSpPr>
+        <p:spPr>
+          <a:xfrm>
+            <a:off x="5836615" y="274320"/>
+            <a:ext cx="5715000" cy="365760"/>
+          </a:xfrm>
+          <a:prstGeom prst="rect">
+            <a:avLst/>
+          </a:prstGeom>
+          <a:noFill/>
+          <a:ln/>
+        </p:spPr>
+        <p:txBody>
+          <a:bodyPr wrap="square" lIns="0" tIns="0" rIns="0" bIns="0" rtlCol="0" anchor="ctr"/>
+          <a:lstStyle/>
+          <a:p>
+            <a:pPr algn="r" indent="0" marL="0">
+              <a:buNone/>
+            </a:pPr>
+            <a:r>
+              <a:rPr lang="en-US" sz="1150" b="1" dirty="0">
+                <a:solidFill>
+                  <a:srgbClr val="1E3A5F"/>
+                </a:solidFill>
+                <a:latin typeface="Arial" pitchFamily="34" charset="0"/>
+                <a:ea typeface="Arial" pitchFamily="34" charset="-122"/>
+                <a:cs typeface="Arial" pitchFamily="34" charset="-120"/>
+              </a:rPr>
+              <a:t>ALL THREE CONDITIONS side by side</a:t>
+            </a:r>
+            <a:pPr algn="r" indent="0" marL="0">
+              <a:buNone/>
+            </a:pPr>
+            <a:r>
+              <a:rPr lang="en-US" sz="1150" dirty="0">
+                <a:solidFill>
+                  <a:srgbClr val="55606E"/>
+                </a:solidFill>
+                <a:latin typeface="Arial" pitchFamily="34" charset="0"/>
+                <a:ea typeface="Arial" pitchFamily="34" charset="-122"/>
+                <a:cs typeface="Arial" pitchFamily="34" charset="-120"/>
+              </a:rPr>
+              <a:t>   T1 only (Gaussian peak, 3 qubits)</a:t>
+            </a:r>
+            <a:endParaRPr lang="en-US" sz="1150" dirty="0"/>
+          </a:p>
+        </p:txBody>
+      </p:sp>
       <p:pic>
         <p:nvPicPr>
-          <p:cNvPr id="4" name="Image 0" descr="/Users/hatanakatomoya/Developer/Sim/llm-vqc/.claude/worktrees/github-author-config-faee6e/docs/presentation/mini5/figures/fig_size_confound.png">    </p:cNvPr>
+          <p:cNvPr id="6" name="Image 0" descr="/Users/hatanakatomoya/Developer/Sim/llm-vqc/.claude/worktrees/github-author-config-faee6e/docs/presentation/mini5/figures/fig_size_confound.png">    </p:cNvPr>
           <p:cNvPicPr>
             <a:picLocks noChangeAspect="1"/>
           </p:cNvPicPr>
@@ -7081,7 +7745,7 @@
       </p:pic>
       <p:sp>
         <p:nvSpPr>
-          <p:cNvPr id="5" name="Shape 2"/>
+          <p:cNvPr id="7" name="Shape 4"/>
           <p:cNvSpPr/>
           <p:nvPr/>
         </p:nvSpPr>
@@ -7108,7 +7772,7 @@
       </p:sp>
       <p:sp>
         <p:nvSpPr>
-          <p:cNvPr id="6" name="Text 3"/>
+          <p:cNvPr id="8" name="Text 5"/>
           <p:cNvSpPr/>
           <p:nvPr/>
         </p:nvSpPr>
@@ -7189,7 +7853,7 @@
       </p:sp>
       <p:sp>
         <p:nvSpPr>
-          <p:cNvPr id="7" name="Text 4"/>
+          <p:cNvPr id="9" name="Text 6"/>
           <p:cNvSpPr/>
           <p:nvPr/>
         </p:nvSpPr>
@@ -7220,7 +7884,7 @@
                 <a:ea typeface="Arial" pitchFamily="34" charset="-122"/>
                 <a:cs typeface="Arial" pitchFamily="34" charset="-120"/>
               </a:rPr>
-              <a:t>Three conditions, same code, same model, same tasks, 10 seeds each · data/condition_comparison.json</a:t>
+              <a:t>All three conditions ran all four tasks with 10 seeds; T1 is shown here because it is the family the pilot used · data/condition_comparison.json</a:t>
             </a:r>
             <a:endParaRPr lang="en-US" sz="1100" dirty="0"/>
           </a:p>
@@ -7336,9 +8000,89 @@
           </a:p>
         </p:txBody>
       </p:sp>
+      <p:sp>
+        <p:nvSpPr>
+          <p:cNvPr id="4" name="Shape 2"/>
+          <p:cNvSpPr/>
+          <p:nvPr/>
+        </p:nvSpPr>
+        <p:spPr>
+          <a:xfrm>
+            <a:off x="5699455" y="256032"/>
+            <a:ext cx="5989320" cy="402336"/>
+          </a:xfrm>
+          <a:prstGeom prst="roundRect">
+            <a:avLst>
+              <a:gd name="adj" fmla="val 15909"/>
+            </a:avLst>
+          </a:prstGeom>
+          <a:solidFill>
+            <a:srgbClr val="F4F6FA"/>
+          </a:solidFill>
+          <a:ln w="12700">
+            <a:solidFill>
+              <a:srgbClr val="D8DDE6"/>
+            </a:solidFill>
+            <a:prstDash val="solid"/>
+          </a:ln>
+        </p:spPr>
+      </p:sp>
+      <p:sp>
+        <p:nvSpPr>
+          <p:cNvPr id="5" name="Text 3"/>
+          <p:cNvSpPr/>
+          <p:nvPr/>
+        </p:nvSpPr>
+        <p:spPr>
+          <a:xfrm>
+            <a:off x="5836615" y="274320"/>
+            <a:ext cx="5715000" cy="365760"/>
+          </a:xfrm>
+          <a:prstGeom prst="rect">
+            <a:avLst/>
+          </a:prstGeom>
+          <a:noFill/>
+          <a:ln/>
+        </p:spPr>
+        <p:txBody>
+          <a:bodyPr wrap="square" lIns="0" tIns="0" rIns="0" bIns="0" rtlCol="0" anchor="ctr"/>
+          <a:lstStyle/>
+          <a:p>
+            <a:pPr algn="r" indent="0" marL="0">
+              <a:buNone/>
+            </a:pPr>
+            <a:r>
+              <a:rPr lang="en-US" sz="1150" b="1" dirty="0">
+                <a:solidFill>
+                  <a:srgbClr val="1E3A5F"/>
+                </a:solidFill>
+                <a:latin typeface="Arial" pitchFamily="34" charset="0"/>
+                <a:ea typeface="Arial" pitchFamily="34" charset="-122"/>
+                <a:cs typeface="Arial" pitchFamily="34" charset="-120"/>
+              </a:rPr>
+              <a:t>PRIMARY: exactly 5 gates, B = 8, 10 seeds</a:t>
+            </a:r>
+            <a:pPr algn="r" indent="0" marL="0">
+              <a:buNone/>
+            </a:pPr>
+            <a:r>
+              <a:rPr lang="en-US" sz="1150" dirty="0">
+                <a:solidFill>
+                  <a:srgbClr val="55606E"/>
+                </a:solidFill>
+                <a:latin typeface="Arial" pitchFamily="34" charset="0"/>
+                <a:ea typeface="Arial" pitchFamily="34" charset="-122"/>
+                <a:cs typeface="Arial" pitchFamily="34" charset="-120"/>
+              </a:rPr>
+              <a:t>   all four tasks, T1-T4</a:t>
+            </a:r>
+            <a:endParaRPr lang="en-US" sz="1150" dirty="0"/>
+          </a:p>
+        </p:txBody>
+      </p:sp>
       <p:pic>
         <p:nvPicPr>
-          <p:cNvPr id="4" name="Image 0" descr="/Users/hatanakatomoya/Developer/Sim/llm-vqc/.claude/worktrees/github-author-config-faee6e/docs/presentation/mini5/figures/fig_anytime.png">    </p:cNvPr>
+          <p:cNvPr id="6" name="Image 0" descr="/Users/hatanakatomoya/Developer/Sim/llm-vqc/.claude/worktrees/github-author-config-faee6e/docs/presentation/mini5/figures/fig_anytime.png">    </p:cNvPr>
           <p:cNvPicPr>
             <a:picLocks noChangeAspect="1"/>
           </p:cNvPicPr>
@@ -7362,7 +8106,7 @@
       </p:pic>
       <p:sp>
         <p:nvSpPr>
-          <p:cNvPr id="5" name="Text 2"/>
+          <p:cNvPr id="7" name="Text 4"/>
           <p:cNvSpPr/>
           <p:nvPr/>
         </p:nvSpPr>
@@ -7432,7 +8176,7 @@
       </p:sp>
       <p:sp>
         <p:nvSpPr>
-          <p:cNvPr id="6" name="Text 3"/>
+          <p:cNvPr id="8" name="Text 5"/>
           <p:cNvSpPr/>
           <p:nvPr/>
         </p:nvSpPr>

</xml_diff>

<commit_message>
Rebuild the deck around what 30 seeds actually showed
The headline changes from "the advantage was circuit size" to the fuller
story: three times an apparent LLM advantage turned out to be something
else. Slide 6 reports the 30-seed result across six arms - significant
against the fixed ansatz on all four tasks, no difference detected
against random on any, with random holding the better median on three of
them. Slide 9 replaces the search-dynamics plot with the hypothesis I
built and then refuted: the hybrid arm fixed the LLM's starting point and
reached the best final median of any arm, and its improvement rate fell
from 17% to 7%, below random's 9%. The 17% was never refinement skill.

A caption error is fixed on the way: an earlier draft cited T1 as
evidence that random holds the better median, when T1 is the one task
where the LLM's median leads (0.110 vs 0.119, not significant).

Co-Authored-By: Claude Opus 5 <noreply@anthropic.com>
</commit_message>
<xml_diff>
--- a/docs/presentation/mini5/20260731_GSoC_mini5.pptx
+++ b/docs/presentation/mini5/20260731_GSoC_mini5.pptx
@@ -1039,7 +1039,7 @@
           <a:p>
             <a:r>
               <a:rPr lang="en-US" dirty="0"/>
-              <a:t>Read the medians, not the individual dots. Random is best on T1, T3 and T4. The LLM arms win on T2 and only there. I am reporting this as measured; it is a negative result for the LLM hypothesis at this scale.</a:t>
+              <a:t>Read the medians. Against the fixed hardware-efficient ansatz every search method wins, decisively. Against random search the LLM wins nothing, and random has the better median on three of four tasks.</a:t>
             </a:r>
             <a:endParaRPr lang="en-US" dirty="0"/>
           </a:p>
@@ -1303,7 +1303,7 @@
           <a:p>
             <a:r>
               <a:rPr lang="en-US" dirty="0"/>
-              <a:t>Worth being explicit: the first version of this experiment handicapped closed-loop through a prompt defect. I fixed it and re-ran rather than reporting the handicapped numbers. Even after the fix, feedback did not help.</a:t>
+              <a:t>This is the slide I would keep if I could keep only one. The diagnosis was that the LLM refines well but starts badly, so I gave it a good start. The start improved, the final score improved, and the refinement rate collapsed below random. The 17 percent was never skill.</a:t>
             </a:r>
             <a:endParaRPr lang="en-US" dirty="0"/>
           </a:p>
@@ -1712,27 +1712,7 @@
                 <a:ea typeface="Arial" pitchFamily="34" charset="-122"/>
                 <a:cs typeface="Arial" pitchFamily="34" charset="-120"/>
               </a:rPr>
-              <a:t>Does an LLM design better quantum circuits,</a:t>
-            </a:r>
-            <a:endParaRPr lang="en-US" sz="4000" dirty="0"/>
-          </a:p>
-          <a:p>
-            <a:pPr indent="0" marL="0">
-              <a:lnSpc>
-                <a:spcPct val="105000"/>
-              </a:lnSpc>
-              <a:buNone/>
-            </a:pPr>
-            <a:r>
-              <a:rPr lang="en-US" sz="4000" b="1" dirty="0">
-                <a:solidFill>
-                  <a:srgbClr val="FFFFFF"/>
-                </a:solidFill>
-                <a:latin typeface="Arial" pitchFamily="34" charset="0"/>
-                <a:ea typeface="Arial" pitchFamily="34" charset="-122"/>
-                <a:cs typeface="Arial" pitchFamily="34" charset="-120"/>
-              </a:rPr>
-              <a:t>or just bigger ones?</a:t>
+              <a:t>Three ways an LLM looked better than it was</a:t>
             </a:r>
             <a:endParaRPr lang="en-US" sz="4000" dirty="0"/>
           </a:p>
@@ -1771,7 +1751,7 @@
                 <a:ea typeface="Arial" pitchFamily="34" charset="-122"/>
                 <a:cs typeface="Arial" pitchFamily="34" charset="-120"/>
               </a:rPr>
-              <a:t>A five-gate, fixed-length comparison of LLM-guided and classical circuit search</a:t>
+              <a:t>Removing one confound at a time from an LLM-guided quantum circuit search</a:t>
             </a:r>
             <a:endParaRPr lang="en-US" sz="2000" dirty="0"/>
           </a:p>
@@ -1853,7 +1833,7 @@
                 <a:ea typeface="Arial" pitchFamily="34" charset="-122"/>
                 <a:cs typeface="Arial" pitchFamily="34" charset="-120"/>
               </a:rPr>
-              <a:t>last week's LLM advantage was mostly a circuit-size decision. Remove that one degree of freedom and it disappears on three of four tasks.</a:t>
+              <a:t>each apparent advantage came from something other than design skill - circuit size, then a bad starting point. The LLM beats a textbook ansatz on all four tasks and never beats random search on any (30 seeds).</a:t>
             </a:r>
             <a:endParaRPr lang="en-US" sz="1800" dirty="0"/>
           </a:p>
@@ -1970,7 +1950,7 @@
                 <a:ea typeface="Arial" pitchFamily="34" charset="-122"/>
                 <a:cs typeface="Arial" pitchFamily="34" charset="-120"/>
               </a:rPr>
-              <a:t>July 31, 2026  ·  commit cb5c29e  ·  experiment/bench-v2-real-llm-cost-minimal</a:t>
+              <a:t>July 31, 2026  ·  commit a01d11a  ·  experiment/bench-v2-real-llm-cost-minimal</a:t>
             </a:r>
             <a:endParaRPr lang="en-US" sz="1200" dirty="0"/>
           </a:p>
@@ -2155,7 +2135,7 @@
                 <a:ea typeface="Arial" pitchFamily="34" charset="-122"/>
                 <a:cs typeface="Arial" pitchFamily="34" charset="-120"/>
               </a:rPr>
-              <a:t>Length fixed: no win over random on 3 of 4 tasks</a:t>
+              <a:t>The LLM beats a textbook ansatz on all 4 tasks</a:t>
             </a:r>
             <a:endParaRPr lang="en-US" sz="1450" dirty="0"/>
           </a:p>
@@ -2179,7 +2159,7 @@
                 <a:ea typeface="Arial" pitchFamily="34" charset="-122"/>
                 <a:cs typeface="Arial" pitchFamily="34" charset="-120"/>
               </a:rPr>
-              <a:t>Clear win on T2, across all 10 seeds</a:t>
+              <a:t>It never beats random search - 30 seeds, 12 pre-declared contrasts</a:t>
             </a:r>
             <a:endParaRPr lang="en-US" sz="1450" dirty="0"/>
           </a:p>
@@ -2203,7 +2183,7 @@
                 <a:ea typeface="Arial" pitchFamily="34" charset="-122"/>
                 <a:cs typeface="Arial" pitchFamily="34" charset="-120"/>
               </a:rPr>
-              <a:t>Length free: the LLM picks the maximum ~70% of the time</a:t>
+              <a:t>Given free length it picks the maximum ~70% of the time</a:t>
             </a:r>
             <a:endParaRPr lang="en-US" sz="1450" dirty="0"/>
           </a:p>
@@ -2227,7 +2207,7 @@
                 <a:ea typeface="Arial" pitchFamily="34" charset="-122"/>
                 <a:cs typeface="Arial" pitchFamily="34" charset="-120"/>
               </a:rPr>
-              <a:t>That one choice explains most of last week's advantage</a:t>
+              <a:t>Its apparent refinement skill vanishes given a good start</a:t>
             </a:r>
             <a:endParaRPr lang="en-US" sz="1450" dirty="0"/>
           </a:p>
@@ -2341,7 +2321,7 @@
                 <a:ea typeface="Arial" pitchFamily="34" charset="-122"/>
                 <a:cs typeface="Arial" pitchFamily="34" charset="-120"/>
               </a:rPr>
-              <a:t>"LLMs cannot design circuits" - one small model, one budget</a:t>
+              <a:t>"LLMs cannot design circuits" - one small model, B = 8</a:t>
             </a:r>
             <a:endParaRPr lang="en-US" sz="1450" dirty="0"/>
           </a:p>
@@ -2365,7 +2345,7 @@
                 <a:ea typeface="Arial" pitchFamily="34" charset="-122"/>
                 <a:cs typeface="Arial" pitchFamily="34" charset="-120"/>
               </a:rPr>
-              <a:t>"Feedback does not work" - it failed here, at this scale</a:t>
+              <a:t>"Task context does not help" - never A/B tested at equal seeds</a:t>
             </a:r>
             <a:endParaRPr lang="en-US" sz="1450" dirty="0"/>
           </a:p>
@@ -5381,7 +5361,7 @@
                 <a:ea typeface="Arial" pitchFamily="34" charset="-122"/>
                 <a:cs typeface="Arial" pitchFamily="34" charset="-120"/>
               </a:rPr>
-              <a:t>Random search wins on three of four tasks</a:t>
+              <a:t>The LLM beats the textbook ansatz, never beats random</a:t>
             </a:r>
             <a:endParaRPr lang="en-US" sz="3000" dirty="0"/>
           </a:p>
@@ -5447,7 +5427,7 @@
                 <a:ea typeface="Arial" pitchFamily="34" charset="-122"/>
                 <a:cs typeface="Arial" pitchFamily="34" charset="-120"/>
               </a:rPr>
-              <a:t>PRIMARY: exactly 5 gates, B = 8, 10 seeds</a:t>
+              <a:t>16 gates, 5 qubits, B = 8, 30 seeds</a:t>
             </a:r>
             <a:pPr algn="r" indent="0" marL="0">
               <a:buNone/>
@@ -5461,7 +5441,7 @@
                 <a:ea typeface="Arial" pitchFamily="34" charset="-122"/>
                 <a:cs typeface="Arial" pitchFamily="34" charset="-120"/>
               </a:rPr>
-              <a:t>   all four tasks, T1-T4</a:t>
+              <a:t>   all four tasks</a:t>
             </a:r>
             <a:endParaRPr lang="en-US" sz="1150" dirty="0"/>
           </a:p>
@@ -5469,7 +5449,7 @@
       </p:sp>
       <p:pic>
         <p:nvPicPr>
-          <p:cNvPr id="6" name="Image 0" descr="/Users/hatanakatomoya/Developer/Sim/llm-vqc/.claude/worktrees/github-author-config-faee6e/docs/presentation/mini5/figures/fig_main.png">    </p:cNvPr>
+          <p:cNvPr id="6" name="Image 0" descr="/Users/hatanakatomoya/Developer/Sim/llm-vqc/.claude/worktrees/github-author-config-faee6e/docs/presentation/mini5/figures/fig_v2_main.png">    </p:cNvPr>
           <p:cNvPicPr>
             <a:picLocks noChangeAspect="1"/>
           </p:cNvPicPr>
@@ -5483,8 +5463,8 @@
         </p:blipFill>
         <p:spPr>
           <a:xfrm>
-            <a:off x="320040" y="1371600"/>
-            <a:ext cx="11521440" cy="3611880"/>
+            <a:off x="274320" y="1371600"/>
+            <a:ext cx="11658600" cy="3337560"/>
           </a:xfrm>
           <a:prstGeom prst="rect">
             <a:avLst/>
@@ -5499,12 +5479,12 @@
         </p:nvSpPr>
         <p:spPr>
           <a:xfrm>
-            <a:off x="548640" y="5230368"/>
-            <a:ext cx="11109960" cy="914400"/>
+            <a:off x="548640" y="5029200"/>
+            <a:ext cx="11109960" cy="1051560"/>
           </a:xfrm>
           <a:prstGeom prst="roundRect">
             <a:avLst>
-              <a:gd name="adj" fmla="val 8000"/>
+              <a:gd name="adj" fmla="val 6957"/>
             </a:avLst>
           </a:prstGeom>
           <a:solidFill>
@@ -5526,8 +5506,8 @@
         </p:nvSpPr>
         <p:spPr>
           <a:xfrm>
-            <a:off x="777240" y="5340096"/>
-            <a:ext cx="10607040" cy="731520"/>
+            <a:off x="777240" y="5138928"/>
+            <a:ext cx="10607040" cy="822960"/>
           </a:xfrm>
           <a:prstGeom prst="rect">
             <a:avLst/>
@@ -5543,7 +5523,7 @@
               <a:buNone/>
             </a:pPr>
             <a:r>
-              <a:rPr lang="en-US" sz="1600" b="1" dirty="0">
+              <a:rPr lang="en-US" sz="1650" b="1" dirty="0">
                 <a:solidFill>
                   <a:srgbClr val="0B7A4B"/>
                 </a:solidFill>
@@ -5551,13 +5531,27 @@
                 <a:ea typeface="Arial" pitchFamily="34" charset="-122"/>
                 <a:cs typeface="Arial" pitchFamily="34" charset="-120"/>
               </a:rPr>
-              <a:t>The LLM wins on T2 alone, and there it wins clearly </a:t>
+              <a:t>vs the fixed ansatz: significant on all 4 tasks. </a:t>
             </a:r>
             <a:pPr indent="0" marL="0">
               <a:buNone/>
             </a:pPr>
             <a:r>
-              <a:rPr lang="en-US" sz="1600" dirty="0">
+              <a:rPr lang="en-US" sz="1650" b="1" dirty="0">
+                <a:solidFill>
+                  <a:srgbClr val="B3261E"/>
+                </a:solidFill>
+                <a:latin typeface="Arial" pitchFamily="34" charset="0"/>
+                <a:ea typeface="Arial" pitchFamily="34" charset="-122"/>
+                <a:cs typeface="Arial" pitchFamily="34" charset="-120"/>
+              </a:rPr>
+              <a:t>  vs random: no difference detected on any. </a:t>
+            </a:r>
+            <a:pPr indent="0" marL="0">
+              <a:buNone/>
+            </a:pPr>
+            <a:r>
+              <a:rPr lang="en-US" sz="1650" dirty="0">
                 <a:solidFill>
                   <a:srgbClr val="1A1A2E"/>
                 </a:solidFill>
@@ -5565,23 +5559,9 @@
                 <a:ea typeface="Arial" pitchFamily="34" charset="-122"/>
                 <a:cs typeface="Arial" pitchFamily="34" charset="-120"/>
               </a:rPr>
-              <a:t>(0.204 vs 0.295).   </a:t>
-            </a:r>
-            <a:pPr indent="0" marL="0">
-              <a:buNone/>
-            </a:pPr>
-            <a:r>
-              <a:rPr lang="en-US" sz="1600" b="1" dirty="0">
-                <a:solidFill>
-                  <a:srgbClr val="B3261E"/>
-                </a:solidFill>
-                <a:latin typeface="Arial" pitchFamily="34" charset="0"/>
-                <a:ea typeface="Arial" pitchFamily="34" charset="-122"/>
-                <a:cs typeface="Arial" pitchFamily="34" charset="-120"/>
-              </a:rPr>
-              <a:t>Closed-loop never beats open-loop on any task: eight rounds of feedback did not help this model at this budget.</a:t>
-            </a:r>
-            <a:endParaRPr lang="en-US" sz="1600" dirty="0"/>
+              <a:t>Random holds the better median on T2, T3 and T4 (T3 0.180 vs 0.212); the LLM leads only on T1 (0.110 vs 0.119), and not significantly.</a:t>
+            </a:r>
+            <a:endParaRPr lang="en-US" sz="1650" dirty="0"/>
           </a:p>
         </p:txBody>
       </p:sp>
@@ -5618,7 +5598,7 @@
                 <a:ea typeface="Arial" pitchFamily="34" charset="-122"/>
                 <a:cs typeface="Arial" pitchFamily="34" charset="-120"/>
               </a:rPr>
-              <a:t>10 seeds per arm, B = 8, exactly 5 gates · data/per_cell.csv</a:t>
+              <a:t>Wilcoxon signed-rank on 30 paired seeds; Holm over the 12 pre-declared primary contrasts · data/ctx_analysis.json</a:t>
             </a:r>
             <a:endParaRPr lang="en-US" sz="1100" dirty="0"/>
           </a:p>
@@ -6439,7 +6419,7 @@
                 <a:ea typeface="Arial" pitchFamily="34" charset="-122"/>
                 <a:cs typeface="Arial" pitchFamily="34" charset="-120"/>
               </a:rPr>
-              <a:t>SEARCH DYNAMICS</a:t>
+              <a:t>A HYPOTHESIS, TESTED AND REFUTED</a:t>
             </a:r>
             <a:endParaRPr lang="en-US" sz="1300" dirty="0"/>
           </a:p>
@@ -6454,7 +6434,7 @@
         <p:spPr>
           <a:xfrm>
             <a:off x="502920" y="548640"/>
-            <a:ext cx="11185855" cy="658368"/>
+            <a:ext cx="11185855" cy="822960"/>
           </a:xfrm>
           <a:prstGeom prst="rect">
             <a:avLst/>
@@ -6470,7 +6450,7 @@
               <a:buNone/>
             </a:pPr>
             <a:r>
-              <a:rPr lang="en-US" sz="3000" b="1" dirty="0">
+              <a:rPr lang="en-US" sz="2400" b="1" dirty="0">
                 <a:solidFill>
                   <a:srgbClr val="1E3A5F"/>
                 </a:solidFill>
@@ -6478,9 +6458,9 @@
                 <a:ea typeface="Arial" pitchFamily="34" charset="-122"/>
                 <a:cs typeface="Arial" pitchFamily="34" charset="-120"/>
               </a:rPr>
-              <a:t>More feedback did not translate into better circuits</a:t>
-            </a:r>
-            <a:endParaRPr lang="en-US" sz="3000" dirty="0"/>
+              <a:t>The LLM's "refinement skill" was the room a bad start leaves</a:t>
+            </a:r>
+            <a:endParaRPr lang="en-US" sz="2400" dirty="0"/>
           </a:p>
         </p:txBody>
       </p:sp>
@@ -6544,7 +6524,7 @@
                 <a:ea typeface="Arial" pitchFamily="34" charset="-122"/>
                 <a:cs typeface="Arial" pitchFamily="34" charset="-120"/>
               </a:rPr>
-              <a:t>PRIMARY: exactly 5 gates, B = 8, 10 seeds</a:t>
+              <a:t>16 gates, B = 8, 30 seeds</a:t>
             </a:r>
             <a:pPr algn="r" indent="0" marL="0">
               <a:buNone/>
@@ -6558,7 +6538,7 @@
                 <a:ea typeface="Arial" pitchFamily="34" charset="-122"/>
                 <a:cs typeface="Arial" pitchFamily="34" charset="-120"/>
               </a:rPr>
-              <a:t>   all four tasks, T1-T4</a:t>
+              <a:t>   median over all four tasks</a:t>
             </a:r>
             <a:endParaRPr lang="en-US" sz="1150" dirty="0"/>
           </a:p>
@@ -6566,7 +6546,7 @@
       </p:sp>
       <p:pic>
         <p:nvPicPr>
-          <p:cNvPr id="6" name="Image 0" descr="/Users/hatanakatomoya/Developer/Sim/llm-vqc/.claude/worktrees/github-author-config-faee6e/docs/presentation/mini5/figures/fig_anytime.png">    </p:cNvPr>
+          <p:cNvPr id="6" name="Image 0" descr="/Users/hatanakatomoya/Developer/Sim/llm-vqc/.claude/worktrees/github-author-config-faee6e/docs/presentation/mini5/figures/fig_v2_mechanism.png">    </p:cNvPr>
           <p:cNvPicPr>
             <a:picLocks noChangeAspect="1"/>
           </p:cNvPicPr>
@@ -6580,8 +6560,8 @@
         </p:blipFill>
         <p:spPr>
           <a:xfrm>
-            <a:off x="320040" y="1371600"/>
-            <a:ext cx="11521440" cy="3200400"/>
+            <a:off x="685800" y="1417320"/>
+            <a:ext cx="10789920" cy="3931920"/>
           </a:xfrm>
           <a:prstGeom prst="rect">
             <a:avLst/>
@@ -6596,20 +6576,20 @@
         </p:nvSpPr>
         <p:spPr>
           <a:xfrm>
-            <a:off x="548640" y="4709160"/>
-            <a:ext cx="11109960" cy="1280160"/>
+            <a:off x="548640" y="5486400"/>
+            <a:ext cx="11109960" cy="841248"/>
           </a:xfrm>
           <a:prstGeom prst="roundRect">
             <a:avLst>
-              <a:gd name="adj" fmla="val 7143"/>
+              <a:gd name="adj" fmla="val 8696"/>
             </a:avLst>
           </a:prstGeom>
           <a:solidFill>
-            <a:srgbClr val="F4F6FA"/>
+            <a:srgbClr val="FDF6E8"/>
           </a:solidFill>
-          <a:ln w="12700">
+          <a:ln w="13970">
             <a:solidFill>
-              <a:srgbClr val="D8DDE6"/>
+              <a:srgbClr val="B8860B"/>
             </a:solidFill>
             <a:prstDash val="solid"/>
           </a:ln>
@@ -6623,8 +6603,8 @@
         </p:nvSpPr>
         <p:spPr>
           <a:xfrm>
-            <a:off x="822960" y="4828032"/>
-            <a:ext cx="10607040" cy="1051560"/>
+            <a:off x="777240" y="5577840"/>
+            <a:ext cx="10607040" cy="685800"/>
           </a:xfrm>
           <a:prstGeom prst="rect">
             <a:avLst/>
@@ -6640,15 +6620,15 @@
               <a:buNone/>
             </a:pPr>
             <a:r>
-              <a:rPr lang="en-US" sz="1700" b="1" dirty="0">
-                <a:solidFill>
-                  <a:srgbClr val="B3261E"/>
-                </a:solidFill>
-                <a:latin typeface="Arial" pitchFamily="34" charset="0"/>
-                <a:ea typeface="Arial" pitchFamily="34" charset="-122"/>
-                <a:cs typeface="Arial" pitchFamily="34" charset="-120"/>
-              </a:rPr>
-              <a:t>Eight rounds of feedback, no gain on any task. </a:t>
+              <a:rPr lang="en-US" sz="1600" b="1" dirty="0">
+                <a:solidFill>
+                  <a:srgbClr val="1A1A2E"/>
+                </a:solidFill>
+                <a:latin typeface="Arial" pitchFamily="34" charset="0"/>
+                <a:ea typeface="Arial" pitchFamily="34" charset="-122"/>
+                <a:cs typeface="Arial" pitchFamily="34" charset="-120"/>
+              </a:rPr>
+              <a:t>I built the hybrid arm expecting it to win. </a:t>
             </a:r>
             <a:pPr indent="0" marL="0">
               <a:buNone/>
@@ -6662,9 +6642,9 @@
                 <a:ea typeface="Arial" pitchFamily="34" charset="-122"/>
                 <a:cs typeface="Arial" pitchFamily="34" charset="-120"/>
               </a:rPr>
-              <a:t>A first run had closed-loop repeating itself 74% of the time and starved of budget; the prompt now lists what it already tried, repeats fell to 16%, and these are the corrected numbers.</a:t>
-            </a:r>
-            <a:endParaRPr lang="en-US" sz="1700" dirty="0"/>
+              <a:t>It reached the best final score of any arm and still could not beat random - because the ability it was built to exploit was not there.</a:t>
+            </a:r>
+            <a:endParaRPr lang="en-US" sz="1600" dirty="0"/>
           </a:p>
         </p:txBody>
       </p:sp>
@@ -6701,7 +6681,7 @@
                 <a:ea typeface="Arial" pitchFamily="34" charset="-122"/>
                 <a:cs typeface="Arial" pitchFamily="34" charset="-120"/>
               </a:rPr>
-              <a:t>Curves are the median best-so-far validation RMSE over 10 seeds; the x-axis is unique candidates, not API calls</a:t>
+              <a:t>Hybrid = random draws candidates 1-2, the LLM proposes 3-8 having seen their validation scores</a:t>
             </a:r>
             <a:endParaRPr lang="en-US" sz="1100" dirty="0"/>
           </a:p>

</xml_diff>

<commit_message>
Fix the setup slides that still described the previous experiment
Slides 1, 6 and 9 were rewritten for the 30-seed run and slides 2 to 5
were not, so the deck stated one experiment and reported another. The
constraints table said 3 qubits for T1/T2 and 5 gates; the run used 5
qubits everywhere and 16 gates, chose angle ranges instead of numbers,
and used 30 seeds and six arms. Caught by a reader question, which is the
right way to catch it and a bad way to have shipped it.

The four tasks now get their own slide with real signals from the frozen
generators - three examples per panel, the question each one asks, and
the range of the answer - because "T3 change point" tells an audience
nothing. The pipeline diagram and constraints merge onto one slide to
hold the deck at ten. The arms figure gains the fixed ansatz and the
hybrid and loses greedy, matching the arms that actually ran.

Co-Authored-By: Claude Opus 5 <noreply@anthropic.com>
</commit_message>
<xml_diff>
--- a/docs/presentation/mini5/20260731_GSoC_mini5.pptx
+++ b/docs/presentation/mini5/20260731_GSoC_mini5.pptx
@@ -775,7 +775,7 @@
           <a:p>
             <a:r>
               <a:rPr lang="en-US" dirty="0"/>
-              <a:t>Everything is on this slide on purpose. Three or five qubits, seven gate types, exactly five gates, one angle per gate, no optimizer, no classical parameters. A reader can verify any proposed circuit against these seven rows.</a:t>
+              <a:t>Four synthetic tasks so I control difficulty and know the answer exactly. Each signal is 32 numbers, which is exactly what five qubits hold, so the whole signal goes in with no padding and no truncation.</a:t>
             </a:r>
             <a:endParaRPr lang="en-US" dirty="0"/>
           </a:p>
@@ -863,7 +863,7 @@
           <a:p>
             <a:r>
               <a:rPr lang="en-US" dirty="0"/>
-              <a:t>RMSE is the typical size of the error, lower is better. The split matters: validation drives the search, and the test set is touched once after the winner is chosen, so the reported number never influenced the choice.</a:t>
+              <a:t>One operation is one physical gate, so sixteen means sixteen. The angle rule matters: the method chooses a range and the harness draws inside it, because the model cannot sample a continuum. Validation picks the winner and the test split is read once afterwards.</a:t>
             </a:r>
             <a:endParaRPr lang="en-US" dirty="0"/>
           </a:p>
@@ -1950,7 +1950,7 @@
                 <a:ea typeface="Arial" pitchFamily="34" charset="-122"/>
                 <a:cs typeface="Arial" pitchFamily="34" charset="-120"/>
               </a:rPr>
-              <a:t>July 31, 2026  ·  commit a01d11a  ·  experiment/bench-v2-real-llm-cost-minimal</a:t>
+              <a:t>July 31, 2026  ·  commit 705cf52  ·  experiment/bench-v2-real-llm-cost-minimal</a:t>
             </a:r>
             <a:endParaRPr lang="en-US" sz="1200" dirty="0"/>
           </a:p>
@@ -2726,7 +2726,7 @@
                 <a:ea typeface="Arial" pitchFamily="34" charset="-122"/>
                 <a:cs typeface="Arial" pitchFamily="34" charset="-120"/>
               </a:rPr>
-              <a:t>So a proposer that always asks for the maximum length wins without designing anything. Fixing the length takes that move away.</a:t>
+              <a:t>A proposer that always asks for the maximum length wins without designing anything. Fixing the length removes that move; 16 gates then makes the circuit visible to the readout.</a:t>
             </a:r>
             <a:endParaRPr lang="en-US" sz="1800" dirty="0"/>
           </a:p>
@@ -2836,7 +2836,7 @@
                 <a:ea typeface="Arial" pitchFamily="34" charset="-122"/>
                 <a:cs typeface="Arial" pitchFamily="34" charset="-120"/>
               </a:rPr>
-              <a:t>SEARCH SPACE</a:t>
+              <a:t>THE FOUR TASKS</a:t>
             </a:r>
             <a:endParaRPr lang="en-US" sz="1300" dirty="0"/>
           </a:p>
@@ -2875,7 +2875,7 @@
                 <a:ea typeface="Arial" pitchFamily="34" charset="-122"/>
                 <a:cs typeface="Arial" pitchFamily="34" charset="-120"/>
               </a:rPr>
-              <a:t>Every rule, stated so you can check any circuit by eye</a:t>
+              <a:t>Four questions about a 32-number signal</a:t>
             </a:r>
             <a:endParaRPr lang="en-US" sz="3000" dirty="0"/>
           </a:p>
@@ -2941,7 +2941,7 @@
                 <a:ea typeface="Arial" pitchFamily="34" charset="-122"/>
                 <a:cs typeface="Arial" pitchFamily="34" charset="-120"/>
               </a:rPr>
-              <a:t>Applies to all three conditions</a:t>
+              <a:t>5 qubits on every task</a:t>
             </a:r>
             <a:pPr algn="r" indent="0" marL="0">
               <a:buNone/>
@@ -2955,15 +2955,607 @@
                 <a:ea typeface="Arial" pitchFamily="34" charset="-122"/>
                 <a:cs typeface="Arial" pitchFamily="34" charset="-120"/>
               </a:rPr>
-              <a:t>   only gate count and B differ between them</a:t>
+              <a:t>   one circuit design per task</a:t>
             </a:r>
             <a:endParaRPr lang="en-US" sz="1150" dirty="0"/>
           </a:p>
         </p:txBody>
       </p:sp>
+      <p:pic>
+        <p:nvPicPr>
+          <p:cNvPr id="6" name="Image 0" descr="/Users/hatanakatomoya/Developer/Sim/llm-vqc/.claude/worktrees/github-author-config-faee6e/docs/presentation/mini5/figures/fig_tasks_v2.png">    </p:cNvPr>
+          <p:cNvPicPr>
+            <a:picLocks noChangeAspect="1"/>
+          </p:cNvPicPr>
+          <p:nvPr/>
+        </p:nvPicPr>
+        <p:blipFill>
+          <a:blip r:embed="rId1"/>
+          <a:stretch>
+            <a:fillRect/>
+          </a:stretch>
+        </p:blipFill>
+        <p:spPr>
+          <a:xfrm>
+            <a:off x="320040" y="1417320"/>
+            <a:ext cx="11567160" cy="2542032"/>
+          </a:xfrm>
+          <a:prstGeom prst="rect">
+            <a:avLst/>
+          </a:prstGeom>
+        </p:spPr>
+      </p:pic>
+      <p:sp>
+        <p:nvSpPr>
+          <p:cNvPr id="7" name="Shape 4"/>
+          <p:cNvSpPr/>
+          <p:nvPr/>
+        </p:nvSpPr>
+        <p:spPr>
+          <a:xfrm>
+            <a:off x="548640" y="4206240"/>
+            <a:ext cx="3520440" cy="1600200"/>
+          </a:xfrm>
+          <a:prstGeom prst="roundRect">
+            <a:avLst>
+              <a:gd name="adj" fmla="val 5714"/>
+            </a:avLst>
+          </a:prstGeom>
+          <a:solidFill>
+            <a:srgbClr val="F4F6FA"/>
+          </a:solidFill>
+          <a:ln w="19050">
+            <a:solidFill>
+              <a:srgbClr val="1E3A5F"/>
+            </a:solidFill>
+            <a:prstDash val="solid"/>
+          </a:ln>
+        </p:spPr>
+      </p:sp>
+      <p:sp>
+        <p:nvSpPr>
+          <p:cNvPr id="8" name="Text 5"/>
+          <p:cNvSpPr/>
+          <p:nvPr/>
+        </p:nvSpPr>
+        <p:spPr>
+          <a:xfrm>
+            <a:off x="777240" y="4315968"/>
+            <a:ext cx="3063240" cy="320040"/>
+          </a:xfrm>
+          <a:prstGeom prst="rect">
+            <a:avLst/>
+          </a:prstGeom>
+          <a:noFill/>
+          <a:ln/>
+        </p:spPr>
+        <p:txBody>
+          <a:bodyPr wrap="square" lIns="0" tIns="0" rIns="0" bIns="0" rtlCol="0" anchor="ctr"/>
+          <a:lstStyle/>
+          <a:p>
+            <a:pPr indent="0" marL="0">
+              <a:buNone/>
+            </a:pPr>
+            <a:r>
+              <a:rPr lang="en-US" sz="1500" b="1" dirty="0">
+                <a:solidFill>
+                  <a:srgbClr val="1E3A5F"/>
+                </a:solidFill>
+                <a:latin typeface="Arial" pitchFamily="34" charset="0"/>
+                <a:ea typeface="Arial" pitchFamily="34" charset="-122"/>
+                <a:cs typeface="Arial" pitchFamily="34" charset="-120"/>
+              </a:rPr>
+              <a:t>All four are synthetic</a:t>
+            </a:r>
+            <a:endParaRPr lang="en-US" sz="1500" dirty="0"/>
+          </a:p>
+        </p:txBody>
+      </p:sp>
+      <p:sp>
+        <p:nvSpPr>
+          <p:cNvPr id="9" name="Text 6"/>
+          <p:cNvSpPr/>
+          <p:nvPr/>
+        </p:nvSpPr>
+        <p:spPr>
+          <a:xfrm>
+            <a:off x="777240" y="4681728"/>
+            <a:ext cx="3063240" cy="1005840"/>
+          </a:xfrm>
+          <a:prstGeom prst="rect">
+            <a:avLst/>
+          </a:prstGeom>
+          <a:noFill/>
+          <a:ln/>
+        </p:spPr>
+        <p:txBody>
+          <a:bodyPr wrap="square" lIns="0" tIns="0" rIns="0" bIns="0" rtlCol="0" anchor="t"/>
+          <a:lstStyle/>
+          <a:p>
+            <a:pPr indent="0" marL="0">
+              <a:buNone/>
+            </a:pPr>
+            <a:r>
+              <a:rPr lang="en-US" sz="1350" dirty="0">
+                <a:solidFill>
+                  <a:srgbClr val="1A1A2E"/>
+                </a:solidFill>
+                <a:latin typeface="Arial" pitchFamily="34" charset="0"/>
+                <a:ea typeface="Arial" pitchFamily="34" charset="-122"/>
+                <a:cs typeface="Arial" pitchFamily="34" charset="-120"/>
+              </a:rPr>
+              <a:t>so difficulty and leakage are controlled, and the answer is known exactly</a:t>
+            </a:r>
+            <a:endParaRPr lang="en-US" sz="1350" dirty="0"/>
+          </a:p>
+        </p:txBody>
+      </p:sp>
+      <p:sp>
+        <p:nvSpPr>
+          <p:cNvPr id="10" name="Shape 7"/>
+          <p:cNvSpPr/>
+          <p:nvPr/>
+        </p:nvSpPr>
+        <p:spPr>
+          <a:xfrm>
+            <a:off x="4315968" y="4206240"/>
+            <a:ext cx="3520440" cy="1600200"/>
+          </a:xfrm>
+          <a:prstGeom prst="roundRect">
+            <a:avLst>
+              <a:gd name="adj" fmla="val 5714"/>
+            </a:avLst>
+          </a:prstGeom>
+          <a:solidFill>
+            <a:srgbClr val="F4F6FA"/>
+          </a:solidFill>
+          <a:ln w="19050">
+            <a:solidFill>
+              <a:srgbClr val="0B7A4B"/>
+            </a:solidFill>
+            <a:prstDash val="solid"/>
+          </a:ln>
+        </p:spPr>
+      </p:sp>
+      <p:sp>
+        <p:nvSpPr>
+          <p:cNvPr id="11" name="Text 8"/>
+          <p:cNvSpPr/>
+          <p:nvPr/>
+        </p:nvSpPr>
+        <p:spPr>
+          <a:xfrm>
+            <a:off x="4544568" y="4315968"/>
+            <a:ext cx="3063240" cy="320040"/>
+          </a:xfrm>
+          <a:prstGeom prst="rect">
+            <a:avLst/>
+          </a:prstGeom>
+          <a:noFill/>
+          <a:ln/>
+        </p:spPr>
+        <p:txBody>
+          <a:bodyPr wrap="square" lIns="0" tIns="0" rIns="0" bIns="0" rtlCol="0" anchor="ctr"/>
+          <a:lstStyle/>
+          <a:p>
+            <a:pPr indent="0" marL="0">
+              <a:buNone/>
+            </a:pPr>
+            <a:r>
+              <a:rPr lang="en-US" sz="1500" b="1" dirty="0">
+                <a:solidFill>
+                  <a:srgbClr val="0B7A4B"/>
+                </a:solidFill>
+                <a:latin typeface="Arial" pitchFamily="34" charset="0"/>
+                <a:ea typeface="Arial" pitchFamily="34" charset="-122"/>
+                <a:cs typeface="Arial" pitchFamily="34" charset="-120"/>
+              </a:rPr>
+              <a:t>T1-T3 are regression</a:t>
+            </a:r>
+            <a:endParaRPr lang="en-US" sz="1500" dirty="0"/>
+          </a:p>
+        </p:txBody>
+      </p:sp>
+      <p:sp>
+        <p:nvSpPr>
+          <p:cNvPr id="12" name="Text 9"/>
+          <p:cNvSpPr/>
+          <p:nvPr/>
+        </p:nvSpPr>
+        <p:spPr>
+          <a:xfrm>
+            <a:off x="4544568" y="4681728"/>
+            <a:ext cx="3063240" cy="1005840"/>
+          </a:xfrm>
+          <a:prstGeom prst="rect">
+            <a:avLst/>
+          </a:prstGeom>
+          <a:noFill/>
+          <a:ln/>
+        </p:spPr>
+        <p:txBody>
+          <a:bodyPr wrap="square" lIns="0" tIns="0" rIns="0" bIns="0" rtlCol="0" anchor="t"/>
+          <a:lstStyle/>
+          <a:p>
+            <a:pPr indent="0" marL="0">
+              <a:buNone/>
+            </a:pPr>
+            <a:r>
+              <a:rPr lang="en-US" sz="1350" dirty="0">
+                <a:solidFill>
+                  <a:srgbClr val="1A1A2E"/>
+                </a:solidFill>
+                <a:latin typeface="Arial" pitchFamily="34" charset="0"/>
+                <a:ea typeface="Arial" pitchFamily="34" charset="-122"/>
+                <a:cs typeface="Arial" pitchFamily="34" charset="-120"/>
+              </a:rPr>
+              <a:t>the target is a position or a rate, so RMSE is the natural score</a:t>
+            </a:r>
+            <a:endParaRPr lang="en-US" sz="1350" dirty="0"/>
+          </a:p>
+        </p:txBody>
+      </p:sp>
+      <p:sp>
+        <p:nvSpPr>
+          <p:cNvPr id="13" name="Shape 10"/>
+          <p:cNvSpPr/>
+          <p:nvPr/>
+        </p:nvSpPr>
+        <p:spPr>
+          <a:xfrm>
+            <a:off x="8092440" y="4206240"/>
+            <a:ext cx="3547872" cy="1600200"/>
+          </a:xfrm>
+          <a:prstGeom prst="roundRect">
+            <a:avLst>
+              <a:gd name="adj" fmla="val 5714"/>
+            </a:avLst>
+          </a:prstGeom>
+          <a:solidFill>
+            <a:srgbClr val="F4F6FA"/>
+          </a:solidFill>
+          <a:ln w="19050">
+            <a:solidFill>
+              <a:srgbClr val="B3261E"/>
+            </a:solidFill>
+            <a:prstDash val="solid"/>
+          </a:ln>
+        </p:spPr>
+      </p:sp>
+      <p:sp>
+        <p:nvSpPr>
+          <p:cNvPr id="14" name="Text 11"/>
+          <p:cNvSpPr/>
+          <p:nvPr/>
+        </p:nvSpPr>
+        <p:spPr>
+          <a:xfrm>
+            <a:off x="8321040" y="4315968"/>
+            <a:ext cx="3090672" cy="320040"/>
+          </a:xfrm>
+          <a:prstGeom prst="rect">
+            <a:avLst/>
+          </a:prstGeom>
+          <a:noFill/>
+          <a:ln/>
+        </p:spPr>
+        <p:txBody>
+          <a:bodyPr wrap="square" lIns="0" tIns="0" rIns="0" bIns="0" rtlCol="0" anchor="ctr"/>
+          <a:lstStyle/>
+          <a:p>
+            <a:pPr indent="0" marL="0">
+              <a:buNone/>
+            </a:pPr>
+            <a:r>
+              <a:rPr lang="en-US" sz="1500" b="1" dirty="0">
+                <a:solidFill>
+                  <a:srgbClr val="B3261E"/>
+                </a:solidFill>
+                <a:latin typeface="Arial" pitchFamily="34" charset="0"/>
+                <a:ea typeface="Arial" pitchFamily="34" charset="-122"/>
+                <a:cs typeface="Arial" pitchFamily="34" charset="-120"/>
+              </a:rPr>
+              <a:t>T4 is a yes/no question</a:t>
+            </a:r>
+            <a:endParaRPr lang="en-US" sz="1500" dirty="0"/>
+          </a:p>
+        </p:txBody>
+      </p:sp>
+      <p:sp>
+        <p:nvSpPr>
+          <p:cNvPr id="15" name="Text 12"/>
+          <p:cNvSpPr/>
+          <p:nvPr/>
+        </p:nvSpPr>
+        <p:spPr>
+          <a:xfrm>
+            <a:off x="8321040" y="4681728"/>
+            <a:ext cx="3090672" cy="1005840"/>
+          </a:xfrm>
+          <a:prstGeom prst="rect">
+            <a:avLst/>
+          </a:prstGeom>
+          <a:noFill/>
+          <a:ln/>
+        </p:spPr>
+        <p:txBody>
+          <a:bodyPr wrap="square" lIns="0" tIns="0" rIns="0" bIns="0" rtlCol="0" anchor="t"/>
+          <a:lstStyle/>
+          <a:p>
+            <a:pPr indent="0" marL="0">
+              <a:buNone/>
+            </a:pPr>
+            <a:r>
+              <a:rPr lang="en-US" sz="1350" dirty="0">
+                <a:solidFill>
+                  <a:srgbClr val="1A1A2E"/>
+                </a:solidFill>
+                <a:latin typeface="Arial" pitchFamily="34" charset="0"/>
+                <a:ea typeface="Arial" pitchFamily="34" charset="-122"/>
+                <a:cs typeface="Arial" pitchFamily="34" charset="-120"/>
+              </a:rPr>
+              <a:t>RMSE there is the error against a 0/1 label; AUROC is recorded too</a:t>
+            </a:r>
+            <a:endParaRPr lang="en-US" sz="1350" dirty="0"/>
+          </a:p>
+        </p:txBody>
+      </p:sp>
+      <p:sp>
+        <p:nvSpPr>
+          <p:cNvPr id="16" name="Text 13"/>
+          <p:cNvSpPr/>
+          <p:nvPr/>
+        </p:nvSpPr>
+        <p:spPr>
+          <a:xfrm>
+            <a:off x="502920" y="6473952"/>
+            <a:ext cx="11185855" cy="274320"/>
+          </a:xfrm>
+          <a:prstGeom prst="rect">
+            <a:avLst/>
+          </a:prstGeom>
+          <a:noFill/>
+          <a:ln/>
+        </p:spPr>
+        <p:txBody>
+          <a:bodyPr wrap="square" lIns="0" tIns="0" rIns="0" bIns="0" rtlCol="0" anchor="ctr"/>
+          <a:lstStyle/>
+          <a:p>
+            <a:pPr indent="0" marL="0">
+              <a:buNone/>
+            </a:pPr>
+            <a:r>
+              <a:rPr lang="en-US" sz="1100" dirty="0">
+                <a:solidFill>
+                  <a:srgbClr val="55606E"/>
+                </a:solidFill>
+                <a:latin typeface="Arial" pitchFamily="34" charset="0"/>
+                <a:ea typeface="Arial" pitchFamily="34" charset="-122"/>
+                <a:cs typeface="Arial" pitchFamily="34" charset="-120"/>
+              </a:rPr>
+              <a:t>Generated by llm_vqc/tasks/signal_suite · 256 train / 256 validation / 2048 test, regenerated per seed</a:t>
+            </a:r>
+            <a:endParaRPr lang="en-US" sz="1100" dirty="0"/>
+          </a:p>
+        </p:txBody>
+      </p:sp>
+    </p:spTree>
+  </p:cSld>
+  <p:clrMapOvr>
+    <a:masterClrMapping/>
+  </p:clrMapOvr>
+</p:sld>
+</file>
+
+<file path=ppt/slides/slide4.xml><?xml version="1.0" encoding="utf-8"?>
+<p:sld xmlns:a="http://schemas.openxmlformats.org/drawingml/2006/main" xmlns:r="http://schemas.openxmlformats.org/officeDocument/2006/relationships" xmlns:p="http://schemas.openxmlformats.org/presentationml/2006/main">
+  <p:cSld name="Slide 4">
+    <p:bg>
+      <p:bgPr>
+        <a:solidFill>
+          <a:srgbClr val="FFFFFF"/>
+        </a:solidFill>
+      </p:bgPr>
+    </p:bg>
+    <p:spTree>
+      <p:nvGrpSpPr>
+        <p:cNvPr id="1" name=""/>
+        <p:cNvGrpSpPr/>
+        <p:nvPr/>
+      </p:nvGrpSpPr>
+      <p:grpSpPr>
+        <a:xfrm>
+          <a:off x="0" y="0"/>
+          <a:ext cx="0" cy="0"/>
+          <a:chOff x="0" y="0"/>
+          <a:chExt cx="0" cy="0"/>
+        </a:xfrm>
+      </p:grpSpPr>
+      <p:sp>
+        <p:nvSpPr>
+          <p:cNvPr id="2" name="Text 0"/>
+          <p:cNvSpPr/>
+          <p:nvPr/>
+        </p:nvSpPr>
+        <p:spPr>
+          <a:xfrm>
+            <a:off x="502920" y="274320"/>
+            <a:ext cx="11185855" cy="274320"/>
+          </a:xfrm>
+          <a:prstGeom prst="rect">
+            <a:avLst/>
+          </a:prstGeom>
+          <a:noFill/>
+          <a:ln/>
+        </p:spPr>
+        <p:txBody>
+          <a:bodyPr wrap="square" lIns="0" tIns="0" rIns="0" bIns="0" rtlCol="0" anchor="ctr"/>
+          <a:lstStyle/>
+          <a:p>
+            <a:pPr indent="0" marL="0">
+              <a:buNone/>
+            </a:pPr>
+            <a:r>
+              <a:rPr lang="en-US" sz="1300" b="1" spc="150" kern="0" dirty="0">
+                <a:solidFill>
+                  <a:srgbClr val="B3261E"/>
+                </a:solidFill>
+                <a:latin typeface="Arial" pitchFamily="34" charset="0"/>
+                <a:ea typeface="Arial" pitchFamily="34" charset="-122"/>
+                <a:cs typeface="Arial" pitchFamily="34" charset="-120"/>
+              </a:rPr>
+              <a:t>THE RULES</a:t>
+            </a:r>
+            <a:endParaRPr lang="en-US" sz="1300" dirty="0"/>
+          </a:p>
+        </p:txBody>
+      </p:sp>
+      <p:sp>
+        <p:nvSpPr>
+          <p:cNvPr id="3" name="Text 1"/>
+          <p:cNvSpPr/>
+          <p:nvPr/>
+        </p:nvSpPr>
+        <p:spPr>
+          <a:xfrm>
+            <a:off x="502920" y="548640"/>
+            <a:ext cx="11185855" cy="658368"/>
+          </a:xfrm>
+          <a:prstGeom prst="rect">
+            <a:avLst/>
+          </a:prstGeom>
+          <a:noFill/>
+          <a:ln/>
+        </p:spPr>
+        <p:txBody>
+          <a:bodyPr wrap="square" lIns="0" tIns="0" rIns="0" bIns="0" rtlCol="0" anchor="ctr"/>
+          <a:lstStyle/>
+          <a:p>
+            <a:pPr indent="0" marL="0">
+              <a:buNone/>
+            </a:pPr>
+            <a:r>
+              <a:rPr lang="en-US" sz="3000" b="1" dirty="0">
+                <a:solidFill>
+                  <a:srgbClr val="1E3A5F"/>
+                </a:solidFill>
+                <a:latin typeface="Arial" pitchFamily="34" charset="0"/>
+                <a:ea typeface="Arial" pitchFamily="34" charset="-122"/>
+                <a:cs typeface="Arial" pitchFamily="34" charset="-120"/>
+              </a:rPr>
+              <a:t>One pipeline, and every constraint on it</a:t>
+            </a:r>
+            <a:endParaRPr lang="en-US" sz="3000" dirty="0"/>
+          </a:p>
+        </p:txBody>
+      </p:sp>
+      <p:sp>
+        <p:nvSpPr>
+          <p:cNvPr id="4" name="Shape 2"/>
+          <p:cNvSpPr/>
+          <p:nvPr/>
+        </p:nvSpPr>
+        <p:spPr>
+          <a:xfrm>
+            <a:off x="5699455" y="256032"/>
+            <a:ext cx="5989320" cy="402336"/>
+          </a:xfrm>
+          <a:prstGeom prst="roundRect">
+            <a:avLst>
+              <a:gd name="adj" fmla="val 15909"/>
+            </a:avLst>
+          </a:prstGeom>
+          <a:solidFill>
+            <a:srgbClr val="F4F6FA"/>
+          </a:solidFill>
+          <a:ln w="12700">
+            <a:solidFill>
+              <a:srgbClr val="D8DDE6"/>
+            </a:solidFill>
+            <a:prstDash val="solid"/>
+          </a:ln>
+        </p:spPr>
+      </p:sp>
+      <p:sp>
+        <p:nvSpPr>
+          <p:cNvPr id="5" name="Text 3"/>
+          <p:cNvSpPr/>
+          <p:nvPr/>
+        </p:nvSpPr>
+        <p:spPr>
+          <a:xfrm>
+            <a:off x="5836615" y="274320"/>
+            <a:ext cx="5715000" cy="365760"/>
+          </a:xfrm>
+          <a:prstGeom prst="rect">
+            <a:avLst/>
+          </a:prstGeom>
+          <a:noFill/>
+          <a:ln/>
+        </p:spPr>
+        <p:txBody>
+          <a:bodyPr wrap="square" lIns="0" tIns="0" rIns="0" bIns="0" rtlCol="0" anchor="ctr"/>
+          <a:lstStyle/>
+          <a:p>
+            <a:pPr algn="r" indent="0" marL="0">
+              <a:buNone/>
+            </a:pPr>
+            <a:r>
+              <a:rPr lang="en-US" sz="1150" b="1" dirty="0">
+                <a:solidFill>
+                  <a:srgbClr val="1E3A5F"/>
+                </a:solidFill>
+                <a:latin typeface="Arial" pitchFamily="34" charset="0"/>
+                <a:ea typeface="Arial" pitchFamily="34" charset="-122"/>
+                <a:cs typeface="Arial" pitchFamily="34" charset="-120"/>
+              </a:rPr>
+              <a:t>The run reported on slides 6 and 9</a:t>
+            </a:r>
+            <a:pPr algn="r" indent="0" marL="0">
+              <a:buNone/>
+            </a:pPr>
+            <a:r>
+              <a:rPr lang="en-US" sz="1150" dirty="0">
+                <a:solidFill>
+                  <a:srgbClr val="55606E"/>
+                </a:solidFill>
+                <a:latin typeface="Arial" pitchFamily="34" charset="0"/>
+                <a:ea typeface="Arial" pitchFamily="34" charset="-122"/>
+                <a:cs typeface="Arial" pitchFamily="34" charset="-120"/>
+              </a:rPr>
+              <a:t>   16 gates, 5 qubits, B = 8, 30 seeds</a:t>
+            </a:r>
+            <a:endParaRPr lang="en-US" sz="1150" dirty="0"/>
+          </a:p>
+        </p:txBody>
+      </p:sp>
+      <p:pic>
+        <p:nvPicPr>
+          <p:cNvPr id="6" name="Image 0" descr="/Users/hatanakatomoya/Developer/Sim/llm-vqc/.claude/worktrees/github-author-config-faee6e/docs/presentation/mini5/figures/fig_contract.png">    </p:cNvPr>
+          <p:cNvPicPr>
+            <a:picLocks noChangeAspect="1"/>
+          </p:cNvPicPr>
+          <p:nvPr/>
+        </p:nvPicPr>
+        <p:blipFill>
+          <a:blip r:embed="rId1"/>
+          <a:stretch>
+            <a:fillRect/>
+          </a:stretch>
+        </p:blipFill>
+        <p:spPr>
+          <a:xfrm>
+            <a:off x="457200" y="1371600"/>
+            <a:ext cx="11292840" cy="2606040"/>
+          </a:xfrm>
+          <a:prstGeom prst="rect">
+            <a:avLst/>
+          </a:prstGeom>
+        </p:spPr>
+      </p:pic>
       <p:graphicFrame>
         <p:nvGraphicFramePr>
-          <p:cNvPr id="4" name="Table 0"/>
+          <p:cNvPr id="5" name="Table 0"/>
           <p:cNvGraphicFramePr>
             <a:graphicFrameLocks noGrp="1"/>
           </p:cNvGraphicFramePr>
@@ -2976,7 +3568,7 @@
           </p:nvPr>
         </p:nvGraphicFramePr>
         <p:xfrm>
-          <a:off x="548640" y="1417320"/>
+          <a:off x="548640" y="4114800"/>
           <a:ext cx="11109960" cy="914400"/>
         </p:xfrm>
         <a:graphic>
@@ -2984,10 +3576,10 @@
             <a:tbl>
               <a:tblPr/>
               <a:tblGrid>
-                <a:gridCol w="2377440"/>
-                <a:gridCol w="8732520"/>
+                <a:gridCol w="2194560"/>
+                <a:gridCol w="8915400"/>
               </a:tblGrid>
-              <a:tr h="457200">
+              <a:tr h="365760">
                 <a:tc>
                   <a:txBody>
                     <a:bodyPr/>
@@ -2997,7 +3589,7 @@
                         <a:buNone/>
                       </a:pPr>
                       <a:r>
-                        <a:rPr lang="en-US" sz="1500" b="1" dirty="0">
+                        <a:rPr lang="en-US" sz="1350" b="1" dirty="0">
                           <a:solidFill>
                             <a:srgbClr val="FFFFFF"/>
                           </a:solidFill>
@@ -3007,14 +3599,14 @@
                         </a:rPr>
                         <a:t>Constraint</a:t>
                       </a:r>
-                      <a:endParaRPr lang="en-US" sz="1500" dirty="0">
+                      <a:endParaRPr lang="en-US" sz="1350" dirty="0">
                         <a:latin typeface="Arial" charset="0"/>
                         <a:ea typeface="Arial" charset="0"/>
                         <a:cs typeface="Arial" charset="0"/>
                       </a:endParaRPr>
                     </a:p>
                   </a:txBody>
-                  <a:tcPr marL="73152" marR="73152" marT="73152" marB="73152" anchor="ctr">
+                  <a:tcPr marL="64008" marR="64008" marT="64008" marB="64008" anchor="ctr">
                     <a:lnL w="9525" cap="flat" cmpd="sng" algn="ctr">
                       <a:solidFill>
                         <a:srgbClr val="D8DDE6"/>
@@ -3065,7 +3657,7 @@
                         <a:buNone/>
                       </a:pPr>
                       <a:r>
-                        <a:rPr lang="en-US" sz="1500" b="1" dirty="0">
+                        <a:rPr lang="en-US" sz="1350" b="1" dirty="0">
                           <a:solidFill>
                             <a:srgbClr val="FFFFFF"/>
                           </a:solidFill>
@@ -3075,14 +3667,14 @@
                         </a:rPr>
                         <a:t>Value</a:t>
                       </a:r>
-                      <a:endParaRPr lang="en-US" sz="1500" dirty="0">
+                      <a:endParaRPr lang="en-US" sz="1350" dirty="0">
                         <a:latin typeface="Arial" charset="0"/>
                         <a:ea typeface="Arial" charset="0"/>
                         <a:cs typeface="Arial" charset="0"/>
                       </a:endParaRPr>
                     </a:p>
                   </a:txBody>
-                  <a:tcPr marL="73152" marR="73152" marT="73152" marB="73152" anchor="ctr">
+                  <a:tcPr marL="64008" marR="64008" marT="64008" marB="64008" anchor="ctr">
                     <a:lnL w="9525" cap="flat" cmpd="sng" algn="ctr">
                       <a:solidFill>
                         <a:srgbClr val="D8DDE6"/>
@@ -3125,7 +3717,7 @@
                   </a:tcPr>
                 </a:tc>
               </a:tr>
-              <a:tr h="457200">
+              <a:tr h="365760">
                 <a:tc>
                   <a:txBody>
                     <a:bodyPr/>
@@ -3135,7 +3727,7 @@
                         <a:buNone/>
                       </a:pPr>
                       <a:r>
-                        <a:rPr lang="en-US" sz="1500" dirty="0">
+                        <a:rPr lang="en-US" sz="1350" dirty="0">
                           <a:solidFill>
                             <a:srgbClr val="000000"/>
                           </a:solidFill>
@@ -3143,16 +3735,16 @@
                           <a:ea typeface="Arial" pitchFamily="34" charset="-122"/>
                           <a:cs typeface="Arial" pitchFamily="34" charset="-120"/>
                         </a:rPr>
-                        <a:t>Tasks</a:t>
+                        <a:t>Gate count</a:t>
                       </a:r>
-                      <a:endParaRPr lang="en-US" sz="1500" dirty="0">
+                      <a:endParaRPr lang="en-US" sz="1350" dirty="0">
                         <a:latin typeface="Arial" charset="0"/>
                         <a:ea typeface="Arial" charset="0"/>
                         <a:cs typeface="Arial" charset="0"/>
                       </a:endParaRPr>
                     </a:p>
                   </a:txBody>
-                  <a:tcPr marL="73152" marR="73152" marT="73152" marB="73152" anchor="ctr">
+                  <a:tcPr marL="64008" marR="64008" marT="64008" marB="64008" anchor="ctr">
                     <a:lnL w="9525" cap="flat" cmpd="sng" algn="ctr">
                       <a:solidFill>
                         <a:srgbClr val="D8DDE6"/>
@@ -3200,7 +3792,7 @@
                         <a:buNone/>
                       </a:pPr>
                       <a:r>
-                        <a:rPr lang="en-US" sz="1500" dirty="0">
+                        <a:rPr lang="en-US" sz="1350" dirty="0">
                           <a:solidFill>
                             <a:srgbClr val="000000"/>
                           </a:solidFill>
@@ -3208,16 +3800,16 @@
                           <a:ea typeface="Arial" pitchFamily="34" charset="-122"/>
                           <a:cs typeface="Arial" pitchFamily="34" charset="-120"/>
                         </a:rPr>
-                        <a:t>T1 peak position · T2 sinusoid frequency · T3 change-point location · T4 one peak vs two (binary)</a:t>
+                        <a:t>16 exactly - enough that the measured qubit can see the circuit (slide 7)</a:t>
                       </a:r>
-                      <a:endParaRPr lang="en-US" sz="1500" dirty="0">
+                      <a:endParaRPr lang="en-US" sz="1350" dirty="0">
                         <a:latin typeface="Arial" charset="0"/>
                         <a:ea typeface="Arial" charset="0"/>
                         <a:cs typeface="Arial" charset="0"/>
                       </a:endParaRPr>
                     </a:p>
                   </a:txBody>
-                  <a:tcPr marL="73152" marR="73152" marT="73152" marB="73152" anchor="ctr">
+                  <a:tcPr marL="64008" marR="64008" marT="64008" marB="64008" anchor="ctr">
                     <a:lnL w="9525" cap="flat" cmpd="sng" algn="ctr">
                       <a:solidFill>
                         <a:srgbClr val="D8DDE6"/>
@@ -3257,7 +3849,7 @@
                   </a:tcPr>
                 </a:tc>
               </a:tr>
-              <a:tr h="457200">
+              <a:tr h="365760">
                 <a:tc>
                   <a:txBody>
                     <a:bodyPr/>
@@ -3267,7 +3859,7 @@
                         <a:buNone/>
                       </a:pPr>
                       <a:r>
-                        <a:rPr lang="en-US" sz="1500" dirty="0">
+                        <a:rPr lang="en-US" sz="1350" dirty="0">
                           <a:solidFill>
                             <a:srgbClr val="000000"/>
                           </a:solidFill>
@@ -3275,16 +3867,16 @@
                           <a:ea typeface="Arial" pitchFamily="34" charset="-122"/>
                           <a:cs typeface="Arial" pitchFamily="34" charset="-120"/>
                         </a:rPr>
-                        <a:t>Qubits</a:t>
+                        <a:t>Gate set</a:t>
                       </a:r>
-                      <a:endParaRPr lang="en-US" sz="1500" dirty="0">
+                      <a:endParaRPr lang="en-US" sz="1350" dirty="0">
                         <a:latin typeface="Arial" charset="0"/>
                         <a:ea typeface="Arial" charset="0"/>
                         <a:cs typeface="Arial" charset="0"/>
                       </a:endParaRPr>
                     </a:p>
                   </a:txBody>
-                  <a:tcPr marL="73152" marR="73152" marT="73152" marB="73152" anchor="ctr">
+                  <a:tcPr marL="64008" marR="64008" marT="64008" marB="64008" anchor="ctr">
                     <a:lnL w="9525" cap="flat" cmpd="sng" algn="ctr">
                       <a:solidFill>
                         <a:srgbClr val="D8DDE6"/>
@@ -3332,7 +3924,7 @@
                         <a:buNone/>
                       </a:pPr>
                       <a:r>
-                        <a:rPr lang="en-US" sz="1500" dirty="0">
+                        <a:rPr lang="en-US" sz="1350" dirty="0">
                           <a:solidFill>
                             <a:srgbClr val="000000"/>
                           </a:solidFill>
@@ -3340,16 +3932,16 @@
                           <a:ea typeface="Arial" pitchFamily="34" charset="-122"/>
                           <a:cs typeface="Arial" pitchFamily="34" charset="-120"/>
                         </a:rPr>
-                        <a:t>3 for T1, T2   ·   5 for T3, T4   (a circuit on n qubits holds 2^n numbers)</a:t>
+                        <a:t>H, RX, RY, RZ (one qubit)   ·   CRX, CRY, CRZ (two qubits)</a:t>
                       </a:r>
-                      <a:endParaRPr lang="en-US" sz="1500" dirty="0">
+                      <a:endParaRPr lang="en-US" sz="1350" dirty="0">
                         <a:latin typeface="Arial" charset="0"/>
                         <a:ea typeface="Arial" charset="0"/>
                         <a:cs typeface="Arial" charset="0"/>
                       </a:endParaRPr>
                     </a:p>
                   </a:txBody>
-                  <a:tcPr marL="73152" marR="73152" marT="73152" marB="73152" anchor="ctr">
+                  <a:tcPr marL="64008" marR="64008" marT="64008" marB="64008" anchor="ctr">
                     <a:lnL w="9525" cap="flat" cmpd="sng" algn="ctr">
                       <a:solidFill>
                         <a:srgbClr val="D8DDE6"/>
@@ -3389,7 +3981,7 @@
                   </a:tcPr>
                 </a:tc>
               </a:tr>
-              <a:tr h="457200">
+              <a:tr h="365760">
                 <a:tc>
                   <a:txBody>
                     <a:bodyPr/>
@@ -3399,7 +3991,7 @@
                         <a:buNone/>
                       </a:pPr>
                       <a:r>
-                        <a:rPr lang="en-US" sz="1500" dirty="0">
+                        <a:rPr lang="en-US" sz="1350" dirty="0">
                           <a:solidFill>
                             <a:srgbClr val="000000"/>
                           </a:solidFill>
@@ -3407,16 +3999,16 @@
                           <a:ea typeface="Arial" pitchFamily="34" charset="-122"/>
                           <a:cs typeface="Arial" pitchFamily="34" charset="-120"/>
                         </a:rPr>
-                        <a:t>Gate count</a:t>
+                        <a:t>Angles</a:t>
                       </a:r>
-                      <a:endParaRPr lang="en-US" sz="1500" dirty="0">
+                      <a:endParaRPr lang="en-US" sz="1350" dirty="0">
                         <a:latin typeface="Arial" charset="0"/>
                         <a:ea typeface="Arial" charset="0"/>
                         <a:cs typeface="Arial" charset="0"/>
                       </a:endParaRPr>
                     </a:p>
                   </a:txBody>
-                  <a:tcPr marL="73152" marR="73152" marT="73152" marB="73152" anchor="ctr">
+                  <a:tcPr marL="64008" marR="64008" marT="64008" marB="64008" anchor="ctr">
                     <a:lnL w="9525" cap="flat" cmpd="sng" algn="ctr">
                       <a:solidFill>
                         <a:srgbClr val="D8DDE6"/>
@@ -3464,7 +4056,7 @@
                         <a:buNone/>
                       </a:pPr>
                       <a:r>
-                        <a:rPr lang="en-US" sz="1500" dirty="0">
+                        <a:rPr lang="en-US" sz="1350" dirty="0">
                           <a:solidFill>
                             <a:srgbClr val="000000"/>
                           </a:solidFill>
@@ -3472,16 +4064,16 @@
                           <a:ea typeface="Arial" pitchFamily="34" charset="-122"/>
                           <a:cs typeface="Arial" pitchFamily="34" charset="-120"/>
                         </a:rPr>
-                        <a:t>5 exactly (PRIMARY)   ·   1 to 5 (both controls)</a:t>
+                        <a:t>the method picks one of 8 RANGES over [-pi, pi]; the harness draws inside it</a:t>
                       </a:r>
-                      <a:endParaRPr lang="en-US" sz="1500" dirty="0">
+                      <a:endParaRPr lang="en-US" sz="1350" dirty="0">
                         <a:latin typeface="Arial" charset="0"/>
                         <a:ea typeface="Arial" charset="0"/>
                         <a:cs typeface="Arial" charset="0"/>
                       </a:endParaRPr>
                     </a:p>
                   </a:txBody>
-                  <a:tcPr marL="73152" marR="73152" marT="73152" marB="73152" anchor="ctr">
+                  <a:tcPr marL="64008" marR="64008" marT="64008" marB="64008" anchor="ctr">
                     <a:lnL w="9525" cap="flat" cmpd="sng" algn="ctr">
                       <a:solidFill>
                         <a:srgbClr val="D8DDE6"/>
@@ -3521,7 +4113,7 @@
                   </a:tcPr>
                 </a:tc>
               </a:tr>
-              <a:tr h="457200">
+              <a:tr h="365760">
                 <a:tc>
                   <a:txBody>
                     <a:bodyPr/>
@@ -3531,7 +4123,7 @@
                         <a:buNone/>
                       </a:pPr>
                       <a:r>
-                        <a:rPr lang="en-US" sz="1500" dirty="0">
+                        <a:rPr lang="en-US" sz="1350" dirty="0">
                           <a:solidFill>
                             <a:srgbClr val="000000"/>
                           </a:solidFill>
@@ -3539,16 +4131,16 @@
                           <a:ea typeface="Arial" pitchFamily="34" charset="-122"/>
                           <a:cs typeface="Arial" pitchFamily="34" charset="-120"/>
                         </a:rPr>
-                        <a:t>Gate set</a:t>
+                        <a:t>Budget B</a:t>
                       </a:r>
-                      <a:endParaRPr lang="en-US" sz="1500" dirty="0">
+                      <a:endParaRPr lang="en-US" sz="1350" dirty="0">
                         <a:latin typeface="Arial" charset="0"/>
                         <a:ea typeface="Arial" charset="0"/>
                         <a:cs typeface="Arial" charset="0"/>
                       </a:endParaRPr>
                     </a:p>
                   </a:txBody>
-                  <a:tcPr marL="73152" marR="73152" marT="73152" marB="73152" anchor="ctr">
+                  <a:tcPr marL="64008" marR="64008" marT="64008" marB="64008" anchor="ctr">
                     <a:lnL w="9525" cap="flat" cmpd="sng" algn="ctr">
                       <a:solidFill>
                         <a:srgbClr val="D8DDE6"/>
@@ -3596,7 +4188,7 @@
                         <a:buNone/>
                       </a:pPr>
                       <a:r>
-                        <a:rPr lang="en-US" sz="1500" dirty="0">
+                        <a:rPr lang="en-US" sz="1350" dirty="0">
                           <a:solidFill>
                             <a:srgbClr val="000000"/>
                           </a:solidFill>
@@ -3604,16 +4196,16 @@
                           <a:ea typeface="Arial" pitchFamily="34" charset="-122"/>
                           <a:cs typeface="Arial" pitchFamily="34" charset="-120"/>
                         </a:rPr>
-                        <a:t>H, RX, RY, RZ (one qubit)   ·   CRX, CRY, CRZ (two qubits)</a:t>
+                        <a:t>8 distinct circuits scored per method   ·   30 seeds</a:t>
                       </a:r>
-                      <a:endParaRPr lang="en-US" sz="1500" dirty="0">
+                      <a:endParaRPr lang="en-US" sz="1350" dirty="0">
                         <a:latin typeface="Arial" charset="0"/>
                         <a:ea typeface="Arial" charset="0"/>
                         <a:cs typeface="Arial" charset="0"/>
                       </a:endParaRPr>
                     </a:p>
                   </a:txBody>
-                  <a:tcPr marL="73152" marR="73152" marT="73152" marB="73152" anchor="ctr">
+                  <a:tcPr marL="64008" marR="64008" marT="64008" marB="64008" anchor="ctr">
                     <a:lnL w="9525" cap="flat" cmpd="sng" algn="ctr">
                       <a:solidFill>
                         <a:srgbClr val="D8DDE6"/>
@@ -3653,7 +4245,7 @@
                   </a:tcPr>
                 </a:tc>
               </a:tr>
-              <a:tr h="457200">
+              <a:tr h="365760">
                 <a:tc>
                   <a:txBody>
                     <a:bodyPr/>
@@ -3663,7 +4255,7 @@
                         <a:buNone/>
                       </a:pPr>
                       <a:r>
-                        <a:rPr lang="en-US" sz="1500" dirty="0">
+                        <a:rPr lang="en-US" sz="1350" dirty="0">
                           <a:solidFill>
                             <a:srgbClr val="000000"/>
                           </a:solidFill>
@@ -3671,16 +4263,16 @@
                           <a:ea typeface="Arial" pitchFamily="34" charset="-122"/>
                           <a:cs typeface="Arial" pitchFamily="34" charset="-120"/>
                         </a:rPr>
-                        <a:t>Angles</a:t>
+                        <a:t>Scoring</a:t>
                       </a:r>
-                      <a:endParaRPr lang="en-US" sz="1500" dirty="0">
+                      <a:endParaRPr lang="en-US" sz="1350" dirty="0">
                         <a:latin typeface="Arial" charset="0"/>
                         <a:ea typeface="Arial" charset="0"/>
                         <a:cs typeface="Arial" charset="0"/>
                       </a:endParaRPr>
                     </a:p>
                   </a:txBody>
-                  <a:tcPr marL="73152" marR="73152" marT="73152" marB="73152" anchor="ctr">
+                  <a:tcPr marL="64008" marR="64008" marT="64008" marB="64008" anchor="ctr">
                     <a:lnL w="9525" cap="flat" cmpd="sng" algn="ctr">
                       <a:solidFill>
                         <a:srgbClr val="D8DDE6"/>
@@ -3728,7 +4320,7 @@
                         <a:buNone/>
                       </a:pPr>
                       <a:r>
-                        <a:rPr lang="en-US" sz="1500" dirty="0">
+                        <a:rPr lang="en-US" sz="1350" dirty="0">
                           <a:solidFill>
                             <a:srgbClr val="000000"/>
                           </a:solidFill>
@@ -3736,544 +4328,16 @@
                           <a:ea typeface="Arial" pitchFamily="34" charset="-122"/>
                           <a:cs typeface="Arial" pitchFamily="34" charset="-120"/>
                         </a:rPr>
-                        <a:t>one number per gate, anywhere in [-pi, pi]   (H has none)</a:t>
+                        <a:t>validation RMSE picks the winner; test RMSE is read once, after that choice</a:t>
                       </a:r>
-                      <a:endParaRPr lang="en-US" sz="1500" dirty="0">
+                      <a:endParaRPr lang="en-US" sz="1350" dirty="0">
                         <a:latin typeface="Arial" charset="0"/>
                         <a:ea typeface="Arial" charset="0"/>
                         <a:cs typeface="Arial" charset="0"/>
                       </a:endParaRPr>
                     </a:p>
                   </a:txBody>
-                  <a:tcPr marL="73152" marR="73152" marT="73152" marB="73152" anchor="ctr">
-                    <a:lnL w="9525" cap="flat" cmpd="sng" algn="ctr">
-                      <a:solidFill>
-                        <a:srgbClr val="D8DDE6"/>
-                      </a:solidFill>
-                      <a:prstDash val="solid"/>
-                      <a:round/>
-                      <a:headEnd type="none" w="med" len="med"/>
-                      <a:tailEnd type="none" w="med" len="med"/>
-                    </a:lnL>
-                    <a:lnR w="9525" cap="flat" cmpd="sng" algn="ctr">
-                      <a:solidFill>
-                        <a:srgbClr val="D8DDE6"/>
-                      </a:solidFill>
-                      <a:prstDash val="solid"/>
-                      <a:round/>
-                      <a:headEnd type="none" w="med" len="med"/>
-                      <a:tailEnd type="none" w="med" len="med"/>
-                    </a:lnR>
-                    <a:lnT w="9525" cap="flat" cmpd="sng" algn="ctr">
-                      <a:solidFill>
-                        <a:srgbClr val="D8DDE6"/>
-                      </a:solidFill>
-                      <a:prstDash val="solid"/>
-                      <a:round/>
-                      <a:headEnd type="none" w="med" len="med"/>
-                      <a:tailEnd type="none" w="med" len="med"/>
-                    </a:lnT>
-                    <a:lnB w="9525" cap="flat" cmpd="sng" algn="ctr">
-                      <a:solidFill>
-                        <a:srgbClr val="D8DDE6"/>
-                      </a:solidFill>
-                      <a:prstDash val="solid"/>
-                      <a:round/>
-                      <a:headEnd type="none" w="med" len="med"/>
-                      <a:tailEnd type="none" w="med" len="med"/>
-                    </a:lnB>
-                  </a:tcPr>
-                </a:tc>
-              </a:tr>
-              <a:tr h="457200">
-                <a:tc>
-                  <a:txBody>
-                    <a:bodyPr/>
-                    <a:lstStyle/>
-                    <a:p>
-                      <a:pPr indent="0" marL="0">
-                        <a:buNone/>
-                      </a:pPr>
-                      <a:r>
-                        <a:rPr lang="en-US" sz="1500" dirty="0">
-                          <a:solidFill>
-                            <a:srgbClr val="000000"/>
-                          </a:solidFill>
-                          <a:latin typeface="Arial" pitchFamily="34" charset="0"/>
-                          <a:ea typeface="Arial" pitchFamily="34" charset="-122"/>
-                          <a:cs typeface="Arial" pitchFamily="34" charset="-120"/>
-                        </a:rPr>
-                        <a:t>Budget B</a:t>
-                      </a:r>
-                      <a:endParaRPr lang="en-US" sz="1500" dirty="0">
-                        <a:latin typeface="Arial" charset="0"/>
-                        <a:ea typeface="Arial" charset="0"/>
-                        <a:cs typeface="Arial" charset="0"/>
-                      </a:endParaRPr>
-                    </a:p>
-                  </a:txBody>
-                  <a:tcPr marL="73152" marR="73152" marT="73152" marB="73152" anchor="ctr">
-                    <a:lnL w="9525" cap="flat" cmpd="sng" algn="ctr">
-                      <a:solidFill>
-                        <a:srgbClr val="D8DDE6"/>
-                      </a:solidFill>
-                      <a:prstDash val="solid"/>
-                      <a:round/>
-                      <a:headEnd type="none" w="med" len="med"/>
-                      <a:tailEnd type="none" w="med" len="med"/>
-                    </a:lnL>
-                    <a:lnR w="9525" cap="flat" cmpd="sng" algn="ctr">
-                      <a:solidFill>
-                        <a:srgbClr val="D8DDE6"/>
-                      </a:solidFill>
-                      <a:prstDash val="solid"/>
-                      <a:round/>
-                      <a:headEnd type="none" w="med" len="med"/>
-                      <a:tailEnd type="none" w="med" len="med"/>
-                    </a:lnR>
-                    <a:lnT w="9525" cap="flat" cmpd="sng" algn="ctr">
-                      <a:solidFill>
-                        <a:srgbClr val="D8DDE6"/>
-                      </a:solidFill>
-                      <a:prstDash val="solid"/>
-                      <a:round/>
-                      <a:headEnd type="none" w="med" len="med"/>
-                      <a:tailEnd type="none" w="med" len="med"/>
-                    </a:lnT>
-                    <a:lnB w="9525" cap="flat" cmpd="sng" algn="ctr">
-                      <a:solidFill>
-                        <a:srgbClr val="D8DDE6"/>
-                      </a:solidFill>
-                      <a:prstDash val="solid"/>
-                      <a:round/>
-                      <a:headEnd type="none" w="med" len="med"/>
-                      <a:tailEnd type="none" w="med" len="med"/>
-                    </a:lnB>
-                  </a:tcPr>
-                </a:tc>
-                <a:tc>
-                  <a:txBody>
-                    <a:bodyPr/>
-                    <a:lstStyle/>
-                    <a:p>
-                      <a:pPr indent="0" marL="0">
-                        <a:buNone/>
-                      </a:pPr>
-                      <a:r>
-                        <a:rPr lang="en-US" sz="1500" dirty="0">
-                          <a:solidFill>
-                            <a:srgbClr val="000000"/>
-                          </a:solidFill>
-                          <a:latin typeface="Arial" pitchFamily="34" charset="0"/>
-                          <a:ea typeface="Arial" pitchFamily="34" charset="-122"/>
-                          <a:cs typeface="Arial" pitchFamily="34" charset="-120"/>
-                        </a:rPr>
-                        <a:t>8 distinct circuits scored per method (4 in Control B)   ·   10 seeds</a:t>
-                      </a:r>
-                      <a:endParaRPr lang="en-US" sz="1500" dirty="0">
-                        <a:latin typeface="Arial" charset="0"/>
-                        <a:ea typeface="Arial" charset="0"/>
-                        <a:cs typeface="Arial" charset="0"/>
-                      </a:endParaRPr>
-                    </a:p>
-                  </a:txBody>
-                  <a:tcPr marL="73152" marR="73152" marT="73152" marB="73152" anchor="ctr">
-                    <a:lnL w="9525" cap="flat" cmpd="sng" algn="ctr">
-                      <a:solidFill>
-                        <a:srgbClr val="D8DDE6"/>
-                      </a:solidFill>
-                      <a:prstDash val="solid"/>
-                      <a:round/>
-                      <a:headEnd type="none" w="med" len="med"/>
-                      <a:tailEnd type="none" w="med" len="med"/>
-                    </a:lnL>
-                    <a:lnR w="9525" cap="flat" cmpd="sng" algn="ctr">
-                      <a:solidFill>
-                        <a:srgbClr val="D8DDE6"/>
-                      </a:solidFill>
-                      <a:prstDash val="solid"/>
-                      <a:round/>
-                      <a:headEnd type="none" w="med" len="med"/>
-                      <a:tailEnd type="none" w="med" len="med"/>
-                    </a:lnR>
-                    <a:lnT w="9525" cap="flat" cmpd="sng" algn="ctr">
-                      <a:solidFill>
-                        <a:srgbClr val="D8DDE6"/>
-                      </a:solidFill>
-                      <a:prstDash val="solid"/>
-                      <a:round/>
-                      <a:headEnd type="none" w="med" len="med"/>
-                      <a:tailEnd type="none" w="med" len="med"/>
-                    </a:lnT>
-                    <a:lnB w="9525" cap="flat" cmpd="sng" algn="ctr">
-                      <a:solidFill>
-                        <a:srgbClr val="D8DDE6"/>
-                      </a:solidFill>
-                      <a:prstDash val="solid"/>
-                      <a:round/>
-                      <a:headEnd type="none" w="med" len="med"/>
-                      <a:tailEnd type="none" w="med" len="med"/>
-                    </a:lnB>
-                  </a:tcPr>
-                </a:tc>
-              </a:tr>
-              <a:tr h="457200">
-                <a:tc>
-                  <a:txBody>
-                    <a:bodyPr/>
-                    <a:lstStyle/>
-                    <a:p>
-                      <a:pPr indent="0" marL="0">
-                        <a:buNone/>
-                      </a:pPr>
-                      <a:r>
-                        <a:rPr lang="en-US" sz="1500" dirty="0">
-                          <a:solidFill>
-                            <a:srgbClr val="000000"/>
-                          </a:solidFill>
-                          <a:latin typeface="Arial" pitchFamily="34" charset="0"/>
-                          <a:ea typeface="Arial" pitchFamily="34" charset="-122"/>
-                          <a:cs typeface="Arial" pitchFamily="34" charset="-120"/>
-                        </a:rPr>
-                        <a:t>Training</a:t>
-                      </a:r>
-                      <a:endParaRPr lang="en-US" sz="1500" dirty="0">
-                        <a:latin typeface="Arial" charset="0"/>
-                        <a:ea typeface="Arial" charset="0"/>
-                        <a:cs typeface="Arial" charset="0"/>
-                      </a:endParaRPr>
-                    </a:p>
-                  </a:txBody>
-                  <a:tcPr marL="73152" marR="73152" marT="73152" marB="73152" anchor="ctr">
-                    <a:lnL w="9525" cap="flat" cmpd="sng" algn="ctr">
-                      <a:solidFill>
-                        <a:srgbClr val="D8DDE6"/>
-                      </a:solidFill>
-                      <a:prstDash val="solid"/>
-                      <a:round/>
-                      <a:headEnd type="none" w="med" len="med"/>
-                      <a:tailEnd type="none" w="med" len="med"/>
-                    </a:lnL>
-                    <a:lnR w="9525" cap="flat" cmpd="sng" algn="ctr">
-                      <a:solidFill>
-                        <a:srgbClr val="D8DDE6"/>
-                      </a:solidFill>
-                      <a:prstDash val="solid"/>
-                      <a:round/>
-                      <a:headEnd type="none" w="med" len="med"/>
-                      <a:tailEnd type="none" w="med" len="med"/>
-                    </a:lnR>
-                    <a:lnT w="9525" cap="flat" cmpd="sng" algn="ctr">
-                      <a:solidFill>
-                        <a:srgbClr val="D8DDE6"/>
-                      </a:solidFill>
-                      <a:prstDash val="solid"/>
-                      <a:round/>
-                      <a:headEnd type="none" w="med" len="med"/>
-                      <a:tailEnd type="none" w="med" len="med"/>
-                    </a:lnT>
-                    <a:lnB w="9525" cap="flat" cmpd="sng" algn="ctr">
-                      <a:solidFill>
-                        <a:srgbClr val="D8DDE6"/>
-                      </a:solidFill>
-                      <a:prstDash val="solid"/>
-                      <a:round/>
-                      <a:headEnd type="none" w="med" len="med"/>
-                      <a:tailEnd type="none" w="med" len="med"/>
-                    </a:lnB>
-                  </a:tcPr>
-                </a:tc>
-                <a:tc>
-                  <a:txBody>
-                    <a:bodyPr/>
-                    <a:lstStyle/>
-                    <a:p>
-                      <a:pPr indent="0" marL="0">
-                        <a:buNone/>
-                      </a:pPr>
-                      <a:r>
-                        <a:rPr lang="en-US" sz="1500" dirty="0">
-                          <a:solidFill>
-                            <a:srgbClr val="000000"/>
-                          </a:solidFill>
-                          <a:latin typeface="Arial" pitchFamily="34" charset="0"/>
-                          <a:ea typeface="Arial" pitchFamily="34" charset="-122"/>
-                          <a:cs typeface="Arial" pitchFamily="34" charset="-120"/>
-                        </a:rPr>
-                        <a:t>none - proposed angles are used exactly as written</a:t>
-                      </a:r>
-                      <a:endParaRPr lang="en-US" sz="1500" dirty="0">
-                        <a:latin typeface="Arial" charset="0"/>
-                        <a:ea typeface="Arial" charset="0"/>
-                        <a:cs typeface="Arial" charset="0"/>
-                      </a:endParaRPr>
-                    </a:p>
-                  </a:txBody>
-                  <a:tcPr marL="73152" marR="73152" marT="73152" marB="73152" anchor="ctr">
-                    <a:lnL w="9525" cap="flat" cmpd="sng" algn="ctr">
-                      <a:solidFill>
-                        <a:srgbClr val="D8DDE6"/>
-                      </a:solidFill>
-                      <a:prstDash val="solid"/>
-                      <a:round/>
-                      <a:headEnd type="none" w="med" len="med"/>
-                      <a:tailEnd type="none" w="med" len="med"/>
-                    </a:lnL>
-                    <a:lnR w="9525" cap="flat" cmpd="sng" algn="ctr">
-                      <a:solidFill>
-                        <a:srgbClr val="D8DDE6"/>
-                      </a:solidFill>
-                      <a:prstDash val="solid"/>
-                      <a:round/>
-                      <a:headEnd type="none" w="med" len="med"/>
-                      <a:tailEnd type="none" w="med" len="med"/>
-                    </a:lnR>
-                    <a:lnT w="9525" cap="flat" cmpd="sng" algn="ctr">
-                      <a:solidFill>
-                        <a:srgbClr val="D8DDE6"/>
-                      </a:solidFill>
-                      <a:prstDash val="solid"/>
-                      <a:round/>
-                      <a:headEnd type="none" w="med" len="med"/>
-                      <a:tailEnd type="none" w="med" len="med"/>
-                    </a:lnT>
-                    <a:lnB w="9525" cap="flat" cmpd="sng" algn="ctr">
-                      <a:solidFill>
-                        <a:srgbClr val="D8DDE6"/>
-                      </a:solidFill>
-                      <a:prstDash val="solid"/>
-                      <a:round/>
-                      <a:headEnd type="none" w="med" len="med"/>
-                      <a:tailEnd type="none" w="med" len="med"/>
-                    </a:lnB>
-                  </a:tcPr>
-                </a:tc>
-              </a:tr>
-              <a:tr h="457200">
-                <a:tc>
-                  <a:txBody>
-                    <a:bodyPr/>
-                    <a:lstStyle/>
-                    <a:p>
-                      <a:pPr indent="0" marL="0">
-                        <a:buNone/>
-                      </a:pPr>
-                      <a:r>
-                        <a:rPr lang="en-US" sz="1500" dirty="0">
-                          <a:solidFill>
-                            <a:srgbClr val="000000"/>
-                          </a:solidFill>
-                          <a:latin typeface="Arial" pitchFamily="34" charset="0"/>
-                          <a:ea typeface="Arial" pitchFamily="34" charset="-122"/>
-                          <a:cs typeface="Arial" pitchFamily="34" charset="-120"/>
-                        </a:rPr>
-                        <a:t>Encoding / readout</a:t>
-                      </a:r>
-                      <a:endParaRPr lang="en-US" sz="1500" dirty="0">
-                        <a:latin typeface="Arial" charset="0"/>
-                        <a:ea typeface="Arial" charset="0"/>
-                        <a:cs typeface="Arial" charset="0"/>
-                      </a:endParaRPr>
-                    </a:p>
-                  </a:txBody>
-                  <a:tcPr marL="73152" marR="73152" marT="73152" marB="73152" anchor="ctr">
-                    <a:lnL w="9525" cap="flat" cmpd="sng" algn="ctr">
-                      <a:solidFill>
-                        <a:srgbClr val="D8DDE6"/>
-                      </a:solidFill>
-                      <a:prstDash val="solid"/>
-                      <a:round/>
-                      <a:headEnd type="none" w="med" len="med"/>
-                      <a:tailEnd type="none" w="med" len="med"/>
-                    </a:lnL>
-                    <a:lnR w="9525" cap="flat" cmpd="sng" algn="ctr">
-                      <a:solidFill>
-                        <a:srgbClr val="D8DDE6"/>
-                      </a:solidFill>
-                      <a:prstDash val="solid"/>
-                      <a:round/>
-                      <a:headEnd type="none" w="med" len="med"/>
-                      <a:tailEnd type="none" w="med" len="med"/>
-                    </a:lnR>
-                    <a:lnT w="9525" cap="flat" cmpd="sng" algn="ctr">
-                      <a:solidFill>
-                        <a:srgbClr val="D8DDE6"/>
-                      </a:solidFill>
-                      <a:prstDash val="solid"/>
-                      <a:round/>
-                      <a:headEnd type="none" w="med" len="med"/>
-                      <a:tailEnd type="none" w="med" len="med"/>
-                    </a:lnT>
-                    <a:lnB w="9525" cap="flat" cmpd="sng" algn="ctr">
-                      <a:solidFill>
-                        <a:srgbClr val="D8DDE6"/>
-                      </a:solidFill>
-                      <a:prstDash val="solid"/>
-                      <a:round/>
-                      <a:headEnd type="none" w="med" len="med"/>
-                      <a:tailEnd type="none" w="med" len="med"/>
-                    </a:lnB>
-                  </a:tcPr>
-                </a:tc>
-                <a:tc>
-                  <a:txBody>
-                    <a:bodyPr/>
-                    <a:lstStyle/>
-                    <a:p>
-                      <a:pPr indent="0" marL="0">
-                        <a:buNone/>
-                      </a:pPr>
-                      <a:r>
-                        <a:rPr lang="en-US" sz="1500" dirty="0">
-                          <a:solidFill>
-                            <a:srgbClr val="000000"/>
-                          </a:solidFill>
-                          <a:latin typeface="Arial" pitchFamily="34" charset="0"/>
-                          <a:ea typeface="Arial" pitchFamily="34" charset="-122"/>
-                          <a:cs typeface="Arial" pitchFamily="34" charset="-120"/>
-                        </a:rPr>
-                        <a:t>amplitude encoding; measure Z on qubit 0</a:t>
-                      </a:r>
-                      <a:endParaRPr lang="en-US" sz="1500" dirty="0">
-                        <a:latin typeface="Arial" charset="0"/>
-                        <a:ea typeface="Arial" charset="0"/>
-                        <a:cs typeface="Arial" charset="0"/>
-                      </a:endParaRPr>
-                    </a:p>
-                  </a:txBody>
-                  <a:tcPr marL="73152" marR="73152" marT="73152" marB="73152" anchor="ctr">
-                    <a:lnL w="9525" cap="flat" cmpd="sng" algn="ctr">
-                      <a:solidFill>
-                        <a:srgbClr val="D8DDE6"/>
-                      </a:solidFill>
-                      <a:prstDash val="solid"/>
-                      <a:round/>
-                      <a:headEnd type="none" w="med" len="med"/>
-                      <a:tailEnd type="none" w="med" len="med"/>
-                    </a:lnL>
-                    <a:lnR w="9525" cap="flat" cmpd="sng" algn="ctr">
-                      <a:solidFill>
-                        <a:srgbClr val="D8DDE6"/>
-                      </a:solidFill>
-                      <a:prstDash val="solid"/>
-                      <a:round/>
-                      <a:headEnd type="none" w="med" len="med"/>
-                      <a:tailEnd type="none" w="med" len="med"/>
-                    </a:lnR>
-                    <a:lnT w="9525" cap="flat" cmpd="sng" algn="ctr">
-                      <a:solidFill>
-                        <a:srgbClr val="D8DDE6"/>
-                      </a:solidFill>
-                      <a:prstDash val="solid"/>
-                      <a:round/>
-                      <a:headEnd type="none" w="med" len="med"/>
-                      <a:tailEnd type="none" w="med" len="med"/>
-                    </a:lnT>
-                    <a:lnB w="9525" cap="flat" cmpd="sng" algn="ctr">
-                      <a:solidFill>
-                        <a:srgbClr val="D8DDE6"/>
-                      </a:solidFill>
-                      <a:prstDash val="solid"/>
-                      <a:round/>
-                      <a:headEnd type="none" w="med" len="med"/>
-                      <a:tailEnd type="none" w="med" len="med"/>
-                    </a:lnB>
-                  </a:tcPr>
-                </a:tc>
-              </a:tr>
-              <a:tr h="457200">
-                <a:tc>
-                  <a:txBody>
-                    <a:bodyPr/>
-                    <a:lstStyle/>
-                    <a:p>
-                      <a:pPr indent="0" marL="0">
-                        <a:buNone/>
-                      </a:pPr>
-                      <a:r>
-                        <a:rPr lang="en-US" sz="1500" dirty="0">
-                          <a:solidFill>
-                            <a:srgbClr val="000000"/>
-                          </a:solidFill>
-                          <a:latin typeface="Arial" pitchFamily="34" charset="0"/>
-                          <a:ea typeface="Arial" pitchFamily="34" charset="-122"/>
-                          <a:cs typeface="Arial" pitchFamily="34" charset="-120"/>
-                        </a:rPr>
-                        <a:t>Classical params</a:t>
-                      </a:r>
-                      <a:endParaRPr lang="en-US" sz="1500" dirty="0">
-                        <a:latin typeface="Arial" charset="0"/>
-                        <a:ea typeface="Arial" charset="0"/>
-                        <a:cs typeface="Arial" charset="0"/>
-                      </a:endParaRPr>
-                    </a:p>
-                  </a:txBody>
-                  <a:tcPr marL="73152" marR="73152" marT="73152" marB="73152" anchor="ctr">
-                    <a:lnL w="9525" cap="flat" cmpd="sng" algn="ctr">
-                      <a:solidFill>
-                        <a:srgbClr val="D8DDE6"/>
-                      </a:solidFill>
-                      <a:prstDash val="solid"/>
-                      <a:round/>
-                      <a:headEnd type="none" w="med" len="med"/>
-                      <a:tailEnd type="none" w="med" len="med"/>
-                    </a:lnL>
-                    <a:lnR w="9525" cap="flat" cmpd="sng" algn="ctr">
-                      <a:solidFill>
-                        <a:srgbClr val="D8DDE6"/>
-                      </a:solidFill>
-                      <a:prstDash val="solid"/>
-                      <a:round/>
-                      <a:headEnd type="none" w="med" len="med"/>
-                      <a:tailEnd type="none" w="med" len="med"/>
-                    </a:lnR>
-                    <a:lnT w="9525" cap="flat" cmpd="sng" algn="ctr">
-                      <a:solidFill>
-                        <a:srgbClr val="D8DDE6"/>
-                      </a:solidFill>
-                      <a:prstDash val="solid"/>
-                      <a:round/>
-                      <a:headEnd type="none" w="med" len="med"/>
-                      <a:tailEnd type="none" w="med" len="med"/>
-                    </a:lnT>
-                    <a:lnB w="9525" cap="flat" cmpd="sng" algn="ctr">
-                      <a:solidFill>
-                        <a:srgbClr val="D8DDE6"/>
-                      </a:solidFill>
-                      <a:prstDash val="solid"/>
-                      <a:round/>
-                      <a:headEnd type="none" w="med" len="med"/>
-                      <a:tailEnd type="none" w="med" len="med"/>
-                    </a:lnB>
-                  </a:tcPr>
-                </a:tc>
-                <a:tc>
-                  <a:txBody>
-                    <a:bodyPr/>
-                    <a:lstStyle/>
-                    <a:p>
-                      <a:pPr indent="0" marL="0">
-                        <a:buNone/>
-                      </a:pPr>
-                      <a:r>
-                        <a:rPr lang="en-US" sz="1500" dirty="0">
-                          <a:solidFill>
-                            <a:srgbClr val="000000"/>
-                          </a:solidFill>
-                          <a:latin typeface="Arial" pitchFamily="34" charset="0"/>
-                          <a:ea typeface="Arial" pitchFamily="34" charset="-122"/>
-                          <a:cs typeface="Arial" pitchFamily="34" charset="-120"/>
-                        </a:rPr>
-                        <a:t>zero - nothing outside the circuit can fix a bad circuit</a:t>
-                      </a:r>
-                      <a:endParaRPr lang="en-US" sz="1500" dirty="0">
-                        <a:latin typeface="Arial" charset="0"/>
-                        <a:ea typeface="Arial" charset="0"/>
-                        <a:cs typeface="Arial" charset="0"/>
-                      </a:endParaRPr>
-                    </a:p>
-                  </a:txBody>
-                  <a:tcPr marL="73152" marR="73152" marT="73152" marB="73152" anchor="ctr">
+                  <a:tcPr marL="64008" marR="64008" marT="64008" marB="64008" anchor="ctr">
                     <a:lnL w="9525" cap="flat" cmpd="sng" algn="ctr">
                       <a:solidFill>
                         <a:srgbClr val="D8DDE6"/>
@@ -4319,7 +4383,7 @@
       </p:graphicFrame>
       <p:sp>
         <p:nvSpPr>
-          <p:cNvPr id="7" name="Text 4"/>
+          <p:cNvPr id="8" name="Text 4"/>
           <p:cNvSpPr/>
           <p:nvPr/>
         </p:nvSpPr>
@@ -4350,575 +4414,7 @@
                 <a:ea typeface="Arial" pitchFamily="34" charset="-122"/>
                 <a:cs typeface="Arial" pitchFamily="34" charset="-120"/>
               </a:rPr>
-              <a:t>One operation = one physical gate; a 5-gate circuit compiles to 5 gates. The same grammar check is applied to classical samplers and LLM replies alike</a:t>
-            </a:r>
-            <a:endParaRPr lang="en-US" sz="1100" dirty="0"/>
-          </a:p>
-        </p:txBody>
-      </p:sp>
-    </p:spTree>
-  </p:cSld>
-  <p:clrMapOvr>
-    <a:masterClrMapping/>
-  </p:clrMapOvr>
-</p:sld>
-</file>
-
-<file path=ppt/slides/slide4.xml><?xml version="1.0" encoding="utf-8"?>
-<p:sld xmlns:a="http://schemas.openxmlformats.org/drawingml/2006/main" xmlns:r="http://schemas.openxmlformats.org/officeDocument/2006/relationships" xmlns:p="http://schemas.openxmlformats.org/presentationml/2006/main">
-  <p:cSld name="Slide 4">
-    <p:bg>
-      <p:bgPr>
-        <a:solidFill>
-          <a:srgbClr val="FFFFFF"/>
-        </a:solidFill>
-      </p:bgPr>
-    </p:bg>
-    <p:spTree>
-      <p:nvGrpSpPr>
-        <p:cNvPr id="1" name=""/>
-        <p:cNvGrpSpPr/>
-        <p:nvPr/>
-      </p:nvGrpSpPr>
-      <p:grpSpPr>
-        <a:xfrm>
-          <a:off x="0" y="0"/>
-          <a:ext cx="0" cy="0"/>
-          <a:chOff x="0" y="0"/>
-          <a:chExt cx="0" cy="0"/>
-        </a:xfrm>
-      </p:grpSpPr>
-      <p:sp>
-        <p:nvSpPr>
-          <p:cNvPr id="2" name="Text 0"/>
-          <p:cNvSpPr/>
-          <p:nvPr/>
-        </p:nvSpPr>
-        <p:spPr>
-          <a:xfrm>
-            <a:off x="502920" y="274320"/>
-            <a:ext cx="11185855" cy="274320"/>
-          </a:xfrm>
-          <a:prstGeom prst="rect">
-            <a:avLst/>
-          </a:prstGeom>
-          <a:noFill/>
-          <a:ln/>
-        </p:spPr>
-        <p:txBody>
-          <a:bodyPr wrap="square" lIns="0" tIns="0" rIns="0" bIns="0" rtlCol="0" anchor="ctr"/>
-          <a:lstStyle/>
-          <a:p>
-            <a:pPr indent="0" marL="0">
-              <a:buNone/>
-            </a:pPr>
-            <a:r>
-              <a:rPr lang="en-US" sz="1300" b="1" spc="150" kern="0" dirty="0">
-                <a:solidFill>
-                  <a:srgbClr val="B3261E"/>
-                </a:solidFill>
-                <a:latin typeface="Arial" pitchFamily="34" charset="0"/>
-                <a:ea typeface="Arial" pitchFamily="34" charset="-122"/>
-                <a:cs typeface="Arial" pitchFamily="34" charset="-120"/>
-              </a:rPr>
-              <a:t>WHAT IS MEASURED</a:t>
-            </a:r>
-            <a:endParaRPr lang="en-US" sz="1300" dirty="0"/>
-          </a:p>
-        </p:txBody>
-      </p:sp>
-      <p:sp>
-        <p:nvSpPr>
-          <p:cNvPr id="3" name="Text 1"/>
-          <p:cNvSpPr/>
-          <p:nvPr/>
-        </p:nvSpPr>
-        <p:spPr>
-          <a:xfrm>
-            <a:off x="502920" y="548640"/>
-            <a:ext cx="11185855" cy="658368"/>
-          </a:xfrm>
-          <a:prstGeom prst="rect">
-            <a:avLst/>
-          </a:prstGeom>
-          <a:noFill/>
-          <a:ln/>
-        </p:spPr>
-        <p:txBody>
-          <a:bodyPr wrap="square" lIns="0" tIns="0" rIns="0" bIns="0" rtlCol="0" anchor="ctr"/>
-          <a:lstStyle/>
-          <a:p>
-            <a:pPr indent="0" marL="0">
-              <a:buNone/>
-            </a:pPr>
-            <a:r>
-              <a:rPr lang="en-US" sz="3000" b="1" dirty="0">
-                <a:solidFill>
-                  <a:srgbClr val="1E3A5F"/>
-                </a:solidFill>
-                <a:latin typeface="Arial" pitchFamily="34" charset="0"/>
-                <a:ea typeface="Arial" pitchFamily="34" charset="-122"/>
-                <a:cs typeface="Arial" pitchFamily="34" charset="-120"/>
-              </a:rPr>
-              <a:t>One number: RMSE, the typical size of the error</a:t>
-            </a:r>
-            <a:endParaRPr lang="en-US" sz="3000" dirty="0"/>
-          </a:p>
-        </p:txBody>
-      </p:sp>
-      <p:sp>
-        <p:nvSpPr>
-          <p:cNvPr id="4" name="Shape 2"/>
-          <p:cNvSpPr/>
-          <p:nvPr/>
-        </p:nvSpPr>
-        <p:spPr>
-          <a:xfrm>
-            <a:off x="5699455" y="256032"/>
-            <a:ext cx="5989320" cy="402336"/>
-          </a:xfrm>
-          <a:prstGeom prst="roundRect">
-            <a:avLst>
-              <a:gd name="adj" fmla="val 15909"/>
-            </a:avLst>
-          </a:prstGeom>
-          <a:solidFill>
-            <a:srgbClr val="F4F6FA"/>
-          </a:solidFill>
-          <a:ln w="12700">
-            <a:solidFill>
-              <a:srgbClr val="D8DDE6"/>
-            </a:solidFill>
-            <a:prstDash val="solid"/>
-          </a:ln>
-        </p:spPr>
-      </p:sp>
-      <p:sp>
-        <p:nvSpPr>
-          <p:cNvPr id="5" name="Text 3"/>
-          <p:cNvSpPr/>
-          <p:nvPr/>
-        </p:nvSpPr>
-        <p:spPr>
-          <a:xfrm>
-            <a:off x="5836615" y="274320"/>
-            <a:ext cx="5715000" cy="365760"/>
-          </a:xfrm>
-          <a:prstGeom prst="rect">
-            <a:avLst/>
-          </a:prstGeom>
-          <a:noFill/>
-          <a:ln/>
-        </p:spPr>
-        <p:txBody>
-          <a:bodyPr wrap="square" lIns="0" tIns="0" rIns="0" bIns="0" rtlCol="0" anchor="ctr"/>
-          <a:lstStyle/>
-          <a:p>
-            <a:pPr algn="r" indent="0" marL="0">
-              <a:buNone/>
-            </a:pPr>
-            <a:r>
-              <a:rPr lang="en-US" sz="1150" b="1" dirty="0">
-                <a:solidFill>
-                  <a:srgbClr val="1E3A5F"/>
-                </a:solidFill>
-                <a:latin typeface="Arial" pitchFamily="34" charset="0"/>
-                <a:ea typeface="Arial" pitchFamily="34" charset="-122"/>
-                <a:cs typeface="Arial" pitchFamily="34" charset="-120"/>
-              </a:rPr>
-              <a:t>Applies to all three conditions</a:t>
-            </a:r>
-            <a:pPr algn="r" indent="0" marL="0">
-              <a:buNone/>
-            </a:pPr>
-            <a:r>
-              <a:rPr lang="en-US" sz="1150" dirty="0">
-                <a:solidFill>
-                  <a:srgbClr val="55606E"/>
-                </a:solidFill>
-                <a:latin typeface="Arial" pitchFamily="34" charset="0"/>
-                <a:ea typeface="Arial" pitchFamily="34" charset="-122"/>
-                <a:cs typeface="Arial" pitchFamily="34" charset="-120"/>
-              </a:rPr>
-              <a:t>   same pipeline throughout</a:t>
-            </a:r>
-            <a:endParaRPr lang="en-US" sz="1150" dirty="0"/>
-          </a:p>
-        </p:txBody>
-      </p:sp>
-      <p:pic>
-        <p:nvPicPr>
-          <p:cNvPr id="6" name="Image 0" descr="/Users/hatanakatomoya/Developer/Sim/llm-vqc/.claude/worktrees/github-author-config-faee6e/docs/presentation/mini5/figures/fig_contract.png">    </p:cNvPr>
-          <p:cNvPicPr>
-            <a:picLocks noChangeAspect="1"/>
-          </p:cNvPicPr>
-          <p:nvPr/>
-        </p:nvPicPr>
-        <p:blipFill>
-          <a:blip r:embed="rId1"/>
-          <a:stretch>
-            <a:fillRect/>
-          </a:stretch>
-        </p:blipFill>
-        <p:spPr>
-          <a:xfrm>
-            <a:off x="411480" y="1371600"/>
-            <a:ext cx="11384280" cy="2624328"/>
-          </a:xfrm>
-          <a:prstGeom prst="rect">
-            <a:avLst/>
-          </a:prstGeom>
-        </p:spPr>
-      </p:pic>
-      <p:sp>
-        <p:nvSpPr>
-          <p:cNvPr id="7" name="Shape 4"/>
-          <p:cNvSpPr/>
-          <p:nvPr/>
-        </p:nvSpPr>
-        <p:spPr>
-          <a:xfrm>
-            <a:off x="548640" y="4206240"/>
-            <a:ext cx="3520440" cy="1600200"/>
-          </a:xfrm>
-          <a:prstGeom prst="roundRect">
-            <a:avLst>
-              <a:gd name="adj" fmla="val 5714"/>
-            </a:avLst>
-          </a:prstGeom>
-          <a:solidFill>
-            <a:srgbClr val="F4F6FA"/>
-          </a:solidFill>
-          <a:ln w="19050">
-            <a:solidFill>
-              <a:srgbClr val="1E3A5F"/>
-            </a:solidFill>
-            <a:prstDash val="solid"/>
-          </a:ln>
-        </p:spPr>
-      </p:sp>
-      <p:sp>
-        <p:nvSpPr>
-          <p:cNvPr id="8" name="Text 5"/>
-          <p:cNvSpPr/>
-          <p:nvPr/>
-        </p:nvSpPr>
-        <p:spPr>
-          <a:xfrm>
-            <a:off x="777240" y="4315968"/>
-            <a:ext cx="3108960" cy="320040"/>
-          </a:xfrm>
-          <a:prstGeom prst="rect">
-            <a:avLst/>
-          </a:prstGeom>
-          <a:noFill/>
-          <a:ln/>
-        </p:spPr>
-        <p:txBody>
-          <a:bodyPr wrap="square" lIns="0" tIns="0" rIns="0" bIns="0" rtlCol="0" anchor="ctr"/>
-          <a:lstStyle/>
-          <a:p>
-            <a:pPr indent="0" marL="0">
-              <a:buNone/>
-            </a:pPr>
-            <a:r>
-              <a:rPr lang="en-US" sz="1500" b="1" dirty="0">
-                <a:solidFill>
-                  <a:srgbClr val="1E3A5F"/>
-                </a:solidFill>
-                <a:latin typeface="Arial" pitchFamily="34" charset="0"/>
-                <a:ea typeface="Arial" pitchFamily="34" charset="-122"/>
-                <a:cs typeface="Arial" pitchFamily="34" charset="-120"/>
-              </a:rPr>
-              <a:t>Validation RMSE</a:t>
-            </a:r>
-            <a:endParaRPr lang="en-US" sz="1500" dirty="0"/>
-          </a:p>
-        </p:txBody>
-      </p:sp>
-      <p:sp>
-        <p:nvSpPr>
-          <p:cNvPr id="9" name="Text 6"/>
-          <p:cNvSpPr/>
-          <p:nvPr/>
-        </p:nvSpPr>
-        <p:spPr>
-          <a:xfrm>
-            <a:off x="777240" y="4681728"/>
-            <a:ext cx="3108960" cy="1005840"/>
-          </a:xfrm>
-          <a:prstGeom prst="rect">
-            <a:avLst/>
-          </a:prstGeom>
-          <a:noFill/>
-          <a:ln/>
-        </p:spPr>
-        <p:txBody>
-          <a:bodyPr wrap="square" lIns="0" tIns="0" rIns="0" bIns="0" rtlCol="0" anchor="t"/>
-          <a:lstStyle/>
-          <a:p>
-            <a:pPr indent="0" marL="0">
-              <a:buNone/>
-            </a:pPr>
-            <a:r>
-              <a:rPr lang="en-US" sz="1350" dirty="0">
-                <a:solidFill>
-                  <a:srgbClr val="1A1A2E"/>
-                </a:solidFill>
-                <a:latin typeface="Arial" pitchFamily="34" charset="0"/>
-                <a:ea typeface="Arial" pitchFamily="34" charset="-122"/>
-                <a:cs typeface="Arial" pitchFamily="34" charset="-120"/>
-              </a:rPr>
-              <a:t>drives the search - each method keeps its own best</a:t>
-            </a:r>
-            <a:endParaRPr lang="en-US" sz="1350" dirty="0"/>
-          </a:p>
-        </p:txBody>
-      </p:sp>
-      <p:sp>
-        <p:nvSpPr>
-          <p:cNvPr id="10" name="Shape 7"/>
-          <p:cNvSpPr/>
-          <p:nvPr/>
-        </p:nvSpPr>
-        <p:spPr>
-          <a:xfrm>
-            <a:off x="4315968" y="4206240"/>
-            <a:ext cx="3520440" cy="1600200"/>
-          </a:xfrm>
-          <a:prstGeom prst="roundRect">
-            <a:avLst>
-              <a:gd name="adj" fmla="val 5714"/>
-            </a:avLst>
-          </a:prstGeom>
-          <a:solidFill>
-            <a:srgbClr val="F4F6FA"/>
-          </a:solidFill>
-          <a:ln w="19050">
-            <a:solidFill>
-              <a:srgbClr val="0B7A4B"/>
-            </a:solidFill>
-            <a:prstDash val="solid"/>
-          </a:ln>
-        </p:spPr>
-      </p:sp>
-      <p:sp>
-        <p:nvSpPr>
-          <p:cNvPr id="11" name="Text 8"/>
-          <p:cNvSpPr/>
-          <p:nvPr/>
-        </p:nvSpPr>
-        <p:spPr>
-          <a:xfrm>
-            <a:off x="4544568" y="4315968"/>
-            <a:ext cx="3108960" cy="320040"/>
-          </a:xfrm>
-          <a:prstGeom prst="rect">
-            <a:avLst/>
-          </a:prstGeom>
-          <a:noFill/>
-          <a:ln/>
-        </p:spPr>
-        <p:txBody>
-          <a:bodyPr wrap="square" lIns="0" tIns="0" rIns="0" bIns="0" rtlCol="0" anchor="ctr"/>
-          <a:lstStyle/>
-          <a:p>
-            <a:pPr indent="0" marL="0">
-              <a:buNone/>
-            </a:pPr>
-            <a:r>
-              <a:rPr lang="en-US" sz="1500" b="1" dirty="0">
-                <a:solidFill>
-                  <a:srgbClr val="0B7A4B"/>
-                </a:solidFill>
-                <a:latin typeface="Arial" pitchFamily="34" charset="0"/>
-                <a:ea typeface="Arial" pitchFamily="34" charset="-122"/>
-                <a:cs typeface="Arial" pitchFamily="34" charset="-120"/>
-              </a:rPr>
-              <a:t>Test RMSE</a:t>
-            </a:r>
-            <a:endParaRPr lang="en-US" sz="1500" dirty="0"/>
-          </a:p>
-        </p:txBody>
-      </p:sp>
-      <p:sp>
-        <p:nvSpPr>
-          <p:cNvPr id="12" name="Text 9"/>
-          <p:cNvSpPr/>
-          <p:nvPr/>
-        </p:nvSpPr>
-        <p:spPr>
-          <a:xfrm>
-            <a:off x="4544568" y="4681728"/>
-            <a:ext cx="3108960" cy="1005840"/>
-          </a:xfrm>
-          <a:prstGeom prst="rect">
-            <a:avLst/>
-          </a:prstGeom>
-          <a:noFill/>
-          <a:ln/>
-        </p:spPr>
-        <p:txBody>
-          <a:bodyPr wrap="square" lIns="0" tIns="0" rIns="0" bIns="0" rtlCol="0" anchor="t"/>
-          <a:lstStyle/>
-          <a:p>
-            <a:pPr indent="0" marL="0">
-              <a:buNone/>
-            </a:pPr>
-            <a:r>
-              <a:rPr lang="en-US" sz="1350" dirty="0">
-                <a:solidFill>
-                  <a:srgbClr val="1A1A2E"/>
-                </a:solidFill>
-                <a:latin typeface="Arial" pitchFamily="34" charset="0"/>
-                <a:ea typeface="Arial" pitchFamily="34" charset="-122"/>
-                <a:cs typeface="Arial" pitchFamily="34" charset="-120"/>
-              </a:rPr>
-              <a:t>reported once, after the choice is frozen. Never used to choose.</a:t>
-            </a:r>
-            <a:endParaRPr lang="en-US" sz="1350" dirty="0"/>
-          </a:p>
-        </p:txBody>
-      </p:sp>
-      <p:sp>
-        <p:nvSpPr>
-          <p:cNvPr id="13" name="Shape 10"/>
-          <p:cNvSpPr/>
-          <p:nvPr/>
-        </p:nvSpPr>
-        <p:spPr>
-          <a:xfrm>
-            <a:off x="8092440" y="4206240"/>
-            <a:ext cx="3520440" cy="1600200"/>
-          </a:xfrm>
-          <a:prstGeom prst="roundRect">
-            <a:avLst>
-              <a:gd name="adj" fmla="val 5714"/>
-            </a:avLst>
-          </a:prstGeom>
-          <a:solidFill>
-            <a:srgbClr val="F4F6FA"/>
-          </a:solidFill>
-          <a:ln w="19050">
-            <a:solidFill>
-              <a:srgbClr val="B3261E"/>
-            </a:solidFill>
-            <a:prstDash val="solid"/>
-          </a:ln>
-        </p:spPr>
-      </p:sp>
-      <p:sp>
-        <p:nvSpPr>
-          <p:cNvPr id="14" name="Text 11"/>
-          <p:cNvSpPr/>
-          <p:nvPr/>
-        </p:nvSpPr>
-        <p:spPr>
-          <a:xfrm>
-            <a:off x="8321040" y="4315968"/>
-            <a:ext cx="3108960" cy="320040"/>
-          </a:xfrm>
-          <a:prstGeom prst="rect">
-            <a:avLst/>
-          </a:prstGeom>
-          <a:noFill/>
-          <a:ln/>
-        </p:spPr>
-        <p:txBody>
-          <a:bodyPr wrap="square" lIns="0" tIns="0" rIns="0" bIns="0" rtlCol="0" anchor="ctr"/>
-          <a:lstStyle/>
-          <a:p>
-            <a:pPr indent="0" marL="0">
-              <a:buNone/>
-            </a:pPr>
-            <a:r>
-              <a:rPr lang="en-US" sz="1500" b="1" dirty="0">
-                <a:solidFill>
-                  <a:srgbClr val="B3261E"/>
-                </a:solidFill>
-                <a:latin typeface="Arial" pitchFamily="34" charset="0"/>
-                <a:ea typeface="Arial" pitchFamily="34" charset="-122"/>
-                <a:cs typeface="Arial" pitchFamily="34" charset="-120"/>
-              </a:rPr>
-              <a:t>T4 is yes/no</a:t>
-            </a:r>
-            <a:endParaRPr lang="en-US" sz="1500" dirty="0"/>
-          </a:p>
-        </p:txBody>
-      </p:sp>
-      <p:sp>
-        <p:nvSpPr>
-          <p:cNvPr id="15" name="Text 12"/>
-          <p:cNvSpPr/>
-          <p:nvPr/>
-        </p:nvSpPr>
-        <p:spPr>
-          <a:xfrm>
-            <a:off x="8321040" y="4681728"/>
-            <a:ext cx="3108960" cy="1005840"/>
-          </a:xfrm>
-          <a:prstGeom prst="rect">
-            <a:avLst/>
-          </a:prstGeom>
-          <a:noFill/>
-          <a:ln/>
-        </p:spPr>
-        <p:txBody>
-          <a:bodyPr wrap="square" lIns="0" tIns="0" rIns="0" bIns="0" rtlCol="0" anchor="t"/>
-          <a:lstStyle/>
-          <a:p>
-            <a:pPr indent="0" marL="0">
-              <a:buNone/>
-            </a:pPr>
-            <a:r>
-              <a:rPr lang="en-US" sz="1350" dirty="0">
-                <a:solidFill>
-                  <a:srgbClr val="1A1A2E"/>
-                </a:solidFill>
-                <a:latin typeface="Arial" pitchFamily="34" charset="0"/>
-                <a:ea typeface="Arial" pitchFamily="34" charset="-122"/>
-                <a:cs typeface="Arial" pitchFamily="34" charset="-120"/>
-              </a:rPr>
-              <a:t>so RMSE there is the error on a 0/1 label. AUROC is shown too - slide 7.</a:t>
-            </a:r>
-            <a:endParaRPr lang="en-US" sz="1350" dirty="0"/>
-          </a:p>
-        </p:txBody>
-      </p:sp>
-      <p:sp>
-        <p:nvSpPr>
-          <p:cNvPr id="16" name="Text 13"/>
-          <p:cNvSpPr/>
-          <p:nvPr/>
-        </p:nvSpPr>
-        <p:spPr>
-          <a:xfrm>
-            <a:off x="502920" y="6473952"/>
-            <a:ext cx="11185855" cy="274320"/>
-          </a:xfrm>
-          <a:prstGeom prst="rect">
-            <a:avLst/>
-          </a:prstGeom>
-          <a:noFill/>
-          <a:ln/>
-        </p:spPr>
-        <p:txBody>
-          <a:bodyPr wrap="square" lIns="0" tIns="0" rIns="0" bIns="0" rtlCol="0" anchor="ctr"/>
-          <a:lstStyle/>
-          <a:p>
-            <a:pPr indent="0" marL="0">
-              <a:buNone/>
-            </a:pPr>
-            <a:r>
-              <a:rPr lang="en-US" sz="1100" dirty="0">
-                <a:solidFill>
-                  <a:srgbClr val="55606E"/>
-                </a:solidFill>
-                <a:latin typeface="Arial" pitchFamily="34" charset="0"/>
-                <a:ea typeface="Arial" pitchFamily="34" charset="-122"/>
-                <a:cs typeface="Arial" pitchFamily="34" charset="-120"/>
-              </a:rPr>
-              <a:t>RMSE compares arms WITHIN one task only: the four tasks predict different quantities on different scales</a:t>
+              <a:t>RMSE compares arms WITHIN one task only - the four tasks predict different quantities on different scales</a:t>
             </a:r>
             <a:endParaRPr lang="en-US" sz="1100" dirty="0"/>
           </a:p>
@@ -5028,7 +4524,7 @@
                 <a:ea typeface="Arial" pitchFamily="34" charset="-122"/>
                 <a:cs typeface="Arial" pitchFamily="34" charset="-120"/>
               </a:rPr>
-              <a:t>Five methods, one shared budget</a:t>
+              <a:t>Six methods, one shared budget</a:t>
             </a:r>
             <a:endParaRPr lang="en-US" sz="3000" dirty="0"/>
           </a:p>
@@ -5094,7 +4590,7 @@
                 <a:ea typeface="Arial" pitchFamily="34" charset="-122"/>
                 <a:cs typeface="Arial" pitchFamily="34" charset="-120"/>
               </a:rPr>
-              <a:t>Applies to all three conditions</a:t>
+              <a:t>Six arms</a:t>
             </a:r>
             <a:pPr algn="r" indent="0" marL="0">
               <a:buNone/>
@@ -5108,7 +4604,7 @@
                 <a:ea typeface="Arial" pitchFamily="34" charset="-122"/>
                 <a:cs typeface="Arial" pitchFamily="34" charset="-120"/>
               </a:rPr>
-              <a:t>   arms are identical throughout</a:t>
+              <a:t>   identical budget, identical pipeline</a:t>
             </a:r>
             <a:endParaRPr lang="en-US" sz="1150" dirty="0"/>
           </a:p>
@@ -5198,7 +4694,7 @@
                 <a:ea typeface="Arial" pitchFamily="34" charset="-122"/>
                 <a:cs typeface="Arial" pitchFamily="34" charset="-120"/>
               </a:rPr>
-              <a:t>Open-loop vs closed-loop: </a:t>
+              <a:t>All three LLM arms are told what the task is. </a:t>
             </a:r>
             <a:pPr indent="0" marL="0">
               <a:buNone/>
@@ -5212,7 +4708,7 @@
                 <a:ea typeface="Arial" pitchFamily="34" charset="-122"/>
                 <a:cs typeface="Arial" pitchFamily="34" charset="-120"/>
               </a:rPr>
-              <a:t>open-loop never sees how its own circuits scored; closed-loop does, eight times. That is the only difference between them.</a:t>
+              <a:t>Open-loop never sees how its circuits scored, closed-loop does, and the hybrid lets random pick the first two before the LLM takes over.</a:t>
             </a:r>
             <a:endParaRPr lang="en-US" sz="1700" dirty="0"/>
           </a:p>
@@ -5251,7 +4747,7 @@
                 <a:ea typeface="Arial" pitchFamily="34" charset="-122"/>
                 <a:cs typeface="Arial" pitchFamily="34" charset="-120"/>
               </a:rPr>
-              <a:t>Greedy growth cannot apply at fixed length, so Greedy here is fixed-length hill climbing</a:t>
+              <a:t>The fixed ansatz is size-matched at 16 gates, so it cannot be beaten or helped by circuit size</a:t>
             </a:r>
             <a:endParaRPr lang="en-US" sz="1100" dirty="0"/>
           </a:p>

</xml_diff>

<commit_message>
Rebuild slide 7 from the 30-seed run and label slide 8 as the earlier one
Slide 7 was still drawing the T4 metric comparison from the 5-gate,
10-seed run - the same failure as the setup slides, caught by the same
reader. Rebuilt from the 712 cells every other v2 figure uses, so all six
arms appear and the seed count matches the badge.

Slide 8 is the opposite case: its data is correct and must stay 5-gate,
because the whole point is to reconstruct the pilot's own search space
and measure what circuit size bought. What was missing was saying so. It
now carries "A SEPARATE, EARLIER RUN - 5 gates, 3 qubits, 10 seeds - not
the run on slides 6, 7, 9" and its title says (earlier run), so nobody
reads its 10-seed numbers as part of the 30-seed result.

Every remaining figure now traces to one of two declared runs, and each
slide states which.

Co-Authored-By: Claude Opus 5 <noreply@anthropic.com>
</commit_message>
<xml_diff>
--- a/docs/presentation/mini5/20260731_GSoC_mini5.pptx
+++ b/docs/presentation/mini5/20260731_GSoC_mini5.pptx
@@ -1127,7 +1127,7 @@
           <a:p>
             <a:r>
               <a:rPr lang="en-US" dirty="0"/>
-              <a:t>This is why I kept AUROC even though the request was to use plain RMSE everywhere. On T4 the two metrics disagree about who wins, so reporting only one would have asserted something the data does not settle.</a:t>
+              <a:t>T4 is the one task where the metric can pick the winner, so both are on the slide. Here they agree that nothing works: RMSE near 0.5 and AUROC barely above a coin flip.</a:t>
             </a:r>
             <a:endParaRPr lang="en-US" dirty="0"/>
           </a:p>
@@ -1950,7 +1950,7 @@
                 <a:ea typeface="Arial" pitchFamily="34" charset="-122"/>
                 <a:cs typeface="Arial" pitchFamily="34" charset="-120"/>
               </a:rPr>
-              <a:t>July 31, 2026  ·  commit 705cf52  ·  experiment/bench-v2-real-llm-cost-minimal</a:t>
+              <a:t>July 31, 2026  ·  commit 3f36d8c  ·  experiment/bench-v2-real-llm-cost-minimal</a:t>
             </a:r>
             <a:endParaRPr lang="en-US" sz="1200" dirty="0"/>
           </a:p>
@@ -2955,7 +2955,7 @@
                 <a:ea typeface="Arial" pitchFamily="34" charset="-122"/>
                 <a:cs typeface="Arial" pitchFamily="34" charset="-120"/>
               </a:rPr>
-              <a:t>   one circuit design per task</a:t>
+              <a:t>   32 numbers in, one number out</a:t>
             </a:r>
             <a:endParaRPr lang="en-US" sz="1150" dirty="0"/>
           </a:p>
@@ -4590,7 +4590,7 @@
                 <a:ea typeface="Arial" pitchFamily="34" charset="-122"/>
                 <a:cs typeface="Arial" pitchFamily="34" charset="-120"/>
               </a:rPr>
-              <a:t>Six arms</a:t>
+              <a:t>Six arms, identical pipeline</a:t>
             </a:r>
             <a:pPr algn="r" indent="0" marL="0">
               <a:buNone/>
@@ -4604,7 +4604,7 @@
                 <a:ea typeface="Arial" pitchFamily="34" charset="-122"/>
                 <a:cs typeface="Arial" pitchFamily="34" charset="-120"/>
               </a:rPr>
-              <a:t>   identical budget, identical pipeline</a:t>
+              <a:t>   16 gates, 5 qubits, B = 8 each</a:t>
             </a:r>
             <a:endParaRPr lang="en-US" sz="1150" dirty="0"/>
           </a:p>
@@ -5204,7 +5204,7 @@
                 <a:ea typeface="Arial" pitchFamily="34" charset="-122"/>
                 <a:cs typeface="Arial" pitchFamily="34" charset="-120"/>
               </a:rPr>
-              <a:t>On T4 the metric, not the method, picks the winner</a:t>
+              <a:t>On T4 the two scores tell different stories</a:t>
             </a:r>
             <a:endParaRPr lang="en-US" sz="3000" dirty="0"/>
           </a:p>
@@ -5270,7 +5270,7 @@
                 <a:ea typeface="Arial" pitchFamily="34" charset="-122"/>
                 <a:cs typeface="Arial" pitchFamily="34" charset="-120"/>
               </a:rPr>
-              <a:t>PRIMARY: exactly 5 gates, B = 8, 10 seeds</a:t>
+              <a:t>16 gates, 5 qubits, B = 8, 30 seeds</a:t>
             </a:r>
             <a:pPr algn="r" indent="0" marL="0">
               <a:buNone/>
@@ -5284,7 +5284,7 @@
                 <a:ea typeface="Arial" pitchFamily="34" charset="-122"/>
                 <a:cs typeface="Arial" pitchFamily="34" charset="-120"/>
               </a:rPr>
-              <a:t>   T4 only (peak count, 5 qubits)</a:t>
+              <a:t>   T4 only (one bump or two)</a:t>
             </a:r>
             <a:endParaRPr lang="en-US" sz="1150" dirty="0"/>
           </a:p>
@@ -5292,7 +5292,7 @@
       </p:sp>
       <p:pic>
         <p:nvPicPr>
-          <p:cNvPr id="6" name="Image 0" descr="/Users/hatanakatomoya/Developer/Sim/llm-vqc/.claude/worktrees/github-author-config-faee6e/docs/presentation/mini5/figures/fig_t4_check.png">    </p:cNvPr>
+          <p:cNvPr id="6" name="Image 0" descr="/Users/hatanakatomoya/Developer/Sim/llm-vqc/.claude/worktrees/github-author-config-faee6e/docs/presentation/mini5/figures/fig_v2_t4.png">    </p:cNvPr>
           <p:cNvPicPr>
             <a:picLocks noChangeAspect="1"/>
           </p:cNvPicPr>
@@ -5306,8 +5306,8 @@
         </p:blipFill>
         <p:spPr>
           <a:xfrm>
-            <a:off x="731520" y="1417320"/>
-            <a:ext cx="6675120" cy="3017520"/>
+            <a:off x="822960" y="1417320"/>
+            <a:ext cx="7589520" cy="3291840"/>
           </a:xfrm>
           <a:prstGeom prst="rect">
             <a:avLst/>
@@ -5322,8 +5322,8 @@
         </p:nvSpPr>
         <p:spPr>
           <a:xfrm>
-            <a:off x="7680960" y="1600200"/>
-            <a:ext cx="4023360" cy="2926080"/>
+            <a:off x="8641080" y="1600200"/>
+            <a:ext cx="3108960" cy="3017520"/>
           </a:xfrm>
           <a:prstGeom prst="rect">
             <a:avLst/>
@@ -5362,7 +5362,7 @@
                 <a:ea typeface="Arial" pitchFamily="34" charset="-122"/>
                 <a:cs typeface="Arial" pitchFamily="34" charset="-120"/>
               </a:rPr>
-              <a:t>= how often the model ranks a two-peak signal above a one-peak one. 1.0 perfect, 0.5 coin flip.
+              <a:t>= how often the model ranks a two-bump signal above a one-bump one. 1.0 perfect, 0.5 a coin flip.
 </a:t>
             </a:r>
             <a:pPr indent="0" marL="0">
@@ -5377,7 +5377,7 @@
                 <a:ea typeface="Arial" pitchFamily="34" charset="-122"/>
                 <a:cs typeface="Arial" pitchFamily="34" charset="-120"/>
               </a:rPr>
-              <a:t>Why they disagree
+              <a:t>Why report both
 </a:t>
             </a:r>
             <a:pPr indent="0" marL="0">
@@ -5392,7 +5392,7 @@
                 <a:ea typeface="Arial" pitchFamily="34" charset="-122"/>
                 <a:cs typeface="Arial" pitchFamily="34" charset="-120"/>
               </a:rPr>
-              <a:t>RMSE also punishes outputting 0.45 / 0.55 instead of 0 / 1. AUROC only cares about the order.</a:t>
+              <a:t>RMSE also punishes outputting 0.45 / 0.55 instead of 0 / 1. AUROC only cares about the order, so one alone can assert the wrong winner.</a:t>
             </a:r>
             <a:endParaRPr lang="en-US" sz="1700" dirty="0"/>
           </a:p>
@@ -5406,12 +5406,12 @@
         </p:nvSpPr>
         <p:spPr>
           <a:xfrm>
-            <a:off x="548640" y="4754880"/>
-            <a:ext cx="11109960" cy="1280160"/>
+            <a:off x="548640" y="5029200"/>
+            <a:ext cx="11109960" cy="1051560"/>
           </a:xfrm>
           <a:prstGeom prst="roundRect">
             <a:avLst>
-              <a:gd name="adj" fmla="val 7143"/>
+              <a:gd name="adj" fmla="val 8696"/>
             </a:avLst>
           </a:prstGeom>
           <a:solidFill>
@@ -5433,8 +5433,8 @@
         </p:nvSpPr>
         <p:spPr>
           <a:xfrm>
-            <a:off x="777240" y="4864608"/>
-            <a:ext cx="10607040" cy="1097280"/>
+            <a:off x="777240" y="5138928"/>
+            <a:ext cx="10607040" cy="822960"/>
           </a:xfrm>
           <a:prstGeom prst="rect">
             <a:avLst/>
@@ -5458,7 +5458,7 @@
                 <a:ea typeface="Arial" pitchFamily="34" charset="-122"/>
                 <a:cs typeface="Arial" pitchFamily="34" charset="-120"/>
               </a:rPr>
-              <a:t>Neither reading is strong: </a:t>
+              <a:t>Neither reading is strong. </a:t>
             </a:r>
             <a:pPr indent="0" marL="0">
               <a:buNone/>
@@ -5472,7 +5472,7 @@
                 <a:ea typeface="Arial" pitchFamily="34" charset="-122"/>
                 <a:cs typeface="Arial" pitchFamily="34" charset="-120"/>
               </a:rPr>
-              <a:t>AUROC spans 0.59 to 0.62 against 0.5 for chance. Five gates without training barely solve T4 at all.</a:t>
+              <a:t>Every method sits near 0.50 RMSE and barely above chance on AUROC. Sixteen gates without training do not solve T4, and no arm separates from the others.</a:t>
             </a:r>
             <a:endParaRPr lang="en-US" sz="1700" dirty="0"/>
           </a:p>
@@ -5582,7 +5582,7 @@
                 <a:ea typeface="Arial" pitchFamily="34" charset="-122"/>
                 <a:cs typeface="Arial" pitchFamily="34" charset="-120"/>
               </a:rPr>
-              <a:t>ATTRIBUTION</a:t>
+              <a:t>ATTRIBUTION (EARLIER RUN)</a:t>
             </a:r>
             <a:endParaRPr lang="en-US" sz="1300" dirty="0"/>
           </a:p>
@@ -5687,7 +5687,7 @@
                 <a:ea typeface="Arial" pitchFamily="34" charset="-122"/>
                 <a:cs typeface="Arial" pitchFamily="34" charset="-120"/>
               </a:rPr>
-              <a:t>ALL THREE CONDITIONS side by side</a:t>
+              <a:t>A SEPARATE, EARLIER RUN</a:t>
             </a:r>
             <a:pPr algn="r" indent="0" marL="0">
               <a:buNone/>
@@ -5701,7 +5701,7 @@
                 <a:ea typeface="Arial" pitchFamily="34" charset="-122"/>
                 <a:cs typeface="Arial" pitchFamily="34" charset="-120"/>
               </a:rPr>
-              <a:t>   T1 only (Gaussian peak, 3 qubits)</a:t>
+              <a:t>   5 gates, 3 qubits, 10 seeds - not the run on slides 6, 7, 9</a:t>
             </a:r>
             <a:endParaRPr lang="en-US" sz="1150" dirty="0"/>
           </a:p>
@@ -5844,7 +5844,7 @@
                 <a:ea typeface="Arial" pitchFamily="34" charset="-122"/>
                 <a:cs typeface="Arial" pitchFamily="34" charset="-120"/>
               </a:rPr>
-              <a:t>All three conditions ran all four tasks with 10 seeds; T1 is shown here because it is the family the pilot used · data/condition_comparison.json</a:t>
+              <a:t>This attribution needed the pilot's own 5-gate space, so it has its own runs: all four tasks, 10 seeds, T1 plotted because the pilot used that family · data/condition_comparison.json</a:t>
             </a:r>
             <a:endParaRPr lang="en-US" sz="1100" dirty="0"/>
           </a:p>

</xml_diff>